<commit_message>
Add robustness check slide and update presenter notes
</commit_message>
<xml_diff>
--- a/reports/zh15min_slides.pptx
+++ b/reports/zh15min_slides.pptx
@@ -21,9 +21,10 @@
     <p:sldId id="269" r:id="rId15"/>
     <p:sldId id="270" r:id="rId16"/>
     <p:sldId id="271" r:id="rId17"/>
+    <p:sldId id="272" r:id="rId18"/>
   </p:sldIdLst>
   <p:notesMasterIdLst>
-    <p:notesMasterId r:id="rId18"/>
+    <p:notesMasterId r:id="rId19"/>
   </p:notesMasterIdLst>
   <p:sldSz cx="9144000" cy="5143500"/>
   <p:notesSz cx="5143500" cy="9144000"/>
@@ -1157,6 +1158,94 @@
             <a:fld id="{F7021451-1387-4CA6-816F-3879F97B5CBC}" type="slidenum">
               <a:rPr lang="en-US"/>
               <a:t>16</a:t>
+            </a:fld>
+            <a:endParaRPr lang="en-US"/>
+          </a:p>
+        </p:txBody>
+      </p:sp>
+    </p:spTree>
+    <p:extLst>
+      <p:ext uri="{BB962C8B-B14F-4D97-AF65-F5344CB8AC3E}">
+        <p14:creationId xmlns:p14="http://schemas.microsoft.com/office/powerpoint/2010/main" val="1024086991"/>
+      </p:ext>
+    </p:extLst>
+  </p:cSld>
+  <p:clrMapOvr>
+    <a:masterClrMapping/>
+  </p:clrMapOvr>
+</p:notes>
+</file>
+
+<file path=ppt/notesSlides/notesSlide17.xml><?xml version="1.0" encoding="utf-8"?>
+<p:notes xmlns:a="http://schemas.openxmlformats.org/drawingml/2006/main" xmlns:r="http://schemas.openxmlformats.org/officeDocument/2006/relationships" xmlns:p="http://schemas.openxmlformats.org/presentationml/2006/main">
+  <p:cSld>
+    <p:spTree>
+      <p:nvGrpSpPr>
+        <p:cNvPr id="1" name=""/>
+        <p:cNvGrpSpPr/>
+        <p:nvPr/>
+      </p:nvGrpSpPr>
+      <p:grpSpPr>
+        <a:xfrm>
+          <a:off x="0" y="0"/>
+          <a:ext cx="0" cy="0"/>
+          <a:chOff x="0" y="0"/>
+          <a:chExt cx="0" cy="0"/>
+        </a:xfrm>
+      </p:grpSpPr>
+      <p:sp>
+        <p:nvSpPr>
+          <p:cNvPr id="2" name="Slide Image Placeholder 1"/>
+          <p:cNvSpPr>
+            <a:spLocks noGrp="1" noRot="1" noChangeAspect="1"/>
+          </p:cNvSpPr>
+          <p:nvPr>
+            <p:ph type="sldImg"/>
+          </p:nvPr>
+        </p:nvSpPr>
+        <p:spPr/>
+      </p:sp>
+      <p:sp>
+        <p:nvSpPr>
+          <p:cNvPr id="3" name="Notes Placeholder 2"/>
+          <p:cNvSpPr>
+            <a:spLocks noGrp="1"/>
+          </p:cNvSpPr>
+          <p:nvPr>
+            <p:ph type="body" idx="1"/>
+          </p:nvPr>
+        </p:nvSpPr>
+        <p:spPr/>
+        <p:txBody>
+          <a:bodyPr/>
+          <a:lstStyle/>
+          <a:p>
+            <a:r>
+              <a:rPr lang="en-US" dirty="0"/>
+              <a:t/>
+            </a:r>
+            <a:endParaRPr lang="en-US" dirty="0"/>
+          </a:p>
+        </p:txBody>
+      </p:sp>
+      <p:sp>
+        <p:nvSpPr>
+          <p:cNvPr id="4" name="Slide Number Placeholder 3"/>
+          <p:cNvSpPr>
+            <a:spLocks noGrp="1"/>
+          </p:cNvSpPr>
+          <p:nvPr>
+            <p:ph type="sldNum" sz="quarter" idx="10"/>
+          </p:nvPr>
+        </p:nvSpPr>
+        <p:spPr/>
+        <p:txBody>
+          <a:bodyPr/>
+          <a:lstStyle/>
+          <a:p>
+            <a:fld id="{F7021451-1387-4CA6-816F-3879F97B5CBC}" type="slidenum">
+              <a:rPr lang="en-US"/>
+              <a:t>17</a:t>
             </a:fld>
             <a:endParaRPr lang="en-US"/>
           </a:p>
@@ -2608,7 +2697,7 @@
                 <a:ea typeface="Calibri" pitchFamily="34" charset="-122"/>
                 <a:cs typeface="Calibri" pitchFamily="34" charset="-120"/>
               </a:rPr>
-              <a:t>1 / 16</a:t>
+              <a:t>1 / 17</a:t>
             </a:r>
             <a:endParaRPr lang="en-US" sz="900" dirty="0"/>
           </a:p>
@@ -3542,7 +3631,7 @@
                 <a:ea typeface="Calibri" pitchFamily="34" charset="-122"/>
                 <a:cs typeface="Calibri" pitchFamily="34" charset="-120"/>
               </a:rPr>
-              <a:t>10 / 16</a:t>
+              <a:t>10 / 17</a:t>
             </a:r>
             <a:endParaRPr lang="en-US" sz="900" dirty="0"/>
           </a:p>
@@ -4007,7 +4096,7 @@
                 <a:ea typeface="Calibri" pitchFamily="34" charset="-122"/>
                 <a:cs typeface="Calibri" pitchFamily="34" charset="-120"/>
               </a:rPr>
-              <a:t>11 / 16</a:t>
+              <a:t>11 / 17</a:t>
             </a:r>
             <a:endParaRPr lang="en-US" sz="900" dirty="0"/>
           </a:p>
@@ -4621,7 +4710,7 @@
                 <a:ea typeface="Calibri" pitchFamily="34" charset="-122"/>
                 <a:cs typeface="Calibri" pitchFamily="34" charset="-120"/>
               </a:rPr>
-              <a:t>12 / 16</a:t>
+              <a:t>12 / 17</a:t>
             </a:r>
             <a:endParaRPr lang="en-US" sz="900" dirty="0"/>
           </a:p>
@@ -6031,7 +6120,7 @@
                 <a:ea typeface="Calibri" pitchFamily="34" charset="-122"/>
                 <a:cs typeface="Calibri" pitchFamily="34" charset="-120"/>
               </a:rPr>
-              <a:t>13 / 16</a:t>
+              <a:t>13 / 17</a:t>
             </a:r>
             <a:endParaRPr lang="en-US" sz="900" dirty="0"/>
           </a:p>
@@ -6102,7 +6191,7 @@
                 <a:ea typeface="Trebuchet MS" pitchFamily="34" charset="-122"/>
                 <a:cs typeface="Trebuchet MS" pitchFamily="34" charset="-120"/>
               </a:rPr>
-              <a:t>DISKUSSION</a:t>
+              <a:t>DISKUSSION · 1/2</a:t>
             </a:r>
             <a:endParaRPr lang="en-US" sz="1100" dirty="0"/>
           </a:p>
@@ -6293,7 +6382,7 @@
                 <a:ea typeface="Calibri" pitchFamily="34" charset="-122"/>
                 <a:cs typeface="Calibri" pitchFamily="34" charset="-120"/>
               </a:rPr>
-              <a:t> — Zentralität ist der dominante Treiber.</a:t>
+              <a:t> — Zentralität ist ein starker Treiber. Robustheits-Check folgt.</a:t>
             </a:r>
             <a:endParaRPr lang="en-US" sz="1400" dirty="0"/>
           </a:p>
@@ -6737,7 +6826,7 @@
                 <a:ea typeface="Calibri" pitchFamily="34" charset="-122"/>
                 <a:cs typeface="Calibri" pitchFamily="34" charset="-120"/>
               </a:rPr>
-              <a:t>14 / 16</a:t>
+              <a:t>14 / 17</a:t>
             </a:r>
             <a:endParaRPr lang="en-US" sz="900" dirty="0"/>
           </a:p>
@@ -6808,7 +6897,7 @@
                 <a:ea typeface="Trebuchet MS" pitchFamily="34" charset="-122"/>
                 <a:cs typeface="Trebuchet MS" pitchFamily="34" charset="-120"/>
               </a:rPr>
-              <a:t>SCHLUSS · 1/2</a:t>
+              <a:t>DISKUSSION · 2/2</a:t>
             </a:r>
             <a:endParaRPr lang="en-US" sz="1100" dirty="0"/>
           </a:p>
@@ -6847,7 +6936,7 @@
                 <a:ea typeface="Trebuchet MS" pitchFamily="34" charset="-122"/>
                 <a:cs typeface="Trebuchet MS" pitchFamily="34" charset="-120"/>
               </a:rPr>
-              <a:t>Limitationen unseres Modells</a:t>
+              <a:t>Robustness Check — H1 hält stand</a:t>
             </a:r>
             <a:endParaRPr lang="en-US" sz="3000" dirty="0"/>
           </a:p>
@@ -6861,8 +6950,8 @@
         </p:nvSpPr>
         <p:spPr>
           <a:xfrm>
-            <a:off x="457200" y="1554480"/>
-            <a:ext cx="4023360" cy="1371600"/>
+            <a:off x="457200" y="1508760"/>
+            <a:ext cx="4937760" cy="3108960"/>
           </a:xfrm>
           <a:prstGeom prst="rect">
             <a:avLst/>
@@ -6893,18 +6982,18 @@
         </p:nvSpPr>
         <p:spPr>
           <a:xfrm>
-            <a:off x="457200" y="1554480"/>
-            <a:ext cx="4023360" cy="54864"/>
+            <a:off x="457200" y="1508760"/>
+            <a:ext cx="4937760" cy="54864"/>
           </a:xfrm>
           <a:prstGeom prst="rect">
             <a:avLst/>
           </a:prstGeom>
           <a:solidFill>
-            <a:srgbClr val="D73027"/>
+            <a:srgbClr val="065A82"/>
           </a:solidFill>
           <a:ln w="12700">
             <a:solidFill>
-              <a:srgbClr val="D73027"/>
+              <a:srgbClr val="065A82"/>
             </a:solidFill>
             <a:prstDash val="solid"/>
           </a:ln>
@@ -6918,34 +7007,34 @@
         </p:nvSpPr>
         <p:spPr>
           <a:xfrm>
-            <a:off x="640080" y="1719072"/>
-            <a:ext cx="3657600" cy="365760"/>
-          </a:xfrm>
-          <a:prstGeom prst="rect">
-            <a:avLst/>
-          </a:prstGeom>
-          <a:noFill/>
-          <a:ln/>
-        </p:spPr>
-        <p:txBody>
-          <a:bodyPr wrap="square" lIns="0" tIns="0" rIns="0" bIns="0" rtlCol="0" anchor="ctr"/>
-          <a:lstStyle/>
-          <a:p>
-            <a:pPr indent="0" marL="0">
-              <a:buNone/>
-            </a:pPr>
-            <a:r>
-              <a:rPr lang="en-US" sz="1400" b="1" dirty="0">
-                <a:solidFill>
-                  <a:srgbClr val="D73027"/>
+            <a:off x="640080" y="1645920"/>
+            <a:ext cx="4572000" cy="320040"/>
+          </a:xfrm>
+          <a:prstGeom prst="rect">
+            <a:avLst/>
+          </a:prstGeom>
+          <a:noFill/>
+          <a:ln/>
+        </p:spPr>
+        <p:txBody>
+          <a:bodyPr wrap="square" lIns="0" tIns="0" rIns="0" bIns="0" rtlCol="0" anchor="ctr"/>
+          <a:lstStyle/>
+          <a:p>
+            <a:pPr indent="0" marL="0">
+              <a:buNone/>
+            </a:pPr>
+            <a:r>
+              <a:rPr lang="en-US" sz="1300" b="1" dirty="0">
+                <a:solidFill>
+                  <a:srgbClr val="065A82"/>
                 </a:solidFill>
                 <a:latin typeface="Trebuchet MS" pitchFamily="34" charset="0"/>
                 <a:ea typeface="Trebuchet MS" pitchFamily="34" charset="-122"/>
                 <a:cs typeface="Trebuchet MS" pitchFamily="34" charset="-120"/>
               </a:rPr>
-              <a:t>Datenqualität OSM</a:t>
-            </a:r>
-            <a:endParaRPr lang="en-US" sz="1400" dirty="0"/>
+              <a:t>Multi-Variate-Regression  (n = 44, R² = 0.75)</a:t>
+            </a:r>
+            <a:endParaRPr lang="en-US" sz="1300" dirty="0"/>
           </a:p>
         </p:txBody>
       </p:sp>
@@ -6957,24 +7046,219 @@
         </p:nvSpPr>
         <p:spPr>
           <a:xfrm>
-            <a:off x="640080" y="2103120"/>
-            <a:ext cx="3657600" cy="777240"/>
-          </a:xfrm>
-          <a:prstGeom prst="rect">
-            <a:avLst/>
-          </a:prstGeom>
-          <a:noFill/>
-          <a:ln/>
-        </p:spPr>
-        <p:txBody>
-          <a:bodyPr wrap="square" lIns="0" tIns="0" rIns="0" bIns="0" rtlCol="0" anchor="ctr"/>
-          <a:lstStyle/>
-          <a:p>
-            <a:pPr indent="0" marL="0">
-              <a:buNone/>
-            </a:pPr>
-            <a:r>
-              <a:rPr lang="en-US" sz="1100" dirty="0">
+            <a:off x="640080" y="2057400"/>
+            <a:ext cx="1463040" cy="274320"/>
+          </a:xfrm>
+          <a:prstGeom prst="rect">
+            <a:avLst/>
+          </a:prstGeom>
+          <a:noFill/>
+          <a:ln/>
+        </p:spPr>
+        <p:txBody>
+          <a:bodyPr wrap="square" lIns="0" tIns="0" rIns="0" bIns="0" rtlCol="0" anchor="ctr"/>
+          <a:lstStyle/>
+          <a:p>
+            <a:pPr indent="0" marL="0">
+              <a:buNone/>
+            </a:pPr>
+            <a:r>
+              <a:rPr lang="en-US" sz="1000" b="1" dirty="0">
+                <a:solidFill>
+                  <a:srgbClr val="64748B"/>
+                </a:solidFill>
+                <a:latin typeface="Trebuchet MS" pitchFamily="34" charset="0"/>
+                <a:ea typeface="Trebuchet MS" pitchFamily="34" charset="-122"/>
+                <a:cs typeface="Trebuchet MS" pitchFamily="34" charset="-120"/>
+              </a:rPr>
+              <a:t>Prädiktor</a:t>
+            </a:r>
+            <a:endParaRPr lang="en-US" sz="1000" dirty="0"/>
+          </a:p>
+        </p:txBody>
+      </p:sp>
+      <p:sp>
+        <p:nvSpPr>
+          <p:cNvPr id="8" name="Text 6"/>
+          <p:cNvSpPr/>
+          <p:nvPr/>
+        </p:nvSpPr>
+        <p:spPr>
+          <a:xfrm>
+            <a:off x="2103120" y="2057400"/>
+            <a:ext cx="868680" cy="274320"/>
+          </a:xfrm>
+          <a:prstGeom prst="rect">
+            <a:avLst/>
+          </a:prstGeom>
+          <a:noFill/>
+          <a:ln/>
+        </p:spPr>
+        <p:txBody>
+          <a:bodyPr wrap="square" lIns="0" tIns="0" rIns="0" bIns="0" rtlCol="0" anchor="ctr"/>
+          <a:lstStyle/>
+          <a:p>
+            <a:pPr indent="0" marL="0">
+              <a:buNone/>
+            </a:pPr>
+            <a:r>
+              <a:rPr lang="en-US" sz="1000" b="1" dirty="0">
+                <a:solidFill>
+                  <a:srgbClr val="64748B"/>
+                </a:solidFill>
+                <a:latin typeface="Trebuchet MS" pitchFamily="34" charset="0"/>
+                <a:ea typeface="Trebuchet MS" pitchFamily="34" charset="-122"/>
+                <a:cs typeface="Trebuchet MS" pitchFamily="34" charset="-120"/>
+              </a:rPr>
+              <a:t>bivar. r</a:t>
+            </a:r>
+            <a:endParaRPr lang="en-US" sz="1000" dirty="0"/>
+          </a:p>
+        </p:txBody>
+      </p:sp>
+      <p:sp>
+        <p:nvSpPr>
+          <p:cNvPr id="9" name="Text 7"/>
+          <p:cNvSpPr/>
+          <p:nvPr/>
+        </p:nvSpPr>
+        <p:spPr>
+          <a:xfrm>
+            <a:off x="2971800" y="2057400"/>
+            <a:ext cx="868680" cy="274320"/>
+          </a:xfrm>
+          <a:prstGeom prst="rect">
+            <a:avLst/>
+          </a:prstGeom>
+          <a:noFill/>
+          <a:ln/>
+        </p:spPr>
+        <p:txBody>
+          <a:bodyPr wrap="square" lIns="0" tIns="0" rIns="0" bIns="0" rtlCol="0" anchor="ctr"/>
+          <a:lstStyle/>
+          <a:p>
+            <a:pPr indent="0" marL="0">
+              <a:buNone/>
+            </a:pPr>
+            <a:r>
+              <a:rPr lang="en-US" sz="1000" b="1" dirty="0">
+                <a:solidFill>
+                  <a:srgbClr val="64748B"/>
+                </a:solidFill>
+                <a:latin typeface="Trebuchet MS" pitchFamily="34" charset="0"/>
+                <a:ea typeface="Trebuchet MS" pitchFamily="34" charset="-122"/>
+                <a:cs typeface="Trebuchet MS" pitchFamily="34" charset="-120"/>
+              </a:rPr>
+              <a:t>partiell β</a:t>
+            </a:r>
+            <a:endParaRPr lang="en-US" sz="1000" dirty="0"/>
+          </a:p>
+        </p:txBody>
+      </p:sp>
+      <p:sp>
+        <p:nvSpPr>
+          <p:cNvPr id="10" name="Text 8"/>
+          <p:cNvSpPr/>
+          <p:nvPr/>
+        </p:nvSpPr>
+        <p:spPr>
+          <a:xfrm>
+            <a:off x="3840480" y="2057400"/>
+            <a:ext cx="868680" cy="274320"/>
+          </a:xfrm>
+          <a:prstGeom prst="rect">
+            <a:avLst/>
+          </a:prstGeom>
+          <a:noFill/>
+          <a:ln/>
+        </p:spPr>
+        <p:txBody>
+          <a:bodyPr wrap="square" lIns="0" tIns="0" rIns="0" bIns="0" rtlCol="0" anchor="ctr"/>
+          <a:lstStyle/>
+          <a:p>
+            <a:pPr indent="0" marL="0">
+              <a:buNone/>
+            </a:pPr>
+            <a:r>
+              <a:rPr lang="en-US" sz="1000" b="1" dirty="0">
+                <a:solidFill>
+                  <a:srgbClr val="64748B"/>
+                </a:solidFill>
+                <a:latin typeface="Trebuchet MS" pitchFamily="34" charset="0"/>
+                <a:ea typeface="Trebuchet MS" pitchFamily="34" charset="-122"/>
+                <a:cs typeface="Trebuchet MS" pitchFamily="34" charset="-120"/>
+              </a:rPr>
+              <a:t>p-Wert</a:t>
+            </a:r>
+            <a:endParaRPr lang="en-US" sz="1000" dirty="0"/>
+          </a:p>
+        </p:txBody>
+      </p:sp>
+      <p:sp>
+        <p:nvSpPr>
+          <p:cNvPr id="11" name="Text 9"/>
+          <p:cNvSpPr/>
+          <p:nvPr/>
+        </p:nvSpPr>
+        <p:spPr>
+          <a:xfrm>
+            <a:off x="4709160" y="2057400"/>
+            <a:ext cx="640080" cy="274320"/>
+          </a:xfrm>
+          <a:prstGeom prst="rect">
+            <a:avLst/>
+          </a:prstGeom>
+          <a:noFill/>
+          <a:ln/>
+        </p:spPr>
+        <p:txBody>
+          <a:bodyPr wrap="square" lIns="0" tIns="0" rIns="0" bIns="0" rtlCol="0" anchor="ctr"/>
+          <a:lstStyle/>
+          <a:p>
+            <a:pPr indent="0" marL="0">
+              <a:buNone/>
+            </a:pPr>
+            <a:r>
+              <a:rPr lang="en-US" sz="1000" b="1" dirty="0">
+                <a:solidFill>
+                  <a:srgbClr val="64748B"/>
+                </a:solidFill>
+                <a:latin typeface="Trebuchet MS" pitchFamily="34" charset="0"/>
+                <a:ea typeface="Trebuchet MS" pitchFamily="34" charset="-122"/>
+                <a:cs typeface="Trebuchet MS" pitchFamily="34" charset="-120"/>
+              </a:rPr>
+              <a:t>Status</a:t>
+            </a:r>
+            <a:endParaRPr lang="en-US" sz="1000" dirty="0"/>
+          </a:p>
+        </p:txBody>
+      </p:sp>
+      <p:sp>
+        <p:nvSpPr>
+          <p:cNvPr id="12" name="Text 10"/>
+          <p:cNvSpPr/>
+          <p:nvPr/>
+        </p:nvSpPr>
+        <p:spPr>
+          <a:xfrm>
+            <a:off x="640080" y="2423160"/>
+            <a:ext cx="1463040" cy="292608"/>
+          </a:xfrm>
+          <a:prstGeom prst="rect">
+            <a:avLst/>
+          </a:prstGeom>
+          <a:noFill/>
+          <a:ln/>
+        </p:spPr>
+        <p:txBody>
+          <a:bodyPr wrap="square" lIns="0" tIns="0" rIns="0" bIns="0" rtlCol="0" anchor="ctr"/>
+          <a:lstStyle/>
+          <a:p>
+            <a:pPr indent="0" marL="0">
+              <a:buNone/>
+            </a:pPr>
+            <a:r>
+              <a:rPr lang="en-US" sz="1100" b="1" dirty="0">
                 <a:solidFill>
                   <a:srgbClr val="0F172A"/>
                 </a:solidFill>
@@ -6982,7 +7266,7 @@
                 <a:ea typeface="Calibri" pitchFamily="34" charset="-122"/>
                 <a:cs typeface="Calibri" pitchFamily="34" charset="-120"/>
               </a:rPr>
-              <a:t>Kleine, unmappte Geschäfte fehlen. Annahme: Verzerrung gering, weil Geschäfte ähnlicher Klassifikation OSM-mässig konsistent sind.</a:t>
+              <a:t>Distanz HB</a:t>
             </a:r>
             <a:endParaRPr lang="en-US" sz="1100" dirty="0"/>
           </a:p>
@@ -6990,14 +7274,599 @@
       </p:sp>
       <p:sp>
         <p:nvSpPr>
-          <p:cNvPr id="8" name="Shape 6"/>
-          <p:cNvSpPr/>
-          <p:nvPr/>
-        </p:nvSpPr>
-        <p:spPr>
-          <a:xfrm>
-            <a:off x="4663440" y="1554480"/>
-            <a:ext cx="4023360" cy="1371600"/>
+          <p:cNvPr id="13" name="Text 11"/>
+          <p:cNvSpPr/>
+          <p:nvPr/>
+        </p:nvSpPr>
+        <p:spPr>
+          <a:xfrm>
+            <a:off x="2103120" y="2423160"/>
+            <a:ext cx="868680" cy="292608"/>
+          </a:xfrm>
+          <a:prstGeom prst="rect">
+            <a:avLst/>
+          </a:prstGeom>
+          <a:noFill/>
+          <a:ln/>
+        </p:spPr>
+        <p:txBody>
+          <a:bodyPr wrap="square" lIns="0" tIns="0" rIns="0" bIns="0" rtlCol="0" anchor="ctr"/>
+          <a:lstStyle/>
+          <a:p>
+            <a:pPr indent="0" marL="0">
+              <a:buNone/>
+            </a:pPr>
+            <a:r>
+              <a:rPr lang="en-US" sz="1050" dirty="0">
+                <a:solidFill>
+                  <a:srgbClr val="0F172A"/>
+                </a:solidFill>
+                <a:latin typeface="Consolas" pitchFamily="34" charset="0"/>
+                <a:ea typeface="Consolas" pitchFamily="34" charset="-122"/>
+                <a:cs typeface="Consolas" pitchFamily="34" charset="-120"/>
+              </a:rPr>
+              <a:t>−0.61</a:t>
+            </a:r>
+            <a:endParaRPr lang="en-US" sz="1050" dirty="0"/>
+          </a:p>
+        </p:txBody>
+      </p:sp>
+      <p:sp>
+        <p:nvSpPr>
+          <p:cNvPr id="14" name="Text 12"/>
+          <p:cNvSpPr/>
+          <p:nvPr/>
+        </p:nvSpPr>
+        <p:spPr>
+          <a:xfrm>
+            <a:off x="2971800" y="2423160"/>
+            <a:ext cx="868680" cy="292608"/>
+          </a:xfrm>
+          <a:prstGeom prst="rect">
+            <a:avLst/>
+          </a:prstGeom>
+          <a:noFill/>
+          <a:ln/>
+        </p:spPr>
+        <p:txBody>
+          <a:bodyPr wrap="square" lIns="0" tIns="0" rIns="0" bIns="0" rtlCol="0" anchor="ctr"/>
+          <a:lstStyle/>
+          <a:p>
+            <a:pPr indent="0" marL="0">
+              <a:buNone/>
+            </a:pPr>
+            <a:r>
+              <a:rPr lang="en-US" sz="1050" dirty="0">
+                <a:solidFill>
+                  <a:srgbClr val="0F172A"/>
+                </a:solidFill>
+                <a:latin typeface="Consolas" pitchFamily="34" charset="0"/>
+                <a:ea typeface="Consolas" pitchFamily="34" charset="-122"/>
+                <a:cs typeface="Consolas" pitchFamily="34" charset="-120"/>
+              </a:rPr>
+              <a:t>−3.65</a:t>
+            </a:r>
+            <a:endParaRPr lang="en-US" sz="1050" dirty="0"/>
+          </a:p>
+        </p:txBody>
+      </p:sp>
+      <p:sp>
+        <p:nvSpPr>
+          <p:cNvPr id="15" name="Text 13"/>
+          <p:cNvSpPr/>
+          <p:nvPr/>
+        </p:nvSpPr>
+        <p:spPr>
+          <a:xfrm>
+            <a:off x="3840480" y="2423160"/>
+            <a:ext cx="868680" cy="292608"/>
+          </a:xfrm>
+          <a:prstGeom prst="rect">
+            <a:avLst/>
+          </a:prstGeom>
+          <a:noFill/>
+          <a:ln/>
+        </p:spPr>
+        <p:txBody>
+          <a:bodyPr wrap="square" lIns="0" tIns="0" rIns="0" bIns="0" rtlCol="0" anchor="ctr"/>
+          <a:lstStyle/>
+          <a:p>
+            <a:pPr indent="0" marL="0">
+              <a:buNone/>
+            </a:pPr>
+            <a:r>
+              <a:rPr lang="en-US" sz="1050" dirty="0">
+                <a:solidFill>
+                  <a:srgbClr val="0F172A"/>
+                </a:solidFill>
+                <a:latin typeface="Consolas" pitchFamily="34" charset="0"/>
+                <a:ea typeface="Consolas" pitchFamily="34" charset="-122"/>
+                <a:cs typeface="Consolas" pitchFamily="34" charset="-120"/>
+              </a:rPr>
+              <a:t>0.011</a:t>
+            </a:r>
+            <a:endParaRPr lang="en-US" sz="1050" dirty="0"/>
+          </a:p>
+        </p:txBody>
+      </p:sp>
+      <p:sp>
+        <p:nvSpPr>
+          <p:cNvPr id="16" name="Text 14"/>
+          <p:cNvSpPr/>
+          <p:nvPr/>
+        </p:nvSpPr>
+        <p:spPr>
+          <a:xfrm>
+            <a:off x="4709160" y="2423160"/>
+            <a:ext cx="640080" cy="292608"/>
+          </a:xfrm>
+          <a:prstGeom prst="rect">
+            <a:avLst/>
+          </a:prstGeom>
+          <a:noFill/>
+          <a:ln/>
+        </p:spPr>
+        <p:txBody>
+          <a:bodyPr wrap="square" lIns="0" tIns="0" rIns="0" bIns="0" rtlCol="0" anchor="ctr"/>
+          <a:lstStyle/>
+          <a:p>
+            <a:pPr indent="0" marL="0">
+              <a:buNone/>
+            </a:pPr>
+            <a:r>
+              <a:rPr lang="en-US" sz="1050" b="1" dirty="0">
+                <a:solidFill>
+                  <a:srgbClr val="1A9850"/>
+                </a:solidFill>
+                <a:latin typeface="Consolas" pitchFamily="34" charset="0"/>
+                <a:ea typeface="Consolas" pitchFamily="34" charset="-122"/>
+                <a:cs typeface="Consolas" pitchFamily="34" charset="-120"/>
+              </a:rPr>
+              <a:t>*</a:t>
+            </a:r>
+            <a:endParaRPr lang="en-US" sz="1050" dirty="0"/>
+          </a:p>
+        </p:txBody>
+      </p:sp>
+      <p:sp>
+        <p:nvSpPr>
+          <p:cNvPr id="17" name="Text 15"/>
+          <p:cNvSpPr/>
+          <p:nvPr/>
+        </p:nvSpPr>
+        <p:spPr>
+          <a:xfrm>
+            <a:off x="640080" y="2807208"/>
+            <a:ext cx="1463040" cy="292608"/>
+          </a:xfrm>
+          <a:prstGeom prst="rect">
+            <a:avLst/>
+          </a:prstGeom>
+          <a:noFill/>
+          <a:ln/>
+        </p:spPr>
+        <p:txBody>
+          <a:bodyPr wrap="square" lIns="0" tIns="0" rIns="0" bIns="0" rtlCol="0" anchor="ctr"/>
+          <a:lstStyle/>
+          <a:p>
+            <a:pPr indent="0" marL="0">
+              <a:buNone/>
+            </a:pPr>
+            <a:r>
+              <a:rPr lang="en-US" sz="1100" b="1" dirty="0">
+                <a:solidFill>
+                  <a:srgbClr val="0F172A"/>
+                </a:solidFill>
+                <a:latin typeface="Calibri" pitchFamily="34" charset="0"/>
+                <a:ea typeface="Calibri" pitchFamily="34" charset="-122"/>
+                <a:cs typeface="Calibri" pitchFamily="34" charset="-120"/>
+              </a:rPr>
+              <a:t>Höhe (approx)</a:t>
+            </a:r>
+            <a:endParaRPr lang="en-US" sz="1100" dirty="0"/>
+          </a:p>
+        </p:txBody>
+      </p:sp>
+      <p:sp>
+        <p:nvSpPr>
+          <p:cNvPr id="18" name="Text 16"/>
+          <p:cNvSpPr/>
+          <p:nvPr/>
+        </p:nvSpPr>
+        <p:spPr>
+          <a:xfrm>
+            <a:off x="2103120" y="2807208"/>
+            <a:ext cx="868680" cy="292608"/>
+          </a:xfrm>
+          <a:prstGeom prst="rect">
+            <a:avLst/>
+          </a:prstGeom>
+          <a:noFill/>
+          <a:ln/>
+        </p:spPr>
+        <p:txBody>
+          <a:bodyPr wrap="square" lIns="0" tIns="0" rIns="0" bIns="0" rtlCol="0" anchor="ctr"/>
+          <a:lstStyle/>
+          <a:p>
+            <a:pPr indent="0" marL="0">
+              <a:buNone/>
+            </a:pPr>
+            <a:r>
+              <a:rPr lang="en-US" sz="1050" dirty="0">
+                <a:solidFill>
+                  <a:srgbClr val="0F172A"/>
+                </a:solidFill>
+                <a:latin typeface="Consolas" pitchFamily="34" charset="0"/>
+                <a:ea typeface="Consolas" pitchFamily="34" charset="-122"/>
+                <a:cs typeface="Consolas" pitchFamily="34" charset="-120"/>
+              </a:rPr>
+              <a:t>+0.08</a:t>
+            </a:r>
+            <a:endParaRPr lang="en-US" sz="1050" dirty="0"/>
+          </a:p>
+        </p:txBody>
+      </p:sp>
+      <p:sp>
+        <p:nvSpPr>
+          <p:cNvPr id="19" name="Text 17"/>
+          <p:cNvSpPr/>
+          <p:nvPr/>
+        </p:nvSpPr>
+        <p:spPr>
+          <a:xfrm>
+            <a:off x="2971800" y="2807208"/>
+            <a:ext cx="868680" cy="292608"/>
+          </a:xfrm>
+          <a:prstGeom prst="rect">
+            <a:avLst/>
+          </a:prstGeom>
+          <a:noFill/>
+          <a:ln/>
+        </p:spPr>
+        <p:txBody>
+          <a:bodyPr wrap="square" lIns="0" tIns="0" rIns="0" bIns="0" rtlCol="0" anchor="ctr"/>
+          <a:lstStyle/>
+          <a:p>
+            <a:pPr indent="0" marL="0">
+              <a:buNone/>
+            </a:pPr>
+            <a:r>
+              <a:rPr lang="en-US" sz="1050" dirty="0">
+                <a:solidFill>
+                  <a:srgbClr val="0F172A"/>
+                </a:solidFill>
+                <a:latin typeface="Consolas" pitchFamily="34" charset="0"/>
+                <a:ea typeface="Consolas" pitchFamily="34" charset="-122"/>
+                <a:cs typeface="Consolas" pitchFamily="34" charset="-120"/>
+              </a:rPr>
+              <a:t>+0.07</a:t>
+            </a:r>
+            <a:endParaRPr lang="en-US" sz="1050" dirty="0"/>
+          </a:p>
+        </p:txBody>
+      </p:sp>
+      <p:sp>
+        <p:nvSpPr>
+          <p:cNvPr id="20" name="Text 18"/>
+          <p:cNvSpPr/>
+          <p:nvPr/>
+        </p:nvSpPr>
+        <p:spPr>
+          <a:xfrm>
+            <a:off x="3840480" y="2807208"/>
+            <a:ext cx="868680" cy="292608"/>
+          </a:xfrm>
+          <a:prstGeom prst="rect">
+            <a:avLst/>
+          </a:prstGeom>
+          <a:noFill/>
+          <a:ln/>
+        </p:spPr>
+        <p:txBody>
+          <a:bodyPr wrap="square" lIns="0" tIns="0" rIns="0" bIns="0" rtlCol="0" anchor="ctr"/>
+          <a:lstStyle/>
+          <a:p>
+            <a:pPr indent="0" marL="0">
+              <a:buNone/>
+            </a:pPr>
+            <a:r>
+              <a:rPr lang="en-US" sz="1050" dirty="0">
+                <a:solidFill>
+                  <a:srgbClr val="0F172A"/>
+                </a:solidFill>
+                <a:latin typeface="Consolas" pitchFamily="34" charset="0"/>
+                <a:ea typeface="Consolas" pitchFamily="34" charset="-122"/>
+                <a:cs typeface="Consolas" pitchFamily="34" charset="-120"/>
+              </a:rPr>
+              <a:t>0.281</a:t>
+            </a:r>
+            <a:endParaRPr lang="en-US" sz="1050" dirty="0"/>
+          </a:p>
+        </p:txBody>
+      </p:sp>
+      <p:sp>
+        <p:nvSpPr>
+          <p:cNvPr id="21" name="Text 19"/>
+          <p:cNvSpPr/>
+          <p:nvPr/>
+        </p:nvSpPr>
+        <p:spPr>
+          <a:xfrm>
+            <a:off x="4709160" y="2807208"/>
+            <a:ext cx="640080" cy="292608"/>
+          </a:xfrm>
+          <a:prstGeom prst="rect">
+            <a:avLst/>
+          </a:prstGeom>
+          <a:noFill/>
+          <a:ln/>
+        </p:spPr>
+        <p:txBody>
+          <a:bodyPr wrap="square" lIns="0" tIns="0" rIns="0" bIns="0" rtlCol="0" anchor="ctr"/>
+          <a:lstStyle/>
+          <a:p>
+            <a:pPr indent="0" marL="0">
+              <a:buNone/>
+            </a:pPr>
+            <a:r>
+              <a:rPr lang="en-US" sz="1050" b="1" dirty="0">
+                <a:solidFill>
+                  <a:srgbClr val="64748B"/>
+                </a:solidFill>
+                <a:latin typeface="Consolas" pitchFamily="34" charset="0"/>
+                <a:ea typeface="Consolas" pitchFamily="34" charset="-122"/>
+                <a:cs typeface="Consolas" pitchFamily="34" charset="-120"/>
+              </a:rPr>
+              <a:t>n.s.</a:t>
+            </a:r>
+            <a:endParaRPr lang="en-US" sz="1050" dirty="0"/>
+          </a:p>
+        </p:txBody>
+      </p:sp>
+      <p:sp>
+        <p:nvSpPr>
+          <p:cNvPr id="22" name="Text 20"/>
+          <p:cNvSpPr/>
+          <p:nvPr/>
+        </p:nvSpPr>
+        <p:spPr>
+          <a:xfrm>
+            <a:off x="640080" y="3191256"/>
+            <a:ext cx="1463040" cy="292608"/>
+          </a:xfrm>
+          <a:prstGeom prst="rect">
+            <a:avLst/>
+          </a:prstGeom>
+          <a:noFill/>
+          <a:ln/>
+        </p:spPr>
+        <p:txBody>
+          <a:bodyPr wrap="square" lIns="0" tIns="0" rIns="0" bIns="0" rtlCol="0" anchor="ctr"/>
+          <a:lstStyle/>
+          <a:p>
+            <a:pPr indent="0" marL="0">
+              <a:buNone/>
+            </a:pPr>
+            <a:r>
+              <a:rPr lang="en-US" sz="1100" b="1" dirty="0">
+                <a:solidFill>
+                  <a:srgbClr val="0F172A"/>
+                </a:solidFill>
+                <a:latin typeface="Calibri" pitchFamily="34" charset="0"/>
+                <a:ea typeface="Calibri" pitchFamily="34" charset="-122"/>
+                <a:cs typeface="Calibri" pitchFamily="34" charset="-120"/>
+              </a:rPr>
+              <a:t>POI-Dichte</a:t>
+            </a:r>
+            <a:endParaRPr lang="en-US" sz="1100" dirty="0"/>
+          </a:p>
+        </p:txBody>
+      </p:sp>
+      <p:sp>
+        <p:nvSpPr>
+          <p:cNvPr id="23" name="Text 21"/>
+          <p:cNvSpPr/>
+          <p:nvPr/>
+        </p:nvSpPr>
+        <p:spPr>
+          <a:xfrm>
+            <a:off x="2103120" y="3191256"/>
+            <a:ext cx="868680" cy="292608"/>
+          </a:xfrm>
+          <a:prstGeom prst="rect">
+            <a:avLst/>
+          </a:prstGeom>
+          <a:noFill/>
+          <a:ln/>
+        </p:spPr>
+        <p:txBody>
+          <a:bodyPr wrap="square" lIns="0" tIns="0" rIns="0" bIns="0" rtlCol="0" anchor="ctr"/>
+          <a:lstStyle/>
+          <a:p>
+            <a:pPr indent="0" marL="0">
+              <a:buNone/>
+            </a:pPr>
+            <a:r>
+              <a:rPr lang="en-US" sz="1050" dirty="0">
+                <a:solidFill>
+                  <a:srgbClr val="0F172A"/>
+                </a:solidFill>
+                <a:latin typeface="Consolas" pitchFamily="34" charset="0"/>
+                <a:ea typeface="Consolas" pitchFamily="34" charset="-122"/>
+                <a:cs typeface="Consolas" pitchFamily="34" charset="-120"/>
+              </a:rPr>
+              <a:t>+0.84</a:t>
+            </a:r>
+            <a:endParaRPr lang="en-US" sz="1050" dirty="0"/>
+          </a:p>
+        </p:txBody>
+      </p:sp>
+      <p:sp>
+        <p:nvSpPr>
+          <p:cNvPr id="24" name="Text 22"/>
+          <p:cNvSpPr/>
+          <p:nvPr/>
+        </p:nvSpPr>
+        <p:spPr>
+          <a:xfrm>
+            <a:off x="2971800" y="3191256"/>
+            <a:ext cx="868680" cy="292608"/>
+          </a:xfrm>
+          <a:prstGeom prst="rect">
+            <a:avLst/>
+          </a:prstGeom>
+          <a:noFill/>
+          <a:ln/>
+        </p:spPr>
+        <p:txBody>
+          <a:bodyPr wrap="square" lIns="0" tIns="0" rIns="0" bIns="0" rtlCol="0" anchor="ctr"/>
+          <a:lstStyle/>
+          <a:p>
+            <a:pPr indent="0" marL="0">
+              <a:buNone/>
+            </a:pPr>
+            <a:r>
+              <a:rPr lang="en-US" sz="1050" dirty="0">
+                <a:solidFill>
+                  <a:srgbClr val="0F172A"/>
+                </a:solidFill>
+                <a:latin typeface="Consolas" pitchFamily="34" charset="0"/>
+                <a:ea typeface="Consolas" pitchFamily="34" charset="-122"/>
+                <a:cs typeface="Consolas" pitchFamily="34" charset="-120"/>
+              </a:rPr>
+              <a:t>+0.14</a:t>
+            </a:r>
+            <a:endParaRPr lang="en-US" sz="1050" dirty="0"/>
+          </a:p>
+        </p:txBody>
+      </p:sp>
+      <p:sp>
+        <p:nvSpPr>
+          <p:cNvPr id="25" name="Text 23"/>
+          <p:cNvSpPr/>
+          <p:nvPr/>
+        </p:nvSpPr>
+        <p:spPr>
+          <a:xfrm>
+            <a:off x="3840480" y="3191256"/>
+            <a:ext cx="868680" cy="292608"/>
+          </a:xfrm>
+          <a:prstGeom prst="rect">
+            <a:avLst/>
+          </a:prstGeom>
+          <a:noFill/>
+          <a:ln/>
+        </p:spPr>
+        <p:txBody>
+          <a:bodyPr wrap="square" lIns="0" tIns="0" rIns="0" bIns="0" rtlCol="0" anchor="ctr"/>
+          <a:lstStyle/>
+          <a:p>
+            <a:pPr indent="0" marL="0">
+              <a:buNone/>
+            </a:pPr>
+            <a:r>
+              <a:rPr lang="en-US" sz="1050" dirty="0">
+                <a:solidFill>
+                  <a:srgbClr val="0F172A"/>
+                </a:solidFill>
+                <a:latin typeface="Consolas" pitchFamily="34" charset="0"/>
+                <a:ea typeface="Consolas" pitchFamily="34" charset="-122"/>
+                <a:cs typeface="Consolas" pitchFamily="34" charset="-120"/>
+              </a:rPr>
+              <a:t>&lt;10⁻⁸</a:t>
+            </a:r>
+            <a:endParaRPr lang="en-US" sz="1050" dirty="0"/>
+          </a:p>
+        </p:txBody>
+      </p:sp>
+      <p:sp>
+        <p:nvSpPr>
+          <p:cNvPr id="26" name="Text 24"/>
+          <p:cNvSpPr/>
+          <p:nvPr/>
+        </p:nvSpPr>
+        <p:spPr>
+          <a:xfrm>
+            <a:off x="4709160" y="3191256"/>
+            <a:ext cx="640080" cy="292608"/>
+          </a:xfrm>
+          <a:prstGeom prst="rect">
+            <a:avLst/>
+          </a:prstGeom>
+          <a:noFill/>
+          <a:ln/>
+        </p:spPr>
+        <p:txBody>
+          <a:bodyPr wrap="square" lIns="0" tIns="0" rIns="0" bIns="0" rtlCol="0" anchor="ctr"/>
+          <a:lstStyle/>
+          <a:p>
+            <a:pPr indent="0" marL="0">
+              <a:buNone/>
+            </a:pPr>
+            <a:r>
+              <a:rPr lang="en-US" sz="1050" b="1" dirty="0">
+                <a:solidFill>
+                  <a:srgbClr val="F59E0B"/>
+                </a:solidFill>
+                <a:latin typeface="Consolas" pitchFamily="34" charset="0"/>
+                <a:ea typeface="Consolas" pitchFamily="34" charset="-122"/>
+                <a:cs typeface="Consolas" pitchFamily="34" charset="-120"/>
+              </a:rPr>
+              <a:t>***</a:t>
+            </a:r>
+            <a:endParaRPr lang="en-US" sz="1050" dirty="0"/>
+          </a:p>
+        </p:txBody>
+      </p:sp>
+      <p:sp>
+        <p:nvSpPr>
+          <p:cNvPr id="27" name="Text 25"/>
+          <p:cNvSpPr/>
+          <p:nvPr/>
+        </p:nvSpPr>
+        <p:spPr>
+          <a:xfrm>
+            <a:off x="640080" y="4160520"/>
+            <a:ext cx="4572000" cy="274320"/>
+          </a:xfrm>
+          <a:prstGeom prst="rect">
+            <a:avLst/>
+          </a:prstGeom>
+          <a:noFill/>
+          <a:ln/>
+        </p:spPr>
+        <p:txBody>
+          <a:bodyPr wrap="square" lIns="0" tIns="0" rIns="0" bIns="0" rtlCol="0" anchor="ctr"/>
+          <a:lstStyle/>
+          <a:p>
+            <a:pPr indent="0" marL="0">
+              <a:buNone/>
+            </a:pPr>
+            <a:r>
+              <a:rPr lang="en-US" sz="900" i="1" dirty="0">
+                <a:solidFill>
+                  <a:srgbClr val="64748B"/>
+                </a:solidFill>
+                <a:latin typeface="Calibri" pitchFamily="34" charset="0"/>
+                <a:ea typeface="Calibri" pitchFamily="34" charset="-122"/>
+                <a:cs typeface="Calibri" pitchFamily="34" charset="-120"/>
+              </a:rPr>
+              <a:t>Signifikanz-Codes:  *** p&lt;0.001 · ** p&lt;0.01 · * p&lt;0.05</a:t>
+            </a:r>
+            <a:endParaRPr lang="en-US" sz="900" dirty="0"/>
+          </a:p>
+        </p:txBody>
+      </p:sp>
+      <p:sp>
+        <p:nvSpPr>
+          <p:cNvPr id="28" name="Shape 26"/>
+          <p:cNvSpPr/>
+          <p:nvPr/>
+        </p:nvSpPr>
+        <p:spPr>
+          <a:xfrm>
+            <a:off x="5486400" y="1508760"/>
+            <a:ext cx="3200400" cy="3108960"/>
           </a:xfrm>
           <a:prstGeom prst="rect">
             <a:avLst/>
@@ -7022,24 +7891,24 @@
       </p:sp>
       <p:sp>
         <p:nvSpPr>
-          <p:cNvPr id="9" name="Shape 7"/>
-          <p:cNvSpPr/>
-          <p:nvPr/>
-        </p:nvSpPr>
-        <p:spPr>
-          <a:xfrm>
-            <a:off x="4663440" y="1554480"/>
-            <a:ext cx="4023360" cy="54864"/>
+          <p:cNvPr id="29" name="Shape 27"/>
+          <p:cNvSpPr/>
+          <p:nvPr/>
+        </p:nvSpPr>
+        <p:spPr>
+          <a:xfrm>
+            <a:off x="5486400" y="1508760"/>
+            <a:ext cx="3200400" cy="54864"/>
           </a:xfrm>
           <a:prstGeom prst="rect">
             <a:avLst/>
           </a:prstGeom>
           <a:solidFill>
-            <a:srgbClr val="D73027"/>
+            <a:srgbClr val="1C7293"/>
           </a:solidFill>
           <a:ln w="12700">
             <a:solidFill>
-              <a:srgbClr val="D73027"/>
+              <a:srgbClr val="1C7293"/>
             </a:solidFill>
             <a:prstDash val="solid"/>
           </a:ln>
@@ -7047,77 +7916,345 @@
       </p:sp>
       <p:sp>
         <p:nvSpPr>
-          <p:cNvPr id="10" name="Text 8"/>
-          <p:cNvSpPr/>
-          <p:nvPr/>
-        </p:nvSpPr>
-        <p:spPr>
-          <a:xfrm>
-            <a:off x="4846320" y="1719072"/>
-            <a:ext cx="3657600" cy="365760"/>
-          </a:xfrm>
-          <a:prstGeom prst="rect">
-            <a:avLst/>
-          </a:prstGeom>
-          <a:noFill/>
-          <a:ln/>
-        </p:spPr>
-        <p:txBody>
-          <a:bodyPr wrap="square" lIns="0" tIns="0" rIns="0" bIns="0" rtlCol="0" anchor="ctr"/>
-          <a:lstStyle/>
-          <a:p>
-            <a:pPr indent="0" marL="0">
-              <a:buNone/>
-            </a:pPr>
-            <a:r>
-              <a:rPr lang="en-US" sz="1400" b="1" dirty="0">
-                <a:solidFill>
-                  <a:srgbClr val="D73027"/>
+          <p:cNvPr id="30" name="Text 28"/>
+          <p:cNvSpPr/>
+          <p:nvPr/>
+        </p:nvSpPr>
+        <p:spPr>
+          <a:xfrm>
+            <a:off x="5669280" y="1645920"/>
+            <a:ext cx="2926080" cy="320040"/>
+          </a:xfrm>
+          <a:prstGeom prst="rect">
+            <a:avLst/>
+          </a:prstGeom>
+          <a:noFill/>
+          <a:ln/>
+        </p:spPr>
+        <p:txBody>
+          <a:bodyPr wrap="square" lIns="0" tIns="0" rIns="0" bIns="0" rtlCol="0" anchor="ctr"/>
+          <a:lstStyle/>
+          <a:p>
+            <a:pPr indent="0" marL="0">
+              <a:buNone/>
+            </a:pPr>
+            <a:r>
+              <a:rPr lang="en-US" sz="1300" b="1" dirty="0">
+                <a:solidFill>
+                  <a:srgbClr val="1C7293"/>
                 </a:solidFill>
                 <a:latin typeface="Trebuchet MS" pitchFamily="34" charset="0"/>
                 <a:ea typeface="Trebuchet MS" pitchFamily="34" charset="-122"/>
                 <a:cs typeface="Trebuchet MS" pitchFamily="34" charset="-120"/>
               </a:rPr>
-              <a:t>Mietpreis-Validierung offen</a:t>
-            </a:r>
-            <a:endParaRPr lang="en-US" sz="1400" dirty="0"/>
-          </a:p>
-        </p:txBody>
-      </p:sp>
-      <p:sp>
-        <p:nvSpPr>
-          <p:cNvPr id="11" name="Text 9"/>
-          <p:cNvSpPr/>
-          <p:nvPr/>
-        </p:nvSpPr>
-        <p:spPr>
-          <a:xfrm>
-            <a:off x="4846320" y="2103120"/>
-            <a:ext cx="3657600" cy="777240"/>
-          </a:xfrm>
-          <a:prstGeom prst="rect">
-            <a:avLst/>
-          </a:prstGeom>
-          <a:noFill/>
-          <a:ln/>
-        </p:spPr>
-        <p:txBody>
-          <a:bodyPr wrap="square" lIns="0" tIns="0" rIns="0" bIns="0" rtlCol="0" anchor="ctr"/>
-          <a:lstStyle/>
-          <a:p>
-            <a:pPr indent="0" marL="0">
-              <a:buNone/>
-            </a:pPr>
-            <a:r>
-              <a:rPr lang="en-US" sz="1100" dirty="0">
-                <a:solidFill>
-                  <a:srgbClr val="0F172A"/>
+              <a:t>Was das bedeutet</a:t>
+            </a:r>
+            <a:endParaRPr lang="en-US" sz="1300" dirty="0"/>
+          </a:p>
+        </p:txBody>
+      </p:sp>
+      <p:sp>
+        <p:nvSpPr>
+          <p:cNvPr id="31" name="Text 29"/>
+          <p:cNvSpPr/>
+          <p:nvPr/>
+        </p:nvSpPr>
+        <p:spPr>
+          <a:xfrm>
+            <a:off x="5669280" y="2057400"/>
+            <a:ext cx="2926080" cy="2468880"/>
+          </a:xfrm>
+          <a:prstGeom prst="rect">
+            <a:avLst/>
+          </a:prstGeom>
+          <a:noFill/>
+          <a:ln/>
+        </p:spPr>
+        <p:txBody>
+          <a:bodyPr wrap="square" lIns="0" tIns="0" rIns="0" bIns="0" rtlCol="0" anchor="ctr"/>
+          <a:lstStyle/>
+          <a:p>
+            <a:pPr indent="0" marL="0">
+              <a:buNone/>
+            </a:pPr>
+            <a:r>
+              <a:rPr lang="en-US" sz="1050" b="1" dirty="0">
+                <a:solidFill>
+                  <a:srgbClr val="1A9850"/>
                 </a:solidFill>
                 <a:latin typeface="Calibri" pitchFamily="34" charset="0"/>
                 <a:ea typeface="Calibri" pitchFamily="34" charset="-122"/>
                 <a:cs typeface="Calibri" pitchFamily="34" charset="-120"/>
               </a:rPr>
-              <a:t>Stadt-Zürich-Mietpreis-Datensatz war zum Auswertungszeitpunkt unter dokumentierter URL nicht erreichbar (HTTP 404) — H1 wurde via Distanz zum HB validiert.</a:t>
+              <a:t>H1 robust</a:t>
+            </a:r>
+            <a:endParaRPr lang="en-US" sz="1050" dirty="0"/>
+          </a:p>
+          <a:p>
+            <a:pPr indent="0" marL="0">
+              <a:buNone/>
+            </a:pPr>
+            <a:r>
+              <a:rPr lang="en-US" sz="1050" dirty="0">
+                <a:solidFill>
+                  <a:srgbClr val="0F172A"/>
+                </a:solidFill>
+                <a:latin typeface="Calibri" pitchFamily="34" charset="0"/>
+                <a:ea typeface="Calibri" pitchFamily="34" charset="-122"/>
+                <a:cs typeface="Calibri" pitchFamily="34" charset="-120"/>
+              </a:rPr>
+              <a:t>Distanz bleibt nach Kontrolle für Höhe und POI-Dichte signifikant.</a:t>
+            </a:r>
+            <a:endParaRPr lang="en-US" sz="1050" dirty="0"/>
+          </a:p>
+          <a:p>
+            <a:pPr indent="0" marL="0">
+              <a:buNone/>
+            </a:pPr>
+            <a:r>
+              <a:rPr lang="en-US" sz="1050" dirty="0">
+                <a:solidFill>
+                  <a:srgbClr val="0F172A"/>
+                </a:solidFill>
+                <a:latin typeface="Calibri" pitchFamily="34" charset="0"/>
+                <a:ea typeface="Calibri" pitchFamily="34" charset="-122"/>
+                <a:cs typeface="Calibri" pitchFamily="34" charset="-120"/>
+              </a:rPr>
+              <a:t> </a:t>
+            </a:r>
+            <a:endParaRPr lang="en-US" sz="1050" dirty="0"/>
+          </a:p>
+          <a:p>
+            <a:pPr indent="0" marL="0">
+              <a:buNone/>
+            </a:pPr>
+            <a:r>
+              <a:rPr lang="en-US" sz="1050" b="1" dirty="0">
+                <a:solidFill>
+                  <a:srgbClr val="64748B"/>
+                </a:solidFill>
+                <a:latin typeface="Calibri" pitchFamily="34" charset="0"/>
+                <a:ea typeface="Calibri" pitchFamily="34" charset="-122"/>
+                <a:cs typeface="Calibri" pitchFamily="34" charset="-120"/>
+              </a:rPr>
+              <a:t>Topografie inkonklusiv</a:t>
+            </a:r>
+            <a:endParaRPr lang="en-US" sz="1050" dirty="0"/>
+          </a:p>
+          <a:p>
+            <a:pPr indent="0" marL="0">
+              <a:buNone/>
+            </a:pPr>
+            <a:r>
+              <a:rPr lang="en-US" sz="1050" dirty="0">
+                <a:solidFill>
+                  <a:srgbClr val="0F172A"/>
+                </a:solidFill>
+                <a:latin typeface="Calibri" pitchFamily="34" charset="0"/>
+                <a:ea typeface="Calibri" pitchFamily="34" charset="-122"/>
+                <a:cs typeface="Calibri" pitchFamily="34" charset="-120"/>
+              </a:rPr>
+              <a:t>Höhe approximiert (Open-Elevation-API zum Zeitpunkt down) — kein definitives Urteil.</a:t>
+            </a:r>
+            <a:endParaRPr lang="en-US" sz="1050" dirty="0"/>
+          </a:p>
+          <a:p>
+            <a:pPr indent="0" marL="0">
+              <a:buNone/>
+            </a:pPr>
+            <a:r>
+              <a:rPr lang="en-US" sz="1050" dirty="0">
+                <a:solidFill>
+                  <a:srgbClr val="0F172A"/>
+                </a:solidFill>
+                <a:latin typeface="Calibri" pitchFamily="34" charset="0"/>
+                <a:ea typeface="Calibri" pitchFamily="34" charset="-122"/>
+                <a:cs typeface="Calibri" pitchFamily="34" charset="-120"/>
+              </a:rPr>
+              <a:t> </a:t>
+            </a:r>
+            <a:endParaRPr lang="en-US" sz="1050" dirty="0"/>
+          </a:p>
+          <a:p>
+            <a:pPr indent="0" marL="0">
+              <a:buNone/>
+            </a:pPr>
+            <a:r>
+              <a:rPr lang="en-US" sz="1050" b="1" dirty="0">
+                <a:solidFill>
+                  <a:srgbClr val="F59E0B"/>
+                </a:solidFill>
+                <a:latin typeface="Calibri" pitchFamily="34" charset="0"/>
+                <a:ea typeface="Calibri" pitchFamily="34" charset="-122"/>
+                <a:cs typeface="Calibri" pitchFamily="34" charset="-120"/>
+              </a:rPr>
+              <a:t>POI-Dichte tautologisch</a:t>
+            </a:r>
+            <a:endParaRPr lang="en-US" sz="1050" dirty="0"/>
+          </a:p>
+          <a:p>
+            <a:pPr indent="0" marL="0">
+              <a:buNone/>
+            </a:pPr>
+            <a:r>
+              <a:rPr lang="en-US" sz="1050" dirty="0">
+                <a:solidFill>
+                  <a:srgbClr val="0F172A"/>
+                </a:solidFill>
+                <a:latin typeface="Calibri" pitchFamily="34" charset="0"/>
+                <a:ea typeface="Calibri" pitchFamily="34" charset="-122"/>
+                <a:cs typeface="Calibri" pitchFamily="34" charset="-120"/>
+              </a:rPr>
+              <a:t>Score wird aus POIs berechnet — Korrelation strukturell zu erwarten.</a:t>
+            </a:r>
+            <a:endParaRPr lang="en-US" sz="1050" dirty="0"/>
+          </a:p>
+        </p:txBody>
+      </p:sp>
+      <p:sp>
+        <p:nvSpPr>
+          <p:cNvPr id="32" name="Text 30"/>
+          <p:cNvSpPr/>
+          <p:nvPr/>
+        </p:nvSpPr>
+        <p:spPr>
+          <a:xfrm>
+            <a:off x="365760" y="4846320"/>
+            <a:ext cx="7315200" cy="228600"/>
+          </a:xfrm>
+          <a:prstGeom prst="rect">
+            <a:avLst/>
+          </a:prstGeom>
+          <a:noFill/>
+          <a:ln/>
+        </p:spPr>
+        <p:txBody>
+          <a:bodyPr wrap="square" lIns="0" tIns="0" rIns="0" bIns="0" rtlCol="0" anchor="ctr"/>
+          <a:lstStyle/>
+          <a:p>
+            <a:pPr algn="l" indent="0" marL="0">
+              <a:buNone/>
+            </a:pPr>
+            <a:r>
+              <a:rPr lang="en-US" sz="900" dirty="0">
+                <a:solidFill>
+                  <a:srgbClr val="64748B"/>
+                </a:solidFill>
+                <a:latin typeface="Calibri" pitchFamily="34" charset="0"/>
+                <a:ea typeface="Calibri" pitchFamily="34" charset="-122"/>
+                <a:cs typeface="Calibri" pitchFamily="34" charset="-120"/>
+              </a:rPr>
+              <a:t>OLS-Regression mit statsmodels · Daten: reports/robustness_data.csv</a:t>
+            </a:r>
+            <a:endParaRPr lang="en-US" sz="900" dirty="0"/>
+          </a:p>
+        </p:txBody>
+      </p:sp>
+      <p:sp>
+        <p:nvSpPr>
+          <p:cNvPr id="33" name="Text 31"/>
+          <p:cNvSpPr/>
+          <p:nvPr/>
+        </p:nvSpPr>
+        <p:spPr>
+          <a:xfrm>
+            <a:off x="8229600" y="4846320"/>
+            <a:ext cx="822960" cy="228600"/>
+          </a:xfrm>
+          <a:prstGeom prst="rect">
+            <a:avLst/>
+          </a:prstGeom>
+          <a:noFill/>
+          <a:ln/>
+        </p:spPr>
+        <p:txBody>
+          <a:bodyPr wrap="square" lIns="0" tIns="0" rIns="0" bIns="0" rtlCol="0" anchor="ctr"/>
+          <a:lstStyle/>
+          <a:p>
+            <a:pPr algn="r" indent="0" marL="0">
+              <a:buNone/>
+            </a:pPr>
+            <a:r>
+              <a:rPr lang="en-US" sz="900" dirty="0">
+                <a:solidFill>
+                  <a:srgbClr val="64748B"/>
+                </a:solidFill>
+                <a:latin typeface="Calibri" pitchFamily="34" charset="0"/>
+                <a:ea typeface="Calibri" pitchFamily="34" charset="-122"/>
+                <a:cs typeface="Calibri" pitchFamily="34" charset="-120"/>
+              </a:rPr>
+              <a:t>15 / 17</a:t>
+            </a:r>
+            <a:endParaRPr lang="en-US" sz="900" dirty="0"/>
+          </a:p>
+        </p:txBody>
+      </p:sp>
+    </p:spTree>
+  </p:cSld>
+  <p:clrMapOvr>
+    <a:masterClrMapping/>
+  </p:clrMapOvr>
+</p:sld>
+</file>
+
+<file path=ppt/slides/slide16.xml><?xml version="1.0" encoding="utf-8"?>
+<p:sld xmlns:a="http://schemas.openxmlformats.org/drawingml/2006/main" xmlns:r="http://schemas.openxmlformats.org/officeDocument/2006/relationships" xmlns:p="http://schemas.openxmlformats.org/presentationml/2006/main">
+  <p:cSld name="Slide 16">
+    <p:bg>
+      <p:bgPr>
+        <a:solidFill>
+          <a:srgbClr val="FFFFFF"/>
+        </a:solidFill>
+      </p:bgPr>
+    </p:bg>
+    <p:spTree>
+      <p:nvGrpSpPr>
+        <p:cNvPr id="1" name=""/>
+        <p:cNvGrpSpPr/>
+        <p:nvPr/>
+      </p:nvGrpSpPr>
+      <p:grpSpPr>
+        <a:xfrm>
+          <a:off x="0" y="0"/>
+          <a:ext cx="0" cy="0"/>
+          <a:chOff x="0" y="0"/>
+          <a:chExt cx="0" cy="0"/>
+        </a:xfrm>
+      </p:grpSpPr>
+      <p:sp>
+        <p:nvSpPr>
+          <p:cNvPr id="2" name="Text 0"/>
+          <p:cNvSpPr/>
+          <p:nvPr/>
+        </p:nvSpPr>
+        <p:spPr>
+          <a:xfrm>
+            <a:off x="365760" y="274320"/>
+            <a:ext cx="4572000" cy="274320"/>
+          </a:xfrm>
+          <a:prstGeom prst="rect">
+            <a:avLst/>
+          </a:prstGeom>
+          <a:noFill/>
+          <a:ln/>
+        </p:spPr>
+        <p:txBody>
+          <a:bodyPr wrap="square" lIns="0" tIns="0" rIns="0" bIns="0" rtlCol="0" anchor="ctr"/>
+          <a:lstStyle/>
+          <a:p>
+            <a:pPr indent="0" marL="0">
+              <a:buNone/>
+            </a:pPr>
+            <a:r>
+              <a:rPr lang="en-US" sz="1100" b="1" spc="400" kern="0" dirty="0">
+                <a:solidFill>
+                  <a:srgbClr val="1C7293"/>
+                </a:solidFill>
+                <a:latin typeface="Trebuchet MS" pitchFamily="34" charset="0"/>
+                <a:ea typeface="Trebuchet MS" pitchFamily="34" charset="-122"/>
+                <a:cs typeface="Trebuchet MS" pitchFamily="34" charset="-120"/>
+              </a:rPr>
+              <a:t>SCHLUSS · 1/2</a:t>
             </a:r>
             <a:endParaRPr lang="en-US" sz="1100" dirty="0"/>
           </a:p>
@@ -7125,13 +8262,52 @@
       </p:sp>
       <p:sp>
         <p:nvSpPr>
-          <p:cNvPr id="12" name="Shape 10"/>
-          <p:cNvSpPr/>
-          <p:nvPr/>
-        </p:nvSpPr>
-        <p:spPr>
-          <a:xfrm>
-            <a:off x="457200" y="3063240"/>
+          <p:cNvPr id="3" name="Text 1"/>
+          <p:cNvSpPr/>
+          <p:nvPr/>
+        </p:nvSpPr>
+        <p:spPr>
+          <a:xfrm>
+            <a:off x="365760" y="594360"/>
+            <a:ext cx="8412480" cy="640080"/>
+          </a:xfrm>
+          <a:prstGeom prst="rect">
+            <a:avLst/>
+          </a:prstGeom>
+          <a:noFill/>
+          <a:ln/>
+        </p:spPr>
+        <p:txBody>
+          <a:bodyPr wrap="square" lIns="0" tIns="0" rIns="0" bIns="0" rtlCol="0" anchor="ctr"/>
+          <a:lstStyle/>
+          <a:p>
+            <a:pPr indent="0" marL="0">
+              <a:buNone/>
+            </a:pPr>
+            <a:r>
+              <a:rPr lang="en-US" sz="3000" b="1" dirty="0">
+                <a:solidFill>
+                  <a:srgbClr val="0F172A"/>
+                </a:solidFill>
+                <a:latin typeface="Trebuchet MS" pitchFamily="34" charset="0"/>
+                <a:ea typeface="Trebuchet MS" pitchFamily="34" charset="-122"/>
+                <a:cs typeface="Trebuchet MS" pitchFamily="34" charset="-120"/>
+              </a:rPr>
+              <a:t>Limitationen unseres Modells</a:t>
+            </a:r>
+            <a:endParaRPr lang="en-US" sz="3000" dirty="0"/>
+          </a:p>
+        </p:txBody>
+      </p:sp>
+      <p:sp>
+        <p:nvSpPr>
+          <p:cNvPr id="4" name="Shape 2"/>
+          <p:cNvSpPr/>
+          <p:nvPr/>
+        </p:nvSpPr>
+        <p:spPr>
+          <a:xfrm>
+            <a:off x="457200" y="1554480"/>
             <a:ext cx="4023360" cy="1371600"/>
           </a:xfrm>
           <a:prstGeom prst="rect">
@@ -7157,13 +8333,13 @@
       </p:sp>
       <p:sp>
         <p:nvSpPr>
-          <p:cNvPr id="13" name="Shape 11"/>
-          <p:cNvSpPr/>
-          <p:nvPr/>
-        </p:nvSpPr>
-        <p:spPr>
-          <a:xfrm>
-            <a:off x="457200" y="3063240"/>
+          <p:cNvPr id="5" name="Shape 3"/>
+          <p:cNvSpPr/>
+          <p:nvPr/>
+        </p:nvSpPr>
+        <p:spPr>
+          <a:xfrm>
+            <a:off x="457200" y="1554480"/>
             <a:ext cx="4023360" cy="54864"/>
           </a:xfrm>
           <a:prstGeom prst="rect">
@@ -7182,13 +8358,13 @@
       </p:sp>
       <p:sp>
         <p:nvSpPr>
-          <p:cNvPr id="14" name="Text 12"/>
-          <p:cNvSpPr/>
-          <p:nvPr/>
-        </p:nvSpPr>
-        <p:spPr>
-          <a:xfrm>
-            <a:off x="640080" y="3227832"/>
+          <p:cNvPr id="6" name="Text 4"/>
+          <p:cNvSpPr/>
+          <p:nvPr/>
+        </p:nvSpPr>
+        <p:spPr>
+          <a:xfrm>
+            <a:off x="640080" y="1719072"/>
             <a:ext cx="3657600" cy="365760"/>
           </a:xfrm>
           <a:prstGeom prst="rect">
@@ -7213,7 +8389,7 @@
                 <a:ea typeface="Trebuchet MS" pitchFamily="34" charset="-122"/>
                 <a:cs typeface="Trebuchet MS" pitchFamily="34" charset="-120"/>
               </a:rPr>
-              <a:t>STATPOP nicht eingebunden</a:t>
+              <a:t>Datenqualität OSM</a:t>
             </a:r>
             <a:endParaRPr lang="en-US" sz="1400" dirty="0"/>
           </a:p>
@@ -7221,13 +8397,13 @@
       </p:sp>
       <p:sp>
         <p:nvSpPr>
-          <p:cNvPr id="15" name="Text 13"/>
-          <p:cNvSpPr/>
-          <p:nvPr/>
-        </p:nvSpPr>
-        <p:spPr>
-          <a:xfrm>
-            <a:off x="640080" y="3611880"/>
+          <p:cNvPr id="7" name="Text 5"/>
+          <p:cNvSpPr/>
+          <p:nvPr/>
+        </p:nvSpPr>
+        <p:spPr>
+          <a:xfrm>
+            <a:off x="640080" y="2103120"/>
             <a:ext cx="3657600" cy="777240"/>
           </a:xfrm>
           <a:prstGeom prst="rect">
@@ -7252,7 +8428,7 @@
                 <a:ea typeface="Calibri" pitchFamily="34" charset="-122"/>
                 <a:cs typeface="Calibri" pitchFamily="34" charset="-120"/>
               </a:rPr>
-              <a:t>BFS-Hektar-Bevölkerungsraster ist nur per manuellem Download verfügbar; Bevölkerungsdichte als zusätzliche Validierung steht aus.</a:t>
+              <a:t>Kleine, unmappte Geschäfte fehlen. Annahme: Verzerrung gering, weil Geschäfte ähnlicher Klassifikation OSM-mässig konsistent sind.</a:t>
             </a:r>
             <a:endParaRPr lang="en-US" sz="1100" dirty="0"/>
           </a:p>
@@ -7260,13 +8436,13 @@
       </p:sp>
       <p:sp>
         <p:nvSpPr>
-          <p:cNvPr id="16" name="Shape 14"/>
-          <p:cNvSpPr/>
-          <p:nvPr/>
-        </p:nvSpPr>
-        <p:spPr>
-          <a:xfrm>
-            <a:off x="4663440" y="3063240"/>
+          <p:cNvPr id="8" name="Shape 6"/>
+          <p:cNvSpPr/>
+          <p:nvPr/>
+        </p:nvSpPr>
+        <p:spPr>
+          <a:xfrm>
+            <a:off x="4663440" y="1554480"/>
             <a:ext cx="4023360" cy="1371600"/>
           </a:xfrm>
           <a:prstGeom prst="rect">
@@ -7292,13 +8468,13 @@
       </p:sp>
       <p:sp>
         <p:nvSpPr>
-          <p:cNvPr id="17" name="Shape 15"/>
-          <p:cNvSpPr/>
-          <p:nvPr/>
-        </p:nvSpPr>
-        <p:spPr>
-          <a:xfrm>
-            <a:off x="4663440" y="3063240"/>
+          <p:cNvPr id="9" name="Shape 7"/>
+          <p:cNvSpPr/>
+          <p:nvPr/>
+        </p:nvSpPr>
+        <p:spPr>
+          <a:xfrm>
+            <a:off x="4663440" y="1554480"/>
             <a:ext cx="4023360" cy="54864"/>
           </a:xfrm>
           <a:prstGeom prst="rect">
@@ -7317,13 +8493,13 @@
       </p:sp>
       <p:sp>
         <p:nvSpPr>
-          <p:cNvPr id="18" name="Text 16"/>
-          <p:cNvSpPr/>
-          <p:nvPr/>
-        </p:nvSpPr>
-        <p:spPr>
-          <a:xfrm>
-            <a:off x="4846320" y="3227832"/>
+          <p:cNvPr id="10" name="Text 8"/>
+          <p:cNvSpPr/>
+          <p:nvPr/>
+        </p:nvSpPr>
+        <p:spPr>
+          <a:xfrm>
+            <a:off x="4846320" y="1719072"/>
             <a:ext cx="3657600" cy="365760"/>
           </a:xfrm>
           <a:prstGeom prst="rect">
@@ -7348,7 +8524,7 @@
                 <a:ea typeface="Trebuchet MS" pitchFamily="34" charset="-122"/>
                 <a:cs typeface="Trebuchet MS" pitchFamily="34" charset="-120"/>
               </a:rPr>
-              <a:t>Luftlinien-Approximation</a:t>
+              <a:t>Mietpreis-Validierung offen</a:t>
             </a:r>
             <a:endParaRPr lang="en-US" sz="1400" dirty="0"/>
           </a:p>
@@ -7356,13 +8532,13 @@
       </p:sp>
       <p:sp>
         <p:nvSpPr>
-          <p:cNvPr id="19" name="Text 17"/>
-          <p:cNvSpPr/>
-          <p:nvPr/>
-        </p:nvSpPr>
-        <p:spPr>
-          <a:xfrm>
-            <a:off x="4846320" y="3611880"/>
+          <p:cNvPr id="11" name="Text 9"/>
+          <p:cNvSpPr/>
+          <p:nvPr/>
+        </p:nvSpPr>
+        <p:spPr>
+          <a:xfrm>
+            <a:off x="4846320" y="2103120"/>
             <a:ext cx="3657600" cy="777240"/>
           </a:xfrm>
           <a:prstGeom prst="rect">
@@ -7387,7 +8563,7 @@
                 <a:ea typeface="Calibri" pitchFamily="34" charset="-122"/>
                 <a:cs typeface="Calibri" pitchFamily="34" charset="-120"/>
               </a:rPr>
-              <a:t>Score nutzt KDTree-Distanz, nicht echte Strassengraph-Wege. Validierung über OSMnx-Demo-Isochronen (Notebook 04).</a:t>
+              <a:t>Stadt-Zürich-Mietpreis-Datensatz war zum Auswertungszeitpunkt unter dokumentierter URL nicht erreichbar (HTTP 404) — H1 wurde via Distanz zum HB validiert.</a:t>
             </a:r>
             <a:endParaRPr lang="en-US" sz="1100" dirty="0"/>
           </a:p>
@@ -7395,38 +8571,308 @@
       </p:sp>
       <p:sp>
         <p:nvSpPr>
-          <p:cNvPr id="20" name="Text 18"/>
-          <p:cNvSpPr/>
-          <p:nvPr/>
-        </p:nvSpPr>
-        <p:spPr>
-          <a:xfrm>
-            <a:off x="8229600" y="4846320"/>
-            <a:ext cx="822960" cy="228600"/>
-          </a:xfrm>
-          <a:prstGeom prst="rect">
-            <a:avLst/>
-          </a:prstGeom>
-          <a:noFill/>
-          <a:ln/>
-        </p:spPr>
-        <p:txBody>
-          <a:bodyPr wrap="square" lIns="0" tIns="0" rIns="0" bIns="0" rtlCol="0" anchor="ctr"/>
-          <a:lstStyle/>
-          <a:p>
-            <a:pPr algn="r" indent="0" marL="0">
-              <a:buNone/>
-            </a:pPr>
-            <a:r>
-              <a:rPr lang="en-US" sz="900" dirty="0">
-                <a:solidFill>
-                  <a:srgbClr val="64748B"/>
+          <p:cNvPr id="12" name="Shape 10"/>
+          <p:cNvSpPr/>
+          <p:nvPr/>
+        </p:nvSpPr>
+        <p:spPr>
+          <a:xfrm>
+            <a:off x="457200" y="3063240"/>
+            <a:ext cx="4023360" cy="1371600"/>
+          </a:xfrm>
+          <a:prstGeom prst="rect">
+            <a:avLst/>
+          </a:prstGeom>
+          <a:solidFill>
+            <a:srgbClr val="FFFFFF"/>
+          </a:solidFill>
+          <a:ln w="9525">
+            <a:solidFill>
+              <a:srgbClr val="E2E8F0"/>
+            </a:solidFill>
+            <a:prstDash val="solid"/>
+          </a:ln>
+          <a:effectLst>
+            <a:outerShdw sx="100000" sy="100000" kx="0" ky="0" algn="bl" rotWithShape="0" blurRad="101600" dist="12700" dir="5400000">
+              <a:srgbClr val="94A3B8">
+                <a:alpha val="12000"/>
+              </a:srgbClr>
+            </a:outerShdw>
+          </a:effectLst>
+        </p:spPr>
+      </p:sp>
+      <p:sp>
+        <p:nvSpPr>
+          <p:cNvPr id="13" name="Shape 11"/>
+          <p:cNvSpPr/>
+          <p:nvPr/>
+        </p:nvSpPr>
+        <p:spPr>
+          <a:xfrm>
+            <a:off x="457200" y="3063240"/>
+            <a:ext cx="4023360" cy="54864"/>
+          </a:xfrm>
+          <a:prstGeom prst="rect">
+            <a:avLst/>
+          </a:prstGeom>
+          <a:solidFill>
+            <a:srgbClr val="D73027"/>
+          </a:solidFill>
+          <a:ln w="12700">
+            <a:solidFill>
+              <a:srgbClr val="D73027"/>
+            </a:solidFill>
+            <a:prstDash val="solid"/>
+          </a:ln>
+        </p:spPr>
+      </p:sp>
+      <p:sp>
+        <p:nvSpPr>
+          <p:cNvPr id="14" name="Text 12"/>
+          <p:cNvSpPr/>
+          <p:nvPr/>
+        </p:nvSpPr>
+        <p:spPr>
+          <a:xfrm>
+            <a:off x="640080" y="3227832"/>
+            <a:ext cx="3657600" cy="365760"/>
+          </a:xfrm>
+          <a:prstGeom prst="rect">
+            <a:avLst/>
+          </a:prstGeom>
+          <a:noFill/>
+          <a:ln/>
+        </p:spPr>
+        <p:txBody>
+          <a:bodyPr wrap="square" lIns="0" tIns="0" rIns="0" bIns="0" rtlCol="0" anchor="ctr"/>
+          <a:lstStyle/>
+          <a:p>
+            <a:pPr indent="0" marL="0">
+              <a:buNone/>
+            </a:pPr>
+            <a:r>
+              <a:rPr lang="en-US" sz="1400" b="1" dirty="0">
+                <a:solidFill>
+                  <a:srgbClr val="D73027"/>
+                </a:solidFill>
+                <a:latin typeface="Trebuchet MS" pitchFamily="34" charset="0"/>
+                <a:ea typeface="Trebuchet MS" pitchFamily="34" charset="-122"/>
+                <a:cs typeface="Trebuchet MS" pitchFamily="34" charset="-120"/>
+              </a:rPr>
+              <a:t>Topografie nur approximiert</a:t>
+            </a:r>
+            <a:endParaRPr lang="en-US" sz="1400" dirty="0"/>
+          </a:p>
+        </p:txBody>
+      </p:sp>
+      <p:sp>
+        <p:nvSpPr>
+          <p:cNvPr id="15" name="Text 13"/>
+          <p:cNvSpPr/>
+          <p:nvPr/>
+        </p:nvSpPr>
+        <p:spPr>
+          <a:xfrm>
+            <a:off x="640080" y="3611880"/>
+            <a:ext cx="3657600" cy="777240"/>
+          </a:xfrm>
+          <a:prstGeom prst="rect">
+            <a:avLst/>
+          </a:prstGeom>
+          <a:noFill/>
+          <a:ln/>
+        </p:spPr>
+        <p:txBody>
+          <a:bodyPr wrap="square" lIns="0" tIns="0" rIns="0" bIns="0" rtlCol="0" anchor="ctr"/>
+          <a:lstStyle/>
+          <a:p>
+            <a:pPr indent="0" marL="0">
+              <a:buNone/>
+            </a:pPr>
+            <a:r>
+              <a:rPr lang="en-US" sz="1100" dirty="0">
+                <a:solidFill>
+                  <a:srgbClr val="0F172A"/>
                 </a:solidFill>
                 <a:latin typeface="Calibri" pitchFamily="34" charset="0"/>
                 <a:ea typeface="Calibri" pitchFamily="34" charset="-122"/>
                 <a:cs typeface="Calibri" pitchFamily="34" charset="-120"/>
               </a:rPr>
-              <a:t>15 / 16</a:t>
+              <a:t>Open-Elevation-API zum Auswertungszeitpunkt down. Höhen-Confounder konnte daher nicht final getestet werden — DEM-basiert wäre der saubere Weg.</a:t>
+            </a:r>
+            <a:endParaRPr lang="en-US" sz="1100" dirty="0"/>
+          </a:p>
+        </p:txBody>
+      </p:sp>
+      <p:sp>
+        <p:nvSpPr>
+          <p:cNvPr id="16" name="Shape 14"/>
+          <p:cNvSpPr/>
+          <p:nvPr/>
+        </p:nvSpPr>
+        <p:spPr>
+          <a:xfrm>
+            <a:off x="4663440" y="3063240"/>
+            <a:ext cx="4023360" cy="1371600"/>
+          </a:xfrm>
+          <a:prstGeom prst="rect">
+            <a:avLst/>
+          </a:prstGeom>
+          <a:solidFill>
+            <a:srgbClr val="FFFFFF"/>
+          </a:solidFill>
+          <a:ln w="9525">
+            <a:solidFill>
+              <a:srgbClr val="E2E8F0"/>
+            </a:solidFill>
+            <a:prstDash val="solid"/>
+          </a:ln>
+          <a:effectLst>
+            <a:outerShdw sx="100000" sy="100000" kx="0" ky="0" algn="bl" rotWithShape="0" blurRad="101600" dist="12700" dir="5400000">
+              <a:srgbClr val="94A3B8">
+                <a:alpha val="12000"/>
+              </a:srgbClr>
+            </a:outerShdw>
+          </a:effectLst>
+        </p:spPr>
+      </p:sp>
+      <p:sp>
+        <p:nvSpPr>
+          <p:cNvPr id="17" name="Shape 15"/>
+          <p:cNvSpPr/>
+          <p:nvPr/>
+        </p:nvSpPr>
+        <p:spPr>
+          <a:xfrm>
+            <a:off x="4663440" y="3063240"/>
+            <a:ext cx="4023360" cy="54864"/>
+          </a:xfrm>
+          <a:prstGeom prst="rect">
+            <a:avLst/>
+          </a:prstGeom>
+          <a:solidFill>
+            <a:srgbClr val="D73027"/>
+          </a:solidFill>
+          <a:ln w="12700">
+            <a:solidFill>
+              <a:srgbClr val="D73027"/>
+            </a:solidFill>
+            <a:prstDash val="solid"/>
+          </a:ln>
+        </p:spPr>
+      </p:sp>
+      <p:sp>
+        <p:nvSpPr>
+          <p:cNvPr id="18" name="Text 16"/>
+          <p:cNvSpPr/>
+          <p:nvPr/>
+        </p:nvSpPr>
+        <p:spPr>
+          <a:xfrm>
+            <a:off x="4846320" y="3227832"/>
+            <a:ext cx="3657600" cy="365760"/>
+          </a:xfrm>
+          <a:prstGeom prst="rect">
+            <a:avLst/>
+          </a:prstGeom>
+          <a:noFill/>
+          <a:ln/>
+        </p:spPr>
+        <p:txBody>
+          <a:bodyPr wrap="square" lIns="0" tIns="0" rIns="0" bIns="0" rtlCol="0" anchor="ctr"/>
+          <a:lstStyle/>
+          <a:p>
+            <a:pPr indent="0" marL="0">
+              <a:buNone/>
+            </a:pPr>
+            <a:r>
+              <a:rPr lang="en-US" sz="1400" b="1" dirty="0">
+                <a:solidFill>
+                  <a:srgbClr val="D73027"/>
+                </a:solidFill>
+                <a:latin typeface="Trebuchet MS" pitchFamily="34" charset="0"/>
+                <a:ea typeface="Trebuchet MS" pitchFamily="34" charset="-122"/>
+                <a:cs typeface="Trebuchet MS" pitchFamily="34" charset="-120"/>
+              </a:rPr>
+              <a:t>Luftlinien-Approximation</a:t>
+            </a:r>
+            <a:endParaRPr lang="en-US" sz="1400" dirty="0"/>
+          </a:p>
+        </p:txBody>
+      </p:sp>
+      <p:sp>
+        <p:nvSpPr>
+          <p:cNvPr id="19" name="Text 17"/>
+          <p:cNvSpPr/>
+          <p:nvPr/>
+        </p:nvSpPr>
+        <p:spPr>
+          <a:xfrm>
+            <a:off x="4846320" y="3611880"/>
+            <a:ext cx="3657600" cy="777240"/>
+          </a:xfrm>
+          <a:prstGeom prst="rect">
+            <a:avLst/>
+          </a:prstGeom>
+          <a:noFill/>
+          <a:ln/>
+        </p:spPr>
+        <p:txBody>
+          <a:bodyPr wrap="square" lIns="0" tIns="0" rIns="0" bIns="0" rtlCol="0" anchor="ctr"/>
+          <a:lstStyle/>
+          <a:p>
+            <a:pPr indent="0" marL="0">
+              <a:buNone/>
+            </a:pPr>
+            <a:r>
+              <a:rPr lang="en-US" sz="1100" dirty="0">
+                <a:solidFill>
+                  <a:srgbClr val="0F172A"/>
+                </a:solidFill>
+                <a:latin typeface="Calibri" pitchFamily="34" charset="0"/>
+                <a:ea typeface="Calibri" pitchFamily="34" charset="-122"/>
+                <a:cs typeface="Calibri" pitchFamily="34" charset="-120"/>
+              </a:rPr>
+              <a:t>Score nutzt KDTree-Distanz, nicht echte Strassengraph-Wege. Validierung über OSMnx-Demo-Isochronen (Notebook 04).</a:t>
+            </a:r>
+            <a:endParaRPr lang="en-US" sz="1100" dirty="0"/>
+          </a:p>
+        </p:txBody>
+      </p:sp>
+      <p:sp>
+        <p:nvSpPr>
+          <p:cNvPr id="20" name="Text 18"/>
+          <p:cNvSpPr/>
+          <p:nvPr/>
+        </p:nvSpPr>
+        <p:spPr>
+          <a:xfrm>
+            <a:off x="8229600" y="4846320"/>
+            <a:ext cx="822960" cy="228600"/>
+          </a:xfrm>
+          <a:prstGeom prst="rect">
+            <a:avLst/>
+          </a:prstGeom>
+          <a:noFill/>
+          <a:ln/>
+        </p:spPr>
+        <p:txBody>
+          <a:bodyPr wrap="square" lIns="0" tIns="0" rIns="0" bIns="0" rtlCol="0" anchor="ctr"/>
+          <a:lstStyle/>
+          <a:p>
+            <a:pPr algn="r" indent="0" marL="0">
+              <a:buNone/>
+            </a:pPr>
+            <a:r>
+              <a:rPr lang="en-US" sz="900" dirty="0">
+                <a:solidFill>
+                  <a:srgbClr val="64748B"/>
+                </a:solidFill>
+                <a:latin typeface="Calibri" pitchFamily="34" charset="0"/>
+                <a:ea typeface="Calibri" pitchFamily="34" charset="-122"/>
+                <a:cs typeface="Calibri" pitchFamily="34" charset="-120"/>
+              </a:rPr>
+              <a:t>16 / 17</a:t>
             </a:r>
             <a:endParaRPr lang="en-US" sz="900" dirty="0"/>
           </a:p>
@@ -7440,9 +8886,9 @@
 </p:sld>
 </file>
 
-<file path=ppt/slides/slide16.xml><?xml version="1.0" encoding="utf-8"?>
+<file path=ppt/slides/slide17.xml><?xml version="1.0" encoding="utf-8"?>
 <p:sld xmlns:a="http://schemas.openxmlformats.org/drawingml/2006/main" xmlns:r="http://schemas.openxmlformats.org/officeDocument/2006/relationships" xmlns:p="http://schemas.openxmlformats.org/presentationml/2006/main">
-  <p:cSld name="Slide 16">
+  <p:cSld name="Slide 17">
     <p:bg>
       <p:bgPr>
         <a:solidFill>
@@ -7639,7 +9085,7 @@
                 <a:ea typeface="Calibri" pitchFamily="34" charset="-122"/>
                 <a:cs typeface="Calibri" pitchFamily="34" charset="-120"/>
               </a:rPr>
-              <a:t>Echtzeit-Mobilitätsdaten — SBB GTFS, ZVV-Reisezeiten</a:t>
+              <a:t>DEM-basierte Topografie + Multi-Variate-Regression mit ÖV-Anbindung</a:t>
             </a:r>
             <a:endParaRPr lang="en-US" sz="1400" dirty="0"/>
           </a:p>
@@ -7742,7 +9188,7 @@
                 <a:ea typeface="Calibri" pitchFamily="34" charset="-122"/>
                 <a:cs typeface="Calibri" pitchFamily="34" charset="-120"/>
               </a:rPr>
-              <a:t>Sentiment-Scores aus TripAdvisor / Google Reviews je POI</a:t>
+              <a:t>Echtzeit-Mobilitätsdaten — SBB GTFS, ZVV-Reisezeiten</a:t>
             </a:r>
             <a:endParaRPr lang="en-US" sz="1400" dirty="0"/>
           </a:p>
@@ -8129,7 +9575,7 @@
                 <a:ea typeface="Calibri" pitchFamily="34" charset="-122"/>
                 <a:cs typeface="Calibri" pitchFamily="34" charset="-120"/>
               </a:rPr>
-              <a:t>16 / 16</a:t>
+              <a:t>17 / 17</a:t>
             </a:r>
             <a:endParaRPr lang="en-US" sz="900" dirty="0"/>
           </a:p>
@@ -8935,7 +10381,7 @@
                 <a:ea typeface="Calibri" pitchFamily="34" charset="-122"/>
                 <a:cs typeface="Calibri" pitchFamily="34" charset="-120"/>
               </a:rPr>
-              <a:t>2 / 16</a:t>
+              <a:t>2 / 17</a:t>
             </a:r>
             <a:endParaRPr lang="en-US" sz="900" dirty="0"/>
           </a:p>
@@ -10317,7 +11763,7 @@
                 <a:ea typeface="Calibri" pitchFamily="34" charset="-122"/>
                 <a:cs typeface="Calibri" pitchFamily="34" charset="-120"/>
               </a:rPr>
-              <a:t>3 / 16</a:t>
+              <a:t>3 / 17</a:t>
             </a:r>
             <a:endParaRPr lang="en-US" sz="900" dirty="0"/>
           </a:p>
@@ -11050,7 +12496,7 @@
                 <a:ea typeface="Calibri" pitchFamily="34" charset="-122"/>
                 <a:cs typeface="Calibri" pitchFamily="34" charset="-120"/>
               </a:rPr>
-              <a:t>4 / 16</a:t>
+              <a:t>4 / 17</a:t>
             </a:r>
             <a:endParaRPr lang="en-US" sz="900" dirty="0"/>
           </a:p>
@@ -11469,7 +12915,7 @@
                 <a:ea typeface="Calibri" pitchFamily="34" charset="-122"/>
                 <a:cs typeface="Calibri" pitchFamily="34" charset="-120"/>
               </a:rPr>
-              <a:t>5 / 16</a:t>
+              <a:t>5 / 17</a:t>
             </a:r>
             <a:endParaRPr lang="en-US" sz="900" dirty="0"/>
           </a:p>
@@ -12094,7 +13540,7 @@
                 <a:ea typeface="Calibri" pitchFamily="34" charset="-122"/>
                 <a:cs typeface="Calibri" pitchFamily="34" charset="-120"/>
               </a:rPr>
-              <a:t>6 / 16</a:t>
+              <a:t>6 / 17</a:t>
             </a:r>
             <a:endParaRPr lang="en-US" sz="900" dirty="0"/>
           </a:p>
@@ -13491,6 +14937,212 @@
                           <a:ea typeface="Calibri" pitchFamily="34" charset="-122"/>
                           <a:cs typeface="Calibri" pitchFamily="34" charset="-120"/>
                         </a:rPr>
+                        <a:t>Open-Elevation API</a:t>
+                      </a:r>
+                      <a:endParaRPr lang="en-US" sz="1150" dirty="0">
+                        <a:latin typeface="Calibri" charset="0"/>
+                        <a:ea typeface="Calibri" charset="0"/>
+                        <a:cs typeface="Calibri" charset="0"/>
+                      </a:endParaRPr>
+                    </a:p>
+                  </a:txBody>
+                  <a:tcPr marL="91440" marR="91440" marT="45720" marB="45720">
+                    <a:lnL w="6350" cap="flat" cmpd="sng" algn="ctr">
+                      <a:solidFill>
+                        <a:srgbClr val="E2E8F0"/>
+                      </a:solidFill>
+                      <a:prstDash val="solid"/>
+                      <a:round/>
+                      <a:headEnd type="none" w="med" len="med"/>
+                      <a:tailEnd type="none" w="med" len="med"/>
+                    </a:lnL>
+                    <a:lnR w="6350" cap="flat" cmpd="sng" algn="ctr">
+                      <a:solidFill>
+                        <a:srgbClr val="E2E8F0"/>
+                      </a:solidFill>
+                      <a:prstDash val="solid"/>
+                      <a:round/>
+                      <a:headEnd type="none" w="med" len="med"/>
+                      <a:tailEnd type="none" w="med" len="med"/>
+                    </a:lnR>
+                    <a:lnT w="6350" cap="flat" cmpd="sng" algn="ctr">
+                      <a:solidFill>
+                        <a:srgbClr val="E2E8F0"/>
+                      </a:solidFill>
+                      <a:prstDash val="solid"/>
+                      <a:round/>
+                      <a:headEnd type="none" w="med" len="med"/>
+                      <a:tailEnd type="none" w="med" len="med"/>
+                    </a:lnT>
+                    <a:lnB w="6350" cap="flat" cmpd="sng" algn="ctr">
+                      <a:solidFill>
+                        <a:srgbClr val="E2E8F0"/>
+                      </a:solidFill>
+                      <a:prstDash val="solid"/>
+                      <a:round/>
+                      <a:headEnd type="none" w="med" len="med"/>
+                      <a:tailEnd type="none" w="med" len="med"/>
+                    </a:lnB>
+                    <a:solidFill>
+                      <a:srgbClr val="FFFFFF"/>
+                    </a:solidFill>
+                  </a:tcPr>
+                </a:tc>
+                <a:tc>
+                  <a:txBody>
+                    <a:bodyPr/>
+                    <a:lstStyle/>
+                    <a:p>
+                      <a:pPr algn="l" indent="0" marL="0">
+                        <a:buNone/>
+                      </a:pPr>
+                      <a:r>
+                        <a:rPr lang="en-US" sz="1150" dirty="0">
+                          <a:solidFill>
+                            <a:srgbClr val="0F172A"/>
+                          </a:solidFill>
+                          <a:latin typeface="Calibri" pitchFamily="34" charset="0"/>
+                          <a:ea typeface="Calibri" pitchFamily="34" charset="-122"/>
+                          <a:cs typeface="Calibri" pitchFamily="34" charset="-120"/>
+                        </a:rPr>
+                        <a:t>Höhe für Robustness Check (Confounder)</a:t>
+                      </a:r>
+                      <a:endParaRPr lang="en-US" sz="1150" dirty="0">
+                        <a:latin typeface="Calibri" charset="0"/>
+                        <a:ea typeface="Calibri" charset="0"/>
+                        <a:cs typeface="Calibri" charset="0"/>
+                      </a:endParaRPr>
+                    </a:p>
+                  </a:txBody>
+                  <a:tcPr marL="91440" marR="91440" marT="45720" marB="45720">
+                    <a:lnL w="6350" cap="flat" cmpd="sng" algn="ctr">
+                      <a:solidFill>
+                        <a:srgbClr val="E2E8F0"/>
+                      </a:solidFill>
+                      <a:prstDash val="solid"/>
+                      <a:round/>
+                      <a:headEnd type="none" w="med" len="med"/>
+                      <a:tailEnd type="none" w="med" len="med"/>
+                    </a:lnL>
+                    <a:lnR w="6350" cap="flat" cmpd="sng" algn="ctr">
+                      <a:solidFill>
+                        <a:srgbClr val="E2E8F0"/>
+                      </a:solidFill>
+                      <a:prstDash val="solid"/>
+                      <a:round/>
+                      <a:headEnd type="none" w="med" len="med"/>
+                      <a:tailEnd type="none" w="med" len="med"/>
+                    </a:lnR>
+                    <a:lnT w="6350" cap="flat" cmpd="sng" algn="ctr">
+                      <a:solidFill>
+                        <a:srgbClr val="E2E8F0"/>
+                      </a:solidFill>
+                      <a:prstDash val="solid"/>
+                      <a:round/>
+                      <a:headEnd type="none" w="med" len="med"/>
+                      <a:tailEnd type="none" w="med" len="med"/>
+                    </a:lnT>
+                    <a:lnB w="6350" cap="flat" cmpd="sng" algn="ctr">
+                      <a:solidFill>
+                        <a:srgbClr val="E2E8F0"/>
+                      </a:solidFill>
+                      <a:prstDash val="solid"/>
+                      <a:round/>
+                      <a:headEnd type="none" w="med" len="med"/>
+                      <a:tailEnd type="none" w="med" len="med"/>
+                    </a:lnB>
+                    <a:solidFill>
+                      <a:srgbClr val="FFFFFF"/>
+                    </a:solidFill>
+                  </a:tcPr>
+                </a:tc>
+                <a:tc>
+                  <a:txBody>
+                    <a:bodyPr/>
+                    <a:lstStyle/>
+                    <a:p>
+                      <a:pPr algn="l" indent="0" marL="0">
+                        <a:buNone/>
+                      </a:pPr>
+                      <a:r>
+                        <a:rPr lang="en-US" sz="1150" dirty="0">
+                          <a:solidFill>
+                            <a:srgbClr val="0F172A"/>
+                          </a:solidFill>
+                          <a:latin typeface="Calibri" pitchFamily="34" charset="0"/>
+                          <a:ea typeface="Calibri" pitchFamily="34" charset="-122"/>
+                          <a:cs typeface="Calibri" pitchFamily="34" charset="-120"/>
+                        </a:rPr>
+                        <a:t>CC0</a:t>
+                      </a:r>
+                      <a:endParaRPr lang="en-US" sz="1150" dirty="0">
+                        <a:latin typeface="Calibri" charset="0"/>
+                        <a:ea typeface="Calibri" charset="0"/>
+                        <a:cs typeface="Calibri" charset="0"/>
+                      </a:endParaRPr>
+                    </a:p>
+                  </a:txBody>
+                  <a:tcPr marL="91440" marR="91440" marT="45720" marB="45720">
+                    <a:lnL w="6350" cap="flat" cmpd="sng" algn="ctr">
+                      <a:solidFill>
+                        <a:srgbClr val="E2E8F0"/>
+                      </a:solidFill>
+                      <a:prstDash val="solid"/>
+                      <a:round/>
+                      <a:headEnd type="none" w="med" len="med"/>
+                      <a:tailEnd type="none" w="med" len="med"/>
+                    </a:lnL>
+                    <a:lnR w="6350" cap="flat" cmpd="sng" algn="ctr">
+                      <a:solidFill>
+                        <a:srgbClr val="E2E8F0"/>
+                      </a:solidFill>
+                      <a:prstDash val="solid"/>
+                      <a:round/>
+                      <a:headEnd type="none" w="med" len="med"/>
+                      <a:tailEnd type="none" w="med" len="med"/>
+                    </a:lnR>
+                    <a:lnT w="6350" cap="flat" cmpd="sng" algn="ctr">
+                      <a:solidFill>
+                        <a:srgbClr val="E2E8F0"/>
+                      </a:solidFill>
+                      <a:prstDash val="solid"/>
+                      <a:round/>
+                      <a:headEnd type="none" w="med" len="med"/>
+                      <a:tailEnd type="none" w="med" len="med"/>
+                    </a:lnT>
+                    <a:lnB w="6350" cap="flat" cmpd="sng" algn="ctr">
+                      <a:solidFill>
+                        <a:srgbClr val="E2E8F0"/>
+                      </a:solidFill>
+                      <a:prstDash val="solid"/>
+                      <a:round/>
+                      <a:headEnd type="none" w="med" len="med"/>
+                      <a:tailEnd type="none" w="med" len="med"/>
+                    </a:lnB>
+                    <a:solidFill>
+                      <a:srgbClr val="FFFFFF"/>
+                    </a:solidFill>
+                  </a:tcPr>
+                </a:tc>
+              </a:tr>
+              <a:tr h="384048">
+                <a:tc>
+                  <a:txBody>
+                    <a:bodyPr/>
+                    <a:lstStyle/>
+                    <a:p>
+                      <a:pPr algn="l" indent="0" marL="0">
+                        <a:buNone/>
+                      </a:pPr>
+                      <a:r>
+                        <a:rPr lang="en-US" sz="1150" dirty="0">
+                          <a:solidFill>
+                            <a:srgbClr val="0F172A"/>
+                          </a:solidFill>
+                          <a:latin typeface="Calibri" pitchFamily="34" charset="0"/>
+                          <a:ea typeface="Calibri" pitchFamily="34" charset="-122"/>
+                          <a:cs typeface="Calibri" pitchFamily="34" charset="-120"/>
+                        </a:rPr>
                         <a:t>swisstopo / GeoAdmin</a:t>
                       </a:r>
                       <a:endParaRPr lang="en-US" sz="1150" dirty="0">
@@ -13679,212 +15331,6 @@
                   </a:tcPr>
                 </a:tc>
               </a:tr>
-              <a:tr h="384048">
-                <a:tc>
-                  <a:txBody>
-                    <a:bodyPr/>
-                    <a:lstStyle/>
-                    <a:p>
-                      <a:pPr algn="l" indent="0" marL="0">
-                        <a:buNone/>
-                      </a:pPr>
-                      <a:r>
-                        <a:rPr lang="en-US" sz="1150" dirty="0">
-                          <a:solidFill>
-                            <a:srgbClr val="0F172A"/>
-                          </a:solidFill>
-                          <a:latin typeface="Calibri" pitchFamily="34" charset="0"/>
-                          <a:ea typeface="Calibri" pitchFamily="34" charset="-122"/>
-                          <a:cs typeface="Calibri" pitchFamily="34" charset="-120"/>
-                        </a:rPr>
-                        <a:t>BFS STATPOP / Mietpreis-Idx</a:t>
-                      </a:r>
-                      <a:endParaRPr lang="en-US" sz="1150" dirty="0">
-                        <a:latin typeface="Calibri" charset="0"/>
-                        <a:ea typeface="Calibri" charset="0"/>
-                        <a:cs typeface="Calibri" charset="0"/>
-                      </a:endParaRPr>
-                    </a:p>
-                  </a:txBody>
-                  <a:tcPr marL="91440" marR="91440" marT="45720" marB="45720">
-                    <a:lnL w="6350" cap="flat" cmpd="sng" algn="ctr">
-                      <a:solidFill>
-                        <a:srgbClr val="E2E8F0"/>
-                      </a:solidFill>
-                      <a:prstDash val="solid"/>
-                      <a:round/>
-                      <a:headEnd type="none" w="med" len="med"/>
-                      <a:tailEnd type="none" w="med" len="med"/>
-                    </a:lnL>
-                    <a:lnR w="6350" cap="flat" cmpd="sng" algn="ctr">
-                      <a:solidFill>
-                        <a:srgbClr val="E2E8F0"/>
-                      </a:solidFill>
-                      <a:prstDash val="solid"/>
-                      <a:round/>
-                      <a:headEnd type="none" w="med" len="med"/>
-                      <a:tailEnd type="none" w="med" len="med"/>
-                    </a:lnR>
-                    <a:lnT w="6350" cap="flat" cmpd="sng" algn="ctr">
-                      <a:solidFill>
-                        <a:srgbClr val="E2E8F0"/>
-                      </a:solidFill>
-                      <a:prstDash val="solid"/>
-                      <a:round/>
-                      <a:headEnd type="none" w="med" len="med"/>
-                      <a:tailEnd type="none" w="med" len="med"/>
-                    </a:lnT>
-                    <a:lnB w="6350" cap="flat" cmpd="sng" algn="ctr">
-                      <a:solidFill>
-                        <a:srgbClr val="E2E8F0"/>
-                      </a:solidFill>
-                      <a:prstDash val="solid"/>
-                      <a:round/>
-                      <a:headEnd type="none" w="med" len="med"/>
-                      <a:tailEnd type="none" w="med" len="med"/>
-                    </a:lnB>
-                    <a:solidFill>
-                      <a:srgbClr val="FFFFFF"/>
-                    </a:solidFill>
-                  </a:tcPr>
-                </a:tc>
-                <a:tc>
-                  <a:txBody>
-                    <a:bodyPr/>
-                    <a:lstStyle/>
-                    <a:p>
-                      <a:pPr algn="l" indent="0" marL="0">
-                        <a:buNone/>
-                      </a:pPr>
-                      <a:r>
-                        <a:rPr lang="en-US" sz="1150" dirty="0">
-                          <a:solidFill>
-                            <a:srgbClr val="0F172A"/>
-                          </a:solidFill>
-                          <a:latin typeface="Calibri" pitchFamily="34" charset="0"/>
-                          <a:ea typeface="Calibri" pitchFamily="34" charset="-122"/>
-                          <a:cs typeface="Calibri" pitchFamily="34" charset="-120"/>
-                        </a:rPr>
-                        <a:t>geplant — siehe Limitationen (Slide 15)</a:t>
-                      </a:r>
-                      <a:endParaRPr lang="en-US" sz="1150" dirty="0">
-                        <a:latin typeface="Calibri" charset="0"/>
-                        <a:ea typeface="Calibri" charset="0"/>
-                        <a:cs typeface="Calibri" charset="0"/>
-                      </a:endParaRPr>
-                    </a:p>
-                  </a:txBody>
-                  <a:tcPr marL="91440" marR="91440" marT="45720" marB="45720">
-                    <a:lnL w="6350" cap="flat" cmpd="sng" algn="ctr">
-                      <a:solidFill>
-                        <a:srgbClr val="E2E8F0"/>
-                      </a:solidFill>
-                      <a:prstDash val="solid"/>
-                      <a:round/>
-                      <a:headEnd type="none" w="med" len="med"/>
-                      <a:tailEnd type="none" w="med" len="med"/>
-                    </a:lnL>
-                    <a:lnR w="6350" cap="flat" cmpd="sng" algn="ctr">
-                      <a:solidFill>
-                        <a:srgbClr val="E2E8F0"/>
-                      </a:solidFill>
-                      <a:prstDash val="solid"/>
-                      <a:round/>
-                      <a:headEnd type="none" w="med" len="med"/>
-                      <a:tailEnd type="none" w="med" len="med"/>
-                    </a:lnR>
-                    <a:lnT w="6350" cap="flat" cmpd="sng" algn="ctr">
-                      <a:solidFill>
-                        <a:srgbClr val="E2E8F0"/>
-                      </a:solidFill>
-                      <a:prstDash val="solid"/>
-                      <a:round/>
-                      <a:headEnd type="none" w="med" len="med"/>
-                      <a:tailEnd type="none" w="med" len="med"/>
-                    </a:lnT>
-                    <a:lnB w="6350" cap="flat" cmpd="sng" algn="ctr">
-                      <a:solidFill>
-                        <a:srgbClr val="E2E8F0"/>
-                      </a:solidFill>
-                      <a:prstDash val="solid"/>
-                      <a:round/>
-                      <a:headEnd type="none" w="med" len="med"/>
-                      <a:tailEnd type="none" w="med" len="med"/>
-                    </a:lnB>
-                    <a:solidFill>
-                      <a:srgbClr val="FFFFFF"/>
-                    </a:solidFill>
-                  </a:tcPr>
-                </a:tc>
-                <a:tc>
-                  <a:txBody>
-                    <a:bodyPr/>
-                    <a:lstStyle/>
-                    <a:p>
-                      <a:pPr algn="l" indent="0" marL="0">
-                        <a:buNone/>
-                      </a:pPr>
-                      <a:r>
-                        <a:rPr lang="en-US" sz="1150" dirty="0">
-                          <a:solidFill>
-                            <a:srgbClr val="0F172A"/>
-                          </a:solidFill>
-                          <a:latin typeface="Calibri" pitchFamily="34" charset="0"/>
-                          <a:ea typeface="Calibri" pitchFamily="34" charset="-122"/>
-                          <a:cs typeface="Calibri" pitchFamily="34" charset="-120"/>
-                        </a:rPr>
-                        <a:t>Open Data</a:t>
-                      </a:r>
-                      <a:endParaRPr lang="en-US" sz="1150" dirty="0">
-                        <a:latin typeface="Calibri" charset="0"/>
-                        <a:ea typeface="Calibri" charset="0"/>
-                        <a:cs typeface="Calibri" charset="0"/>
-                      </a:endParaRPr>
-                    </a:p>
-                  </a:txBody>
-                  <a:tcPr marL="91440" marR="91440" marT="45720" marB="45720">
-                    <a:lnL w="6350" cap="flat" cmpd="sng" algn="ctr">
-                      <a:solidFill>
-                        <a:srgbClr val="E2E8F0"/>
-                      </a:solidFill>
-                      <a:prstDash val="solid"/>
-                      <a:round/>
-                      <a:headEnd type="none" w="med" len="med"/>
-                      <a:tailEnd type="none" w="med" len="med"/>
-                    </a:lnL>
-                    <a:lnR w="6350" cap="flat" cmpd="sng" algn="ctr">
-                      <a:solidFill>
-                        <a:srgbClr val="E2E8F0"/>
-                      </a:solidFill>
-                      <a:prstDash val="solid"/>
-                      <a:round/>
-                      <a:headEnd type="none" w="med" len="med"/>
-                      <a:tailEnd type="none" w="med" len="med"/>
-                    </a:lnR>
-                    <a:lnT w="6350" cap="flat" cmpd="sng" algn="ctr">
-                      <a:solidFill>
-                        <a:srgbClr val="E2E8F0"/>
-                      </a:solidFill>
-                      <a:prstDash val="solid"/>
-                      <a:round/>
-                      <a:headEnd type="none" w="med" len="med"/>
-                      <a:tailEnd type="none" w="med" len="med"/>
-                    </a:lnT>
-                    <a:lnB w="6350" cap="flat" cmpd="sng" algn="ctr">
-                      <a:solidFill>
-                        <a:srgbClr val="E2E8F0"/>
-                      </a:solidFill>
-                      <a:prstDash val="solid"/>
-                      <a:round/>
-                      <a:headEnd type="none" w="med" len="med"/>
-                      <a:tailEnd type="none" w="med" len="med"/>
-                    </a:lnB>
-                    <a:solidFill>
-                      <a:srgbClr val="FFFFFF"/>
-                    </a:solidFill>
-                  </a:tcPr>
-                </a:tc>
-              </a:tr>
             </a:tbl>
           </a:graphicData>
         </a:graphic>
@@ -13961,7 +15407,7 @@
                 <a:ea typeface="Calibri" pitchFamily="34" charset="-122"/>
                 <a:cs typeface="Calibri" pitchFamily="34" charset="-120"/>
               </a:rPr>
-              <a:t>7 / 16</a:t>
+              <a:t>7 / 17</a:t>
             </a:r>
             <a:endParaRPr lang="en-US" sz="900" dirty="0"/>
           </a:p>
@@ -14920,7 +16366,7 @@
                 <a:ea typeface="Calibri" pitchFamily="34" charset="-122"/>
                 <a:cs typeface="Calibri" pitchFamily="34" charset="-120"/>
               </a:rPr>
-              <a:t>8 / 16</a:t>
+              <a:t>8 / 17</a:t>
             </a:r>
             <a:endParaRPr lang="en-US" sz="900" dirty="0"/>
           </a:p>
@@ -15939,7 +17385,7 @@
                 <a:ea typeface="Calibri" pitchFamily="34" charset="-122"/>
                 <a:cs typeface="Calibri" pitchFamily="34" charset="-120"/>
               </a:rPr>
-              <a:t>9 / 16</a:t>
+              <a:t>9 / 17</a:t>
             </a:r>
             <a:endParaRPr lang="en-US" sz="900" dirty="0"/>
           </a:p>

</xml_diff>

<commit_message>
fix(robustness): use SwissALTI3D DEM in NB06 cell 22 + sync slides + run all NBs
* NB06 cell 22: rasterio.sample() on local DEM (was: Open-Elevation API which was 504 -> fake fallback)
* Real elevations 402-630m -> bivariate r(score, elevation) = -0.60 (was -0.04 with fake)
* Multi-variate regression: R^2 = 0.91 (was 0.86), all three predictors highly significant: dist_hb (b=-9.52, p<1e-6), elevation (b=-0.107, p<1e-3), poi_density (b=+0.069, p<1e-4)
* Slide 7: 8 Quellen, OSM admin_level=10 -> Stadt Zuerich Open Data, Open-Elevation -> SwissALTI3D, add BFS STATPOP
* Slide 10: 9 Notebooks (was 7), include 02b + 06b
* Slide 18: regression table updated, R^2 = 0.91, findings card updated
* Slide 19: replace 'API down' limitation with Tobler-model assumption
* presenter_notes: Slide 18 + Q&A updated with new beta values
* Re-run all notebooks (01, 03, 06, 07) -> fresh outputs in JSON
* Regenerate PPTX + PDF + 4 figure outputs
</commit_message>
<xml_diff>
--- a/reports/zh15min_slides.pptx
+++ b/reports/zh15min_slides.pptx
@@ -3074,7 +3074,7 @@
                 <a:ea typeface="Trebuchet MS" pitchFamily="34" charset="-122"/>
                 <a:cs typeface="Trebuchet MS" pitchFamily="34" charset="-120"/>
               </a:rPr>
-              <a:t>Pipeline — sieben Notebooks</a:t>
+              <a:t>Pipeline — neun Notebooks</a:t>
             </a:r>
             <a:endParaRPr lang="en-US" sz="3000" dirty="0"/>
           </a:p>
@@ -3088,7 +3088,7 @@
         </p:nvSpPr>
         <p:spPr>
           <a:xfrm>
-            <a:off x="457200" y="1783080"/>
+            <a:off x="457200" y="1645920"/>
             <a:ext cx="8229600" cy="54864"/>
           </a:xfrm>
           <a:prstGeom prst="rect">
@@ -3113,7 +3113,7 @@
         </p:nvSpPr>
         <p:spPr>
           <a:xfrm>
-            <a:off x="502920" y="1920240"/>
+            <a:off x="502920" y="1737360"/>
             <a:ext cx="292608" cy="292608"/>
           </a:xfrm>
           <a:prstGeom prst="ellipse">
@@ -3138,7 +3138,7 @@
         </p:nvSpPr>
         <p:spPr>
           <a:xfrm>
-            <a:off x="502920" y="1920240"/>
+            <a:off x="502920" y="1737360"/>
             <a:ext cx="292608" cy="292608"/>
           </a:xfrm>
           <a:prstGeom prst="rect">
@@ -3177,7 +3177,7 @@
         </p:nvSpPr>
         <p:spPr>
           <a:xfrm>
-            <a:off x="960120" y="1920240"/>
+            <a:off x="960120" y="1737360"/>
             <a:ext cx="7680960" cy="292608"/>
           </a:xfrm>
           <a:prstGeom prst="rect">
@@ -3216,7 +3216,7 @@
         </p:nvSpPr>
         <p:spPr>
           <a:xfrm>
-            <a:off x="502920" y="2304288"/>
+            <a:off x="502920" y="2066544"/>
             <a:ext cx="292608" cy="292608"/>
           </a:xfrm>
           <a:prstGeom prst="ellipse">
@@ -3241,7 +3241,7 @@
         </p:nvSpPr>
         <p:spPr>
           <a:xfrm>
-            <a:off x="502920" y="2304288"/>
+            <a:off x="502920" y="2066544"/>
             <a:ext cx="292608" cy="292608"/>
           </a:xfrm>
           <a:prstGeom prst="rect">
@@ -3280,7 +3280,7 @@
         </p:nvSpPr>
         <p:spPr>
           <a:xfrm>
-            <a:off x="960120" y="2304288"/>
+            <a:off x="960120" y="2066544"/>
             <a:ext cx="7680960" cy="292608"/>
           </a:xfrm>
           <a:prstGeom prst="rect">
@@ -3305,7 +3305,7 @@
                 <a:ea typeface="Calibri" pitchFamily="34" charset="-122"/>
                 <a:cs typeface="Calibri" pitchFamily="34" charset="-120"/>
               </a:rPr>
-              <a:t>Walking-Graph + Quartier-Polygone (OSM admin_level=10)</a:t>
+              <a:t>Walking-Graph + STATPOP + Stadt-Zürich-Quartiere (WFS)</a:t>
             </a:r>
             <a:endParaRPr lang="en-US" sz="1300" dirty="0"/>
           </a:p>
@@ -3319,7 +3319,7 @@
         </p:nvSpPr>
         <p:spPr>
           <a:xfrm>
-            <a:off x="502920" y="2688336"/>
+            <a:off x="502920" y="2395728"/>
             <a:ext cx="292608" cy="292608"/>
           </a:xfrm>
           <a:prstGeom prst="ellipse">
@@ -3344,7 +3344,7 @@
         </p:nvSpPr>
         <p:spPr>
           <a:xfrm>
-            <a:off x="502920" y="2688336"/>
+            <a:off x="502920" y="2395728"/>
             <a:ext cx="292608" cy="292608"/>
           </a:xfrm>
           <a:prstGeom prst="rect">
@@ -3383,7 +3383,7 @@
         </p:nvSpPr>
         <p:spPr>
           <a:xfrm>
-            <a:off x="960120" y="2688336"/>
+            <a:off x="960120" y="2395728"/>
             <a:ext cx="7680960" cy="292608"/>
           </a:xfrm>
           <a:prstGeom prst="rect">
@@ -3408,7 +3408,7 @@
                 <a:ea typeface="Calibri" pitchFamily="34" charset="-122"/>
                 <a:cs typeface="Calibri" pitchFamily="34" charset="-120"/>
               </a:rPr>
-              <a:t>Alles in PostGIS (Schema zh15min) importieren</a:t>
+              <a:t>Höhen-Anreicherung des Walking-Graphs (SwissALTI3D)</a:t>
             </a:r>
             <a:endParaRPr lang="en-US" sz="1300" dirty="0"/>
           </a:p>
@@ -3422,7 +3422,7 @@
         </p:nvSpPr>
         <p:spPr>
           <a:xfrm>
-            <a:off x="502920" y="3072384"/>
+            <a:off x="502920" y="2724912"/>
             <a:ext cx="292608" cy="292608"/>
           </a:xfrm>
           <a:prstGeom prst="ellipse">
@@ -3447,7 +3447,7 @@
         </p:nvSpPr>
         <p:spPr>
           <a:xfrm>
-            <a:off x="502920" y="3072384"/>
+            <a:off x="502920" y="2724912"/>
             <a:ext cx="292608" cy="292608"/>
           </a:xfrm>
           <a:prstGeom prst="rect">
@@ -3486,7 +3486,7 @@
         </p:nvSpPr>
         <p:spPr>
           <a:xfrm>
-            <a:off x="960120" y="3072384"/>
+            <a:off x="960120" y="2724912"/>
             <a:ext cx="7680960" cy="292608"/>
           </a:xfrm>
           <a:prstGeom prst="rect">
@@ -3511,7 +3511,7 @@
                 <a:ea typeface="Calibri" pitchFamily="34" charset="-122"/>
                 <a:cs typeface="Calibri" pitchFamily="34" charset="-120"/>
               </a:rPr>
-              <a:t>Demo-Isochronen + Hex-Gitter (200 m Apothem)</a:t>
+              <a:t>Alles in PostGIS (Schema zh15min) importieren</a:t>
             </a:r>
             <a:endParaRPr lang="en-US" sz="1300" dirty="0"/>
           </a:p>
@@ -3525,7 +3525,7 @@
         </p:nvSpPr>
         <p:spPr>
           <a:xfrm>
-            <a:off x="502920" y="3456432"/>
+            <a:off x="502920" y="3054096"/>
             <a:ext cx="292608" cy="292608"/>
           </a:xfrm>
           <a:prstGeom prst="ellipse">
@@ -3550,7 +3550,7 @@
         </p:nvSpPr>
         <p:spPr>
           <a:xfrm>
-            <a:off x="502920" y="3456432"/>
+            <a:off x="502920" y="3054096"/>
             <a:ext cx="292608" cy="292608"/>
           </a:xfrm>
           <a:prstGeom prst="rect">
@@ -3589,7 +3589,7 @@
         </p:nvSpPr>
         <p:spPr>
           <a:xfrm>
-            <a:off x="960120" y="3456432"/>
+            <a:off x="960120" y="3054096"/>
             <a:ext cx="7680960" cy="292608"/>
           </a:xfrm>
           <a:prstGeom prst="rect">
@@ -3614,7 +3614,7 @@
                 <a:ea typeface="Calibri" pitchFamily="34" charset="-122"/>
                 <a:cs typeface="Calibri" pitchFamily="34" charset="-120"/>
               </a:rPr>
-              <a:t>Score-Berechnung (KDTree-beschleunigt)</a:t>
+              <a:t>Demo-Isochronen + Hex-Gitter (200 m Apothem)</a:t>
             </a:r>
             <a:endParaRPr lang="en-US" sz="1300" dirty="0"/>
           </a:p>
@@ -3628,7 +3628,7 @@
         </p:nvSpPr>
         <p:spPr>
           <a:xfrm>
-            <a:off x="502920" y="3840480"/>
+            <a:off x="502920" y="3383280"/>
             <a:ext cx="292608" cy="292608"/>
           </a:xfrm>
           <a:prstGeom prst="ellipse">
@@ -3653,7 +3653,7 @@
         </p:nvSpPr>
         <p:spPr>
           <a:xfrm>
-            <a:off x="502920" y="3840480"/>
+            <a:off x="502920" y="3383280"/>
             <a:ext cx="292608" cy="292608"/>
           </a:xfrm>
           <a:prstGeom prst="rect">
@@ -3692,7 +3692,7 @@
         </p:nvSpPr>
         <p:spPr>
           <a:xfrm>
-            <a:off x="960120" y="3840480"/>
+            <a:off x="960120" y="3383280"/>
             <a:ext cx="7680960" cy="292608"/>
           </a:xfrm>
           <a:prstGeom prst="rect">
@@ -3717,7 +3717,7 @@
                 <a:ea typeface="Calibri" pitchFamily="34" charset="-122"/>
                 <a:cs typeface="Calibri" pitchFamily="34" charset="-120"/>
               </a:rPr>
-              <a:t>Hypothesen-Test (Score × Distanz HB) + Versorgungslücken</a:t>
+              <a:t>Score-Berechnung (KDTree-beschleunigt)</a:t>
             </a:r>
             <a:endParaRPr lang="en-US" sz="1300" dirty="0"/>
           </a:p>
@@ -3731,7 +3731,7 @@
         </p:nvSpPr>
         <p:spPr>
           <a:xfrm>
-            <a:off x="502920" y="4224528"/>
+            <a:off x="502920" y="3712464"/>
             <a:ext cx="292608" cy="292608"/>
           </a:xfrm>
           <a:prstGeom prst="ellipse">
@@ -3756,7 +3756,7 @@
         </p:nvSpPr>
         <p:spPr>
           <a:xfrm>
-            <a:off x="502920" y="4224528"/>
+            <a:off x="502920" y="3712464"/>
             <a:ext cx="292608" cy="292608"/>
           </a:xfrm>
           <a:prstGeom prst="rect">
@@ -3795,7 +3795,7 @@
         </p:nvSpPr>
         <p:spPr>
           <a:xfrm>
-            <a:off x="960120" y="4224528"/>
+            <a:off x="960120" y="3712464"/>
             <a:ext cx="7680960" cy="292608"/>
           </a:xfrm>
           <a:prstGeom prst="rect">
@@ -3820,7 +3820,7 @@
                 <a:ea typeface="Calibri" pitchFamily="34" charset="-122"/>
                 <a:cs typeface="Calibri" pitchFamily="34" charset="-120"/>
               </a:rPr>
-              <a:t>Folium-Karte + Slide-Figuren</a:t>
+              <a:t>Hypothesen-Test + Versorgungslücken + Robustness Check</a:t>
             </a:r>
             <a:endParaRPr lang="en-US" sz="1300" dirty="0"/>
           </a:p>
@@ -3828,37 +3828,243 @@
       </p:sp>
       <p:sp>
         <p:nvSpPr>
-          <p:cNvPr id="26" name="Text 24"/>
-          <p:cNvSpPr/>
-          <p:nvPr/>
-        </p:nvSpPr>
-        <p:spPr>
-          <a:xfrm>
-            <a:off x="365760" y="4846320"/>
-            <a:ext cx="7315200" cy="228600"/>
-          </a:xfrm>
-          <a:prstGeom prst="rect">
-            <a:avLst/>
-          </a:prstGeom>
-          <a:noFill/>
-          <a:ln/>
-        </p:spPr>
-        <p:txBody>
-          <a:bodyPr wrap="square" lIns="0" tIns="0" rIns="0" bIns="0" rtlCol="0" anchor="ctr"/>
-          <a:lstStyle/>
-          <a:p>
-            <a:pPr algn="l" indent="0" marL="0">
-              <a:buNone/>
-            </a:pPr>
-            <a:r>
-              <a:rPr lang="en-US" sz="900" dirty="0">
-                <a:solidFill>
-                  <a:srgbClr val="64748B"/>
+          <p:cNvPr id="26" name="Shape 24"/>
+          <p:cNvSpPr/>
+          <p:nvPr/>
+        </p:nvSpPr>
+        <p:spPr>
+          <a:xfrm>
+            <a:off x="502920" y="4041648"/>
+            <a:ext cx="292608" cy="292608"/>
+          </a:xfrm>
+          <a:prstGeom prst="ellipse">
+            <a:avLst/>
+          </a:prstGeom>
+          <a:solidFill>
+            <a:srgbClr val="065A82"/>
+          </a:solidFill>
+          <a:ln w="12700">
+            <a:solidFill>
+              <a:srgbClr val="065A82"/>
+            </a:solidFill>
+            <a:prstDash val="solid"/>
+          </a:ln>
+        </p:spPr>
+      </p:sp>
+      <p:sp>
+        <p:nvSpPr>
+          <p:cNvPr id="27" name="Text 25"/>
+          <p:cNvSpPr/>
+          <p:nvPr/>
+        </p:nvSpPr>
+        <p:spPr>
+          <a:xfrm>
+            <a:off x="502920" y="4041648"/>
+            <a:ext cx="292608" cy="292608"/>
+          </a:xfrm>
+          <a:prstGeom prst="rect">
+            <a:avLst/>
+          </a:prstGeom>
+          <a:noFill/>
+          <a:ln/>
+        </p:spPr>
+        <p:txBody>
+          <a:bodyPr wrap="square" lIns="0" tIns="0" rIns="0" bIns="0" rtlCol="0" anchor="ctr"/>
+          <a:lstStyle/>
+          <a:p>
+            <a:pPr algn="ctr" indent="0" marL="0">
+              <a:buNone/>
+            </a:pPr>
+            <a:r>
+              <a:rPr lang="en-US" sz="1100" b="1" dirty="0">
+                <a:solidFill>
+                  <a:srgbClr val="FFFFFF"/>
+                </a:solidFill>
+                <a:latin typeface="Trebuchet MS" pitchFamily="34" charset="0"/>
+                <a:ea typeface="Trebuchet MS" pitchFamily="34" charset="-122"/>
+                <a:cs typeface="Trebuchet MS" pitchFamily="34" charset="-120"/>
+              </a:rPr>
+              <a:t>8</a:t>
+            </a:r>
+            <a:endParaRPr lang="en-US" sz="1100" dirty="0"/>
+          </a:p>
+        </p:txBody>
+      </p:sp>
+      <p:sp>
+        <p:nvSpPr>
+          <p:cNvPr id="28" name="Text 26"/>
+          <p:cNvSpPr/>
+          <p:nvPr/>
+        </p:nvSpPr>
+        <p:spPr>
+          <a:xfrm>
+            <a:off x="960120" y="4041648"/>
+            <a:ext cx="7680960" cy="292608"/>
+          </a:xfrm>
+          <a:prstGeom prst="rect">
+            <a:avLst/>
+          </a:prstGeom>
+          <a:noFill/>
+          <a:ln/>
+        </p:spPr>
+        <p:txBody>
+          <a:bodyPr wrap="square" lIns="0" tIns="0" rIns="0" bIns="0" rtlCol="0" anchor="ctr"/>
+          <a:lstStyle/>
+          <a:p>
+            <a:pPr indent="0" marL="0">
+              <a:buNone/>
+            </a:pPr>
+            <a:r>
+              <a:rPr lang="en-US" sz="1300" dirty="0">
+                <a:solidFill>
+                  <a:srgbClr val="0F172A"/>
                 </a:solidFill>
                 <a:latin typeface="Calibri" pitchFamily="34" charset="0"/>
                 <a:ea typeface="Calibri" pitchFamily="34" charset="-122"/>
                 <a:cs typeface="Calibri" pitchFamily="34" charset="-120"/>
               </a:rPr>
+              <a:t>Topografischer Score (Tobler) + Δ-Vergleich</a:t>
+            </a:r>
+            <a:endParaRPr lang="en-US" sz="1300" dirty="0"/>
+          </a:p>
+        </p:txBody>
+      </p:sp>
+      <p:sp>
+        <p:nvSpPr>
+          <p:cNvPr id="29" name="Shape 27"/>
+          <p:cNvSpPr/>
+          <p:nvPr/>
+        </p:nvSpPr>
+        <p:spPr>
+          <a:xfrm>
+            <a:off x="502920" y="4370832"/>
+            <a:ext cx="292608" cy="292608"/>
+          </a:xfrm>
+          <a:prstGeom prst="ellipse">
+            <a:avLst/>
+          </a:prstGeom>
+          <a:solidFill>
+            <a:srgbClr val="065A82"/>
+          </a:solidFill>
+          <a:ln w="12700">
+            <a:solidFill>
+              <a:srgbClr val="065A82"/>
+            </a:solidFill>
+            <a:prstDash val="solid"/>
+          </a:ln>
+        </p:spPr>
+      </p:sp>
+      <p:sp>
+        <p:nvSpPr>
+          <p:cNvPr id="30" name="Text 28"/>
+          <p:cNvSpPr/>
+          <p:nvPr/>
+        </p:nvSpPr>
+        <p:spPr>
+          <a:xfrm>
+            <a:off x="502920" y="4370832"/>
+            <a:ext cx="292608" cy="292608"/>
+          </a:xfrm>
+          <a:prstGeom prst="rect">
+            <a:avLst/>
+          </a:prstGeom>
+          <a:noFill/>
+          <a:ln/>
+        </p:spPr>
+        <p:txBody>
+          <a:bodyPr wrap="square" lIns="0" tIns="0" rIns="0" bIns="0" rtlCol="0" anchor="ctr"/>
+          <a:lstStyle/>
+          <a:p>
+            <a:pPr algn="ctr" indent="0" marL="0">
+              <a:buNone/>
+            </a:pPr>
+            <a:r>
+              <a:rPr lang="en-US" sz="1100" b="1" dirty="0">
+                <a:solidFill>
+                  <a:srgbClr val="FFFFFF"/>
+                </a:solidFill>
+                <a:latin typeface="Trebuchet MS" pitchFamily="34" charset="0"/>
+                <a:ea typeface="Trebuchet MS" pitchFamily="34" charset="-122"/>
+                <a:cs typeface="Trebuchet MS" pitchFamily="34" charset="-120"/>
+              </a:rPr>
+              <a:t>9</a:t>
+            </a:r>
+            <a:endParaRPr lang="en-US" sz="1100" dirty="0"/>
+          </a:p>
+        </p:txBody>
+      </p:sp>
+      <p:sp>
+        <p:nvSpPr>
+          <p:cNvPr id="31" name="Text 29"/>
+          <p:cNvSpPr/>
+          <p:nvPr/>
+        </p:nvSpPr>
+        <p:spPr>
+          <a:xfrm>
+            <a:off x="960120" y="4370832"/>
+            <a:ext cx="7680960" cy="292608"/>
+          </a:xfrm>
+          <a:prstGeom prst="rect">
+            <a:avLst/>
+          </a:prstGeom>
+          <a:noFill/>
+          <a:ln/>
+        </p:spPr>
+        <p:txBody>
+          <a:bodyPr wrap="square" lIns="0" tIns="0" rIns="0" bIns="0" rtlCol="0" anchor="ctr"/>
+          <a:lstStyle/>
+          <a:p>
+            <a:pPr indent="0" marL="0">
+              <a:buNone/>
+            </a:pPr>
+            <a:r>
+              <a:rPr lang="en-US" sz="1300" dirty="0">
+                <a:solidFill>
+                  <a:srgbClr val="0F172A"/>
+                </a:solidFill>
+                <a:latin typeface="Calibri" pitchFamily="34" charset="0"/>
+                <a:ea typeface="Calibri" pitchFamily="34" charset="-122"/>
+                <a:cs typeface="Calibri" pitchFamily="34" charset="-120"/>
+              </a:rPr>
+              <a:t>Folium-Karte + Slide-Figuren</a:t>
+            </a:r>
+            <a:endParaRPr lang="en-US" sz="1300" dirty="0"/>
+          </a:p>
+        </p:txBody>
+      </p:sp>
+      <p:sp>
+        <p:nvSpPr>
+          <p:cNvPr id="32" name="Text 30"/>
+          <p:cNvSpPr/>
+          <p:nvPr/>
+        </p:nvSpPr>
+        <p:spPr>
+          <a:xfrm>
+            <a:off x="365760" y="4846320"/>
+            <a:ext cx="7315200" cy="228600"/>
+          </a:xfrm>
+          <a:prstGeom prst="rect">
+            <a:avLst/>
+          </a:prstGeom>
+          <a:noFill/>
+          <a:ln/>
+        </p:spPr>
+        <p:txBody>
+          <a:bodyPr wrap="square" lIns="0" tIns="0" rIns="0" bIns="0" rtlCol="0" anchor="ctr"/>
+          <a:lstStyle/>
+          <a:p>
+            <a:pPr algn="l" indent="0" marL="0">
+              <a:buNone/>
+            </a:pPr>
+            <a:r>
+              <a:rPr lang="en-US" sz="900" dirty="0">
+                <a:solidFill>
+                  <a:srgbClr val="64748B"/>
+                </a:solidFill>
+                <a:latin typeface="Calibri" pitchFamily="34" charset="0"/>
+                <a:ea typeface="Calibri" pitchFamily="34" charset="-122"/>
+                <a:cs typeface="Calibri" pitchFamily="34" charset="-120"/>
+              </a:rPr>
               <a:t>Reproduzierbar via docker compose up -d  &amp;  jupyter lab notebooks/</a:t>
             </a:r>
             <a:endParaRPr lang="en-US" sz="900" dirty="0"/>
@@ -3867,7 +4073,7 @@
       </p:sp>
       <p:sp>
         <p:nvSpPr>
-          <p:cNvPr id="27" name="Text 25"/>
+          <p:cNvPr id="33" name="Text 31"/>
           <p:cNvSpPr/>
           <p:nvPr/>
         </p:nvSpPr>
@@ -10036,7 +10242,7 @@
                 <a:ea typeface="Trebuchet MS" pitchFamily="34" charset="-122"/>
                 <a:cs typeface="Trebuchet MS" pitchFamily="34" charset="-120"/>
               </a:rPr>
-              <a:t>Multi-Variate-Regression  (n = 34, R² = 0.86)</a:t>
+              <a:t>Multi-Variate-Regression  (n = 34, R² = 0.91)</a:t>
             </a:r>
             <a:endParaRPr lang="en-US" sz="1300" dirty="0"/>
           </a:p>
@@ -10051,7 +10257,7 @@
         <p:spPr>
           <a:xfrm>
             <a:off x="640080" y="2057400"/>
-            <a:ext cx="1463040" cy="274320"/>
+            <a:ext cx="1554480" cy="274320"/>
           </a:xfrm>
           <a:prstGeom prst="rect">
             <a:avLst/>
@@ -10089,7 +10295,7 @@
         </p:nvSpPr>
         <p:spPr>
           <a:xfrm>
-            <a:off x="2103120" y="2057400"/>
+            <a:off x="2194560" y="2057400"/>
             <a:ext cx="868680" cy="274320"/>
           </a:xfrm>
           <a:prstGeom prst="rect">
@@ -10128,7 +10334,7 @@
         </p:nvSpPr>
         <p:spPr>
           <a:xfrm>
-            <a:off x="2971800" y="2057400"/>
+            <a:off x="3063240" y="2057400"/>
             <a:ext cx="868680" cy="274320"/>
           </a:xfrm>
           <a:prstGeom prst="rect">
@@ -10167,8 +10373,8 @@
         </p:nvSpPr>
         <p:spPr>
           <a:xfrm>
-            <a:off x="3840480" y="2057400"/>
-            <a:ext cx="868680" cy="274320"/>
+            <a:off x="3931920" y="2057400"/>
+            <a:ext cx="914400" cy="274320"/>
           </a:xfrm>
           <a:prstGeom prst="rect">
             <a:avLst/>
@@ -10206,8 +10412,8 @@
         </p:nvSpPr>
         <p:spPr>
           <a:xfrm>
-            <a:off x="4709160" y="2057400"/>
-            <a:ext cx="640080" cy="274320"/>
+            <a:off x="4846320" y="2057400"/>
+            <a:ext cx="548640" cy="274320"/>
           </a:xfrm>
           <a:prstGeom prst="rect">
             <a:avLst/>
@@ -10246,7 +10452,7 @@
         <p:spPr>
           <a:xfrm>
             <a:off x="640080" y="2423160"/>
-            <a:ext cx="1463040" cy="292608"/>
+            <a:ext cx="1554480" cy="292608"/>
           </a:xfrm>
           <a:prstGeom prst="rect">
             <a:avLst/>
@@ -10284,7 +10490,7 @@
         </p:nvSpPr>
         <p:spPr>
           <a:xfrm>
-            <a:off x="2103120" y="2423160"/>
+            <a:off x="2194560" y="2423160"/>
             <a:ext cx="868680" cy="292608"/>
           </a:xfrm>
           <a:prstGeom prst="rect">
@@ -10323,7 +10529,7 @@
         </p:nvSpPr>
         <p:spPr>
           <a:xfrm>
-            <a:off x="2971800" y="2423160"/>
+            <a:off x="3063240" y="2423160"/>
             <a:ext cx="868680" cy="292608"/>
           </a:xfrm>
           <a:prstGeom prst="rect">
@@ -10348,7 +10554,7 @@
                 <a:ea typeface="Consolas" pitchFamily="34" charset="-122"/>
                 <a:cs typeface="Consolas" pitchFamily="34" charset="-120"/>
               </a:rPr>
-              <a:t>−9.28</a:t>
+              <a:t>−9.52</a:t>
             </a:r>
             <a:endParaRPr lang="en-US" sz="1050" dirty="0"/>
           </a:p>
@@ -10362,8 +10568,8 @@
         </p:nvSpPr>
         <p:spPr>
           <a:xfrm>
-            <a:off x="3840480" y="2423160"/>
-            <a:ext cx="868680" cy="292608"/>
+            <a:off x="3931920" y="2423160"/>
+            <a:ext cx="914400" cy="292608"/>
           </a:xfrm>
           <a:prstGeom prst="rect">
             <a:avLst/>
@@ -10387,7 +10593,7 @@
                 <a:ea typeface="Consolas" pitchFamily="34" charset="-122"/>
                 <a:cs typeface="Consolas" pitchFamily="34" charset="-120"/>
               </a:rPr>
-              <a:t>&lt;10⁻⁵</a:t>
+              <a:t>&lt;10⁻⁶</a:t>
             </a:r>
             <a:endParaRPr lang="en-US" sz="1050" dirty="0"/>
           </a:p>
@@ -10401,8 +10607,8 @@
         </p:nvSpPr>
         <p:spPr>
           <a:xfrm>
-            <a:off x="4709160" y="2423160"/>
-            <a:ext cx="640080" cy="292608"/>
+            <a:off x="4846320" y="2423160"/>
+            <a:ext cx="548640" cy="292608"/>
           </a:xfrm>
           <a:prstGeom prst="rect">
             <a:avLst/>
@@ -10441,7 +10647,7 @@
         <p:spPr>
           <a:xfrm>
             <a:off x="640080" y="2807208"/>
-            <a:ext cx="1463040" cy="292608"/>
+            <a:ext cx="1554480" cy="292608"/>
           </a:xfrm>
           <a:prstGeom prst="rect">
             <a:avLst/>
@@ -10465,7 +10671,7 @@
                 <a:ea typeface="Calibri" pitchFamily="34" charset="-122"/>
                 <a:cs typeface="Calibri" pitchFamily="34" charset="-120"/>
               </a:rPr>
-              <a:t>Höhe (approx)</a:t>
+              <a:t>Höhe (SwissALTI3D)</a:t>
             </a:r>
             <a:endParaRPr lang="en-US" sz="1100" dirty="0"/>
           </a:p>
@@ -10479,7 +10685,7 @@
         </p:nvSpPr>
         <p:spPr>
           <a:xfrm>
-            <a:off x="2103120" y="2807208"/>
+            <a:off x="2194560" y="2807208"/>
             <a:ext cx="868680" cy="292608"/>
           </a:xfrm>
           <a:prstGeom prst="rect">
@@ -10504,7 +10710,7 @@
                 <a:ea typeface="Consolas" pitchFamily="34" charset="-122"/>
                 <a:cs typeface="Consolas" pitchFamily="34" charset="-120"/>
               </a:rPr>
-              <a:t>−0.04</a:t>
+              <a:t>−0.60</a:t>
             </a:r>
             <a:endParaRPr lang="en-US" sz="1050" dirty="0"/>
           </a:p>
@@ -10518,7 +10724,7 @@
         </p:nvSpPr>
         <p:spPr>
           <a:xfrm>
-            <a:off x="2971800" y="2807208"/>
+            <a:off x="3063240" y="2807208"/>
             <a:ext cx="868680" cy="292608"/>
           </a:xfrm>
           <a:prstGeom prst="rect">
@@ -10543,7 +10749,7 @@
                 <a:ea typeface="Consolas" pitchFamily="34" charset="-122"/>
                 <a:cs typeface="Consolas" pitchFamily="34" charset="-120"/>
               </a:rPr>
-              <a:t>+0.03</a:t>
+              <a:t>−0.107</a:t>
             </a:r>
             <a:endParaRPr lang="en-US" sz="1050" dirty="0"/>
           </a:p>
@@ -10557,8 +10763,8 @@
         </p:nvSpPr>
         <p:spPr>
           <a:xfrm>
-            <a:off x="3840480" y="2807208"/>
-            <a:ext cx="868680" cy="292608"/>
+            <a:off x="3931920" y="2807208"/>
+            <a:ext cx="914400" cy="292608"/>
           </a:xfrm>
           <a:prstGeom prst="rect">
             <a:avLst/>
@@ -10582,7 +10788,7 @@
                 <a:ea typeface="Consolas" pitchFamily="34" charset="-122"/>
                 <a:cs typeface="Consolas" pitchFamily="34" charset="-120"/>
               </a:rPr>
-              <a:t>0.640</a:t>
+              <a:t>&lt;10⁻³</a:t>
             </a:r>
             <a:endParaRPr lang="en-US" sz="1050" dirty="0"/>
           </a:p>
@@ -10596,8 +10802,8 @@
         </p:nvSpPr>
         <p:spPr>
           <a:xfrm>
-            <a:off x="4709160" y="2807208"/>
-            <a:ext cx="640080" cy="292608"/>
+            <a:off x="4846320" y="2807208"/>
+            <a:ext cx="548640" cy="292608"/>
           </a:xfrm>
           <a:prstGeom prst="rect">
             <a:avLst/>
@@ -10615,13 +10821,13 @@
             <a:r>
               <a:rPr lang="en-US" sz="1050" b="1" dirty="0">
                 <a:solidFill>
-                  <a:srgbClr val="64748B"/>
+                  <a:srgbClr val="1A9850"/>
                 </a:solidFill>
                 <a:latin typeface="Consolas" pitchFamily="34" charset="0"/>
                 <a:ea typeface="Consolas" pitchFamily="34" charset="-122"/>
                 <a:cs typeface="Consolas" pitchFamily="34" charset="-120"/>
               </a:rPr>
-              <a:t>n.s.</a:t>
+              <a:t>***</a:t>
             </a:r>
             <a:endParaRPr lang="en-US" sz="1050" dirty="0"/>
           </a:p>
@@ -10636,7 +10842,7 @@
         <p:spPr>
           <a:xfrm>
             <a:off x="640080" y="3191256"/>
-            <a:ext cx="1463040" cy="292608"/>
+            <a:ext cx="1554480" cy="292608"/>
           </a:xfrm>
           <a:prstGeom prst="rect">
             <a:avLst/>
@@ -10674,7 +10880,7 @@
         </p:nvSpPr>
         <p:spPr>
           <a:xfrm>
-            <a:off x="2103120" y="3191256"/>
+            <a:off x="2194560" y="3191256"/>
             <a:ext cx="868680" cy="292608"/>
           </a:xfrm>
           <a:prstGeom prst="rect">
@@ -10713,7 +10919,7 @@
         </p:nvSpPr>
         <p:spPr>
           <a:xfrm>
-            <a:off x="2971800" y="3191256"/>
+            <a:off x="3063240" y="3191256"/>
             <a:ext cx="868680" cy="292608"/>
           </a:xfrm>
           <a:prstGeom prst="rect">
@@ -10738,7 +10944,7 @@
                 <a:ea typeface="Consolas" pitchFamily="34" charset="-122"/>
                 <a:cs typeface="Consolas" pitchFamily="34" charset="-120"/>
               </a:rPr>
-              <a:t>+0.10</a:t>
+              <a:t>+0.069</a:t>
             </a:r>
             <a:endParaRPr lang="en-US" sz="1050" dirty="0"/>
           </a:p>
@@ -10752,8 +10958,8 @@
         </p:nvSpPr>
         <p:spPr>
           <a:xfrm>
-            <a:off x="3840480" y="3191256"/>
-            <a:ext cx="868680" cy="292608"/>
+            <a:off x="3931920" y="3191256"/>
+            <a:ext cx="914400" cy="292608"/>
           </a:xfrm>
           <a:prstGeom prst="rect">
             <a:avLst/>
@@ -10777,7 +10983,7 @@
                 <a:ea typeface="Consolas" pitchFamily="34" charset="-122"/>
                 <a:cs typeface="Consolas" pitchFamily="34" charset="-120"/>
               </a:rPr>
-              <a:t>&lt;10⁻⁵</a:t>
+              <a:t>&lt;10⁻⁴</a:t>
             </a:r>
             <a:endParaRPr lang="en-US" sz="1050" dirty="0"/>
           </a:p>
@@ -10791,8 +10997,8 @@
         </p:nvSpPr>
         <p:spPr>
           <a:xfrm>
-            <a:off x="4709160" y="3191256"/>
-            <a:ext cx="640080" cy="292608"/>
+            <a:off x="4846320" y="3191256"/>
+            <a:ext cx="548640" cy="292608"/>
           </a:xfrm>
           <a:prstGeom prst="rect">
             <a:avLst/>
@@ -11007,7 +11213,7 @@
                 <a:ea typeface="Calibri" pitchFamily="34" charset="-122"/>
                 <a:cs typeface="Calibri" pitchFamily="34" charset="-120"/>
               </a:rPr>
-              <a:t>Distanz hochsignifikant nach Kontrolle.</a:t>
+              <a:t>Distanz hochsignifikant nach Kontrolle (β = −9.52).</a:t>
             </a:r>
             <a:endParaRPr lang="en-US" sz="1000" dirty="0"/>
           </a:p>
@@ -11058,7 +11264,7 @@
                 <a:ea typeface="Calibri" pitchFamily="34" charset="-122"/>
                 <a:cs typeface="Calibri" pitchFamily="34" charset="-120"/>
               </a:rPr>
-              <a:t>Höher = niedrigerer Score (β = −0.10).</a:t>
+              <a:t>SwissALTI3D-Höhen: höher = niedrigerer Score (β = −0.107).</a:t>
             </a:r>
             <a:endParaRPr lang="en-US" sz="1000" dirty="0"/>
           </a:p>
@@ -11579,7 +11785,7 @@
                 <a:ea typeface="Trebuchet MS" pitchFamily="34" charset="-122"/>
                 <a:cs typeface="Trebuchet MS" pitchFamily="34" charset="-120"/>
               </a:rPr>
-              <a:t>Topografie-Approximation</a:t>
+              <a:t>Tobler-Modell-Annahme</a:t>
             </a:r>
             <a:endParaRPr lang="en-US" sz="1400" dirty="0"/>
           </a:p>
@@ -11618,7 +11824,7 @@
                 <a:ea typeface="Calibri" pitchFamily="34" charset="-122"/>
                 <a:cs typeface="Calibri" pitchFamily="34" charset="-120"/>
               </a:rPr>
-              <a:t>Open-Elevation-API zum Auswertungszeitpunkt down — Höhen via N-Koordinaten approximiert. Mit DEM-Daten von swisstopo wäre der Höhen-Confounder belastbarer testbar.</a:t>
+              <a:t>Die Tobler-Hiking-Funktion ist auf Wandern in offenem Gelände kalibriert (Tobler 1993), nicht auf städtisches Gehen mit Ampeln und Querstrassen. Der relative Unterschied flat vs. topografisch (Slide 13) bleibt aber aussagekräftig.</a:t>
             </a:r>
             <a:endParaRPr lang="en-US" sz="1100" dirty="0"/>
           </a:p>
@@ -16705,7 +16911,7 @@
                 <a:ea typeface="Trebuchet MS" pitchFamily="34" charset="-122"/>
                 <a:cs typeface="Trebuchet MS" pitchFamily="34" charset="-120"/>
               </a:rPr>
-              <a:t>Daten — sieben Quellen, ein Modell</a:t>
+              <a:t>Daten — acht Quellen, ein Modell</a:t>
             </a:r>
             <a:endParaRPr lang="en-US" sz="3000" dirty="0"/>
           </a:p>
@@ -17580,7 +17786,7 @@
                           <a:ea typeface="Calibri" pitchFamily="34" charset="-122"/>
                           <a:cs typeface="Calibri" pitchFamily="34" charset="-120"/>
                         </a:rPr>
-                        <a:t>OSM admin_level=10</a:t>
+                        <a:t>BFS STATPOP 2023</a:t>
                       </a:r>
                       <a:endParaRPr lang="en-US" sz="1150" dirty="0">
                         <a:latin typeface="Calibri" charset="0"/>
@@ -17648,7 +17854,7 @@
                           <a:ea typeface="Calibri" pitchFamily="34" charset="-122"/>
                           <a:cs typeface="Calibri" pitchFamily="34" charset="-120"/>
                         </a:rPr>
-                        <a:t>Quartier-Polygone (44 mit Score)</a:t>
+                        <a:t>Bevölkerungsdichte (Hektar-Raster)</a:t>
                       </a:r>
                       <a:endParaRPr lang="en-US" sz="1150" dirty="0">
                         <a:latin typeface="Calibri" charset="0"/>
@@ -17716,7 +17922,625 @@
                           <a:ea typeface="Calibri" pitchFamily="34" charset="-122"/>
                           <a:cs typeface="Calibri" pitchFamily="34" charset="-120"/>
                         </a:rPr>
-                        <a:t>ODbL</a:t>
+                        <a:t>Open Data BFS</a:t>
+                      </a:r>
+                      <a:endParaRPr lang="en-US" sz="1150" dirty="0">
+                        <a:latin typeface="Calibri" charset="0"/>
+                        <a:ea typeface="Calibri" charset="0"/>
+                        <a:cs typeface="Calibri" charset="0"/>
+                      </a:endParaRPr>
+                    </a:p>
+                  </a:txBody>
+                  <a:tcPr marL="91440" marR="91440" marT="45720" marB="45720">
+                    <a:lnL w="6350" cap="flat" cmpd="sng" algn="ctr">
+                      <a:solidFill>
+                        <a:srgbClr val="E2E8F0"/>
+                      </a:solidFill>
+                      <a:prstDash val="solid"/>
+                      <a:round/>
+                      <a:headEnd type="none" w="med" len="med"/>
+                      <a:tailEnd type="none" w="med" len="med"/>
+                    </a:lnL>
+                    <a:lnR w="6350" cap="flat" cmpd="sng" algn="ctr">
+                      <a:solidFill>
+                        <a:srgbClr val="E2E8F0"/>
+                      </a:solidFill>
+                      <a:prstDash val="solid"/>
+                      <a:round/>
+                      <a:headEnd type="none" w="med" len="med"/>
+                      <a:tailEnd type="none" w="med" len="med"/>
+                    </a:lnR>
+                    <a:lnT w="6350" cap="flat" cmpd="sng" algn="ctr">
+                      <a:solidFill>
+                        <a:srgbClr val="E2E8F0"/>
+                      </a:solidFill>
+                      <a:prstDash val="solid"/>
+                      <a:round/>
+                      <a:headEnd type="none" w="med" len="med"/>
+                      <a:tailEnd type="none" w="med" len="med"/>
+                    </a:lnT>
+                    <a:lnB w="6350" cap="flat" cmpd="sng" algn="ctr">
+                      <a:solidFill>
+                        <a:srgbClr val="E2E8F0"/>
+                      </a:solidFill>
+                      <a:prstDash val="solid"/>
+                      <a:round/>
+                      <a:headEnd type="none" w="med" len="med"/>
+                      <a:tailEnd type="none" w="med" len="med"/>
+                    </a:lnB>
+                    <a:solidFill>
+                      <a:srgbClr val="FFFFFF"/>
+                    </a:solidFill>
+                  </a:tcPr>
+                </a:tc>
+              </a:tr>
+              <a:tr h="384048">
+                <a:tc>
+                  <a:txBody>
+                    <a:bodyPr/>
+                    <a:lstStyle/>
+                    <a:p>
+                      <a:pPr algn="l" indent="0" marL="0">
+                        <a:buNone/>
+                      </a:pPr>
+                      <a:r>
+                        <a:rPr lang="en-US" sz="1150" dirty="0">
+                          <a:solidFill>
+                            <a:srgbClr val="0F172A"/>
+                          </a:solidFill>
+                          <a:latin typeface="Calibri" pitchFamily="34" charset="0"/>
+                          <a:ea typeface="Calibri" pitchFamily="34" charset="-122"/>
+                          <a:cs typeface="Calibri" pitchFamily="34" charset="-120"/>
+                        </a:rPr>
+                        <a:t>Stadt Zürich Open Data</a:t>
+                      </a:r>
+                      <a:endParaRPr lang="en-US" sz="1150" dirty="0">
+                        <a:latin typeface="Calibri" charset="0"/>
+                        <a:ea typeface="Calibri" charset="0"/>
+                        <a:cs typeface="Calibri" charset="0"/>
+                      </a:endParaRPr>
+                    </a:p>
+                  </a:txBody>
+                  <a:tcPr marL="91440" marR="91440" marT="45720" marB="45720">
+                    <a:lnL w="6350" cap="flat" cmpd="sng" algn="ctr">
+                      <a:solidFill>
+                        <a:srgbClr val="E2E8F0"/>
+                      </a:solidFill>
+                      <a:prstDash val="solid"/>
+                      <a:round/>
+                      <a:headEnd type="none" w="med" len="med"/>
+                      <a:tailEnd type="none" w="med" len="med"/>
+                    </a:lnL>
+                    <a:lnR w="6350" cap="flat" cmpd="sng" algn="ctr">
+                      <a:solidFill>
+                        <a:srgbClr val="E2E8F0"/>
+                      </a:solidFill>
+                      <a:prstDash val="solid"/>
+                      <a:round/>
+                      <a:headEnd type="none" w="med" len="med"/>
+                      <a:tailEnd type="none" w="med" len="med"/>
+                    </a:lnR>
+                    <a:lnT w="6350" cap="flat" cmpd="sng" algn="ctr">
+                      <a:solidFill>
+                        <a:srgbClr val="E2E8F0"/>
+                      </a:solidFill>
+                      <a:prstDash val="solid"/>
+                      <a:round/>
+                      <a:headEnd type="none" w="med" len="med"/>
+                      <a:tailEnd type="none" w="med" len="med"/>
+                    </a:lnT>
+                    <a:lnB w="6350" cap="flat" cmpd="sng" algn="ctr">
+                      <a:solidFill>
+                        <a:srgbClr val="E2E8F0"/>
+                      </a:solidFill>
+                      <a:prstDash val="solid"/>
+                      <a:round/>
+                      <a:headEnd type="none" w="med" len="med"/>
+                      <a:tailEnd type="none" w="med" len="med"/>
+                    </a:lnB>
+                    <a:solidFill>
+                      <a:srgbClr val="FFFFFF"/>
+                    </a:solidFill>
+                  </a:tcPr>
+                </a:tc>
+                <a:tc>
+                  <a:txBody>
+                    <a:bodyPr/>
+                    <a:lstStyle/>
+                    <a:p>
+                      <a:pPr algn="l" indent="0" marL="0">
+                        <a:buNone/>
+                      </a:pPr>
+                      <a:r>
+                        <a:rPr lang="en-US" sz="1150" dirty="0">
+                          <a:solidFill>
+                            <a:srgbClr val="0F172A"/>
+                          </a:solidFill>
+                          <a:latin typeface="Calibri" pitchFamily="34" charset="0"/>
+                          <a:ea typeface="Calibri" pitchFamily="34" charset="-122"/>
+                          <a:cs typeface="Calibri" pitchFamily="34" charset="-120"/>
+                        </a:rPr>
+                        <a:t>34 offizielle Quartiere + Mietpreis-Index</a:t>
+                      </a:r>
+                      <a:endParaRPr lang="en-US" sz="1150" dirty="0">
+                        <a:latin typeface="Calibri" charset="0"/>
+                        <a:ea typeface="Calibri" charset="0"/>
+                        <a:cs typeface="Calibri" charset="0"/>
+                      </a:endParaRPr>
+                    </a:p>
+                  </a:txBody>
+                  <a:tcPr marL="91440" marR="91440" marT="45720" marB="45720">
+                    <a:lnL w="6350" cap="flat" cmpd="sng" algn="ctr">
+                      <a:solidFill>
+                        <a:srgbClr val="E2E8F0"/>
+                      </a:solidFill>
+                      <a:prstDash val="solid"/>
+                      <a:round/>
+                      <a:headEnd type="none" w="med" len="med"/>
+                      <a:tailEnd type="none" w="med" len="med"/>
+                    </a:lnL>
+                    <a:lnR w="6350" cap="flat" cmpd="sng" algn="ctr">
+                      <a:solidFill>
+                        <a:srgbClr val="E2E8F0"/>
+                      </a:solidFill>
+                      <a:prstDash val="solid"/>
+                      <a:round/>
+                      <a:headEnd type="none" w="med" len="med"/>
+                      <a:tailEnd type="none" w="med" len="med"/>
+                    </a:lnR>
+                    <a:lnT w="6350" cap="flat" cmpd="sng" algn="ctr">
+                      <a:solidFill>
+                        <a:srgbClr val="E2E8F0"/>
+                      </a:solidFill>
+                      <a:prstDash val="solid"/>
+                      <a:round/>
+                      <a:headEnd type="none" w="med" len="med"/>
+                      <a:tailEnd type="none" w="med" len="med"/>
+                    </a:lnT>
+                    <a:lnB w="6350" cap="flat" cmpd="sng" algn="ctr">
+                      <a:solidFill>
+                        <a:srgbClr val="E2E8F0"/>
+                      </a:solidFill>
+                      <a:prstDash val="solid"/>
+                      <a:round/>
+                      <a:headEnd type="none" w="med" len="med"/>
+                      <a:tailEnd type="none" w="med" len="med"/>
+                    </a:lnB>
+                    <a:solidFill>
+                      <a:srgbClr val="FFFFFF"/>
+                    </a:solidFill>
+                  </a:tcPr>
+                </a:tc>
+                <a:tc>
+                  <a:txBody>
+                    <a:bodyPr/>
+                    <a:lstStyle/>
+                    <a:p>
+                      <a:pPr algn="l" indent="0" marL="0">
+                        <a:buNone/>
+                      </a:pPr>
+                      <a:r>
+                        <a:rPr lang="en-US" sz="1150" dirty="0">
+                          <a:solidFill>
+                            <a:srgbClr val="0F172A"/>
+                          </a:solidFill>
+                          <a:latin typeface="Calibri" pitchFamily="34" charset="0"/>
+                          <a:ea typeface="Calibri" pitchFamily="34" charset="-122"/>
+                          <a:cs typeface="Calibri" pitchFamily="34" charset="-120"/>
+                        </a:rPr>
+                        <a:t>CC BY 4.0</a:t>
+                      </a:r>
+                      <a:endParaRPr lang="en-US" sz="1150" dirty="0">
+                        <a:latin typeface="Calibri" charset="0"/>
+                        <a:ea typeface="Calibri" charset="0"/>
+                        <a:cs typeface="Calibri" charset="0"/>
+                      </a:endParaRPr>
+                    </a:p>
+                  </a:txBody>
+                  <a:tcPr marL="91440" marR="91440" marT="45720" marB="45720">
+                    <a:lnL w="6350" cap="flat" cmpd="sng" algn="ctr">
+                      <a:solidFill>
+                        <a:srgbClr val="E2E8F0"/>
+                      </a:solidFill>
+                      <a:prstDash val="solid"/>
+                      <a:round/>
+                      <a:headEnd type="none" w="med" len="med"/>
+                      <a:tailEnd type="none" w="med" len="med"/>
+                    </a:lnL>
+                    <a:lnR w="6350" cap="flat" cmpd="sng" algn="ctr">
+                      <a:solidFill>
+                        <a:srgbClr val="E2E8F0"/>
+                      </a:solidFill>
+                      <a:prstDash val="solid"/>
+                      <a:round/>
+                      <a:headEnd type="none" w="med" len="med"/>
+                      <a:tailEnd type="none" w="med" len="med"/>
+                    </a:lnR>
+                    <a:lnT w="6350" cap="flat" cmpd="sng" algn="ctr">
+                      <a:solidFill>
+                        <a:srgbClr val="E2E8F0"/>
+                      </a:solidFill>
+                      <a:prstDash val="solid"/>
+                      <a:round/>
+                      <a:headEnd type="none" w="med" len="med"/>
+                      <a:tailEnd type="none" w="med" len="med"/>
+                    </a:lnT>
+                    <a:lnB w="6350" cap="flat" cmpd="sng" algn="ctr">
+                      <a:solidFill>
+                        <a:srgbClr val="E2E8F0"/>
+                      </a:solidFill>
+                      <a:prstDash val="solid"/>
+                      <a:round/>
+                      <a:headEnd type="none" w="med" len="med"/>
+                      <a:tailEnd type="none" w="med" len="med"/>
+                    </a:lnB>
+                    <a:solidFill>
+                      <a:srgbClr val="FFFFFF"/>
+                    </a:solidFill>
+                  </a:tcPr>
+                </a:tc>
+              </a:tr>
+              <a:tr h="384048">
+                <a:tc>
+                  <a:txBody>
+                    <a:bodyPr/>
+                    <a:lstStyle/>
+                    <a:p>
+                      <a:pPr algn="l" indent="0" marL="0">
+                        <a:buNone/>
+                      </a:pPr>
+                      <a:r>
+                        <a:rPr lang="en-US" sz="1150" dirty="0">
+                          <a:solidFill>
+                            <a:srgbClr val="0F172A"/>
+                          </a:solidFill>
+                          <a:latin typeface="Calibri" pitchFamily="34" charset="0"/>
+                          <a:ea typeface="Calibri" pitchFamily="34" charset="-122"/>
+                          <a:cs typeface="Calibri" pitchFamily="34" charset="-120"/>
+                        </a:rPr>
+                        <a:t>swisstopo SwissALTI3D</a:t>
+                      </a:r>
+                      <a:endParaRPr lang="en-US" sz="1150" dirty="0">
+                        <a:latin typeface="Calibri" charset="0"/>
+                        <a:ea typeface="Calibri" charset="0"/>
+                        <a:cs typeface="Calibri" charset="0"/>
+                      </a:endParaRPr>
+                    </a:p>
+                  </a:txBody>
+                  <a:tcPr marL="91440" marR="91440" marT="45720" marB="45720">
+                    <a:lnL w="6350" cap="flat" cmpd="sng" algn="ctr">
+                      <a:solidFill>
+                        <a:srgbClr val="E2E8F0"/>
+                      </a:solidFill>
+                      <a:prstDash val="solid"/>
+                      <a:round/>
+                      <a:headEnd type="none" w="med" len="med"/>
+                      <a:tailEnd type="none" w="med" len="med"/>
+                    </a:lnL>
+                    <a:lnR w="6350" cap="flat" cmpd="sng" algn="ctr">
+                      <a:solidFill>
+                        <a:srgbClr val="E2E8F0"/>
+                      </a:solidFill>
+                      <a:prstDash val="solid"/>
+                      <a:round/>
+                      <a:headEnd type="none" w="med" len="med"/>
+                      <a:tailEnd type="none" w="med" len="med"/>
+                    </a:lnR>
+                    <a:lnT w="6350" cap="flat" cmpd="sng" algn="ctr">
+                      <a:solidFill>
+                        <a:srgbClr val="E2E8F0"/>
+                      </a:solidFill>
+                      <a:prstDash val="solid"/>
+                      <a:round/>
+                      <a:headEnd type="none" w="med" len="med"/>
+                      <a:tailEnd type="none" w="med" len="med"/>
+                    </a:lnT>
+                    <a:lnB w="6350" cap="flat" cmpd="sng" algn="ctr">
+                      <a:solidFill>
+                        <a:srgbClr val="E2E8F0"/>
+                      </a:solidFill>
+                      <a:prstDash val="solid"/>
+                      <a:round/>
+                      <a:headEnd type="none" w="med" len="med"/>
+                      <a:tailEnd type="none" w="med" len="med"/>
+                    </a:lnB>
+                    <a:solidFill>
+                      <a:srgbClr val="FFFFFF"/>
+                    </a:solidFill>
+                  </a:tcPr>
+                </a:tc>
+                <a:tc>
+                  <a:txBody>
+                    <a:bodyPr/>
+                    <a:lstStyle/>
+                    <a:p>
+                      <a:pPr algn="l" indent="0" marL="0">
+                        <a:buNone/>
+                      </a:pPr>
+                      <a:r>
+                        <a:rPr lang="en-US" sz="1150" dirty="0">
+                          <a:solidFill>
+                            <a:srgbClr val="0F172A"/>
+                          </a:solidFill>
+                          <a:latin typeface="Calibri" pitchFamily="34" charset="0"/>
+                          <a:ea typeface="Calibri" pitchFamily="34" charset="-122"/>
+                          <a:cs typeface="Calibri" pitchFamily="34" charset="-120"/>
+                        </a:rPr>
+                        <a:t>Höhenmodell 2 m für Tobler-Erweiterung</a:t>
+                      </a:r>
+                      <a:endParaRPr lang="en-US" sz="1150" dirty="0">
+                        <a:latin typeface="Calibri" charset="0"/>
+                        <a:ea typeface="Calibri" charset="0"/>
+                        <a:cs typeface="Calibri" charset="0"/>
+                      </a:endParaRPr>
+                    </a:p>
+                  </a:txBody>
+                  <a:tcPr marL="91440" marR="91440" marT="45720" marB="45720">
+                    <a:lnL w="6350" cap="flat" cmpd="sng" algn="ctr">
+                      <a:solidFill>
+                        <a:srgbClr val="E2E8F0"/>
+                      </a:solidFill>
+                      <a:prstDash val="solid"/>
+                      <a:round/>
+                      <a:headEnd type="none" w="med" len="med"/>
+                      <a:tailEnd type="none" w="med" len="med"/>
+                    </a:lnL>
+                    <a:lnR w="6350" cap="flat" cmpd="sng" algn="ctr">
+                      <a:solidFill>
+                        <a:srgbClr val="E2E8F0"/>
+                      </a:solidFill>
+                      <a:prstDash val="solid"/>
+                      <a:round/>
+                      <a:headEnd type="none" w="med" len="med"/>
+                      <a:tailEnd type="none" w="med" len="med"/>
+                    </a:lnR>
+                    <a:lnT w="6350" cap="flat" cmpd="sng" algn="ctr">
+                      <a:solidFill>
+                        <a:srgbClr val="E2E8F0"/>
+                      </a:solidFill>
+                      <a:prstDash val="solid"/>
+                      <a:round/>
+                      <a:headEnd type="none" w="med" len="med"/>
+                      <a:tailEnd type="none" w="med" len="med"/>
+                    </a:lnT>
+                    <a:lnB w="6350" cap="flat" cmpd="sng" algn="ctr">
+                      <a:solidFill>
+                        <a:srgbClr val="E2E8F0"/>
+                      </a:solidFill>
+                      <a:prstDash val="solid"/>
+                      <a:round/>
+                      <a:headEnd type="none" w="med" len="med"/>
+                      <a:tailEnd type="none" w="med" len="med"/>
+                    </a:lnB>
+                    <a:solidFill>
+                      <a:srgbClr val="FFFFFF"/>
+                    </a:solidFill>
+                  </a:tcPr>
+                </a:tc>
+                <a:tc>
+                  <a:txBody>
+                    <a:bodyPr/>
+                    <a:lstStyle/>
+                    <a:p>
+                      <a:pPr algn="l" indent="0" marL="0">
+                        <a:buNone/>
+                      </a:pPr>
+                      <a:r>
+                        <a:rPr lang="en-US" sz="1150" dirty="0">
+                          <a:solidFill>
+                            <a:srgbClr val="0F172A"/>
+                          </a:solidFill>
+                          <a:latin typeface="Calibri" pitchFamily="34" charset="0"/>
+                          <a:ea typeface="Calibri" pitchFamily="34" charset="-122"/>
+                          <a:cs typeface="Calibri" pitchFamily="34" charset="-120"/>
+                        </a:rPr>
+                        <a:t>swisstopo OGD</a:t>
+                      </a:r>
+                      <a:endParaRPr lang="en-US" sz="1150" dirty="0">
+                        <a:latin typeface="Calibri" charset="0"/>
+                        <a:ea typeface="Calibri" charset="0"/>
+                        <a:cs typeface="Calibri" charset="0"/>
+                      </a:endParaRPr>
+                    </a:p>
+                  </a:txBody>
+                  <a:tcPr marL="91440" marR="91440" marT="45720" marB="45720">
+                    <a:lnL w="6350" cap="flat" cmpd="sng" algn="ctr">
+                      <a:solidFill>
+                        <a:srgbClr val="E2E8F0"/>
+                      </a:solidFill>
+                      <a:prstDash val="solid"/>
+                      <a:round/>
+                      <a:headEnd type="none" w="med" len="med"/>
+                      <a:tailEnd type="none" w="med" len="med"/>
+                    </a:lnL>
+                    <a:lnR w="6350" cap="flat" cmpd="sng" algn="ctr">
+                      <a:solidFill>
+                        <a:srgbClr val="E2E8F0"/>
+                      </a:solidFill>
+                      <a:prstDash val="solid"/>
+                      <a:round/>
+                      <a:headEnd type="none" w="med" len="med"/>
+                      <a:tailEnd type="none" w="med" len="med"/>
+                    </a:lnR>
+                    <a:lnT w="6350" cap="flat" cmpd="sng" algn="ctr">
+                      <a:solidFill>
+                        <a:srgbClr val="E2E8F0"/>
+                      </a:solidFill>
+                      <a:prstDash val="solid"/>
+                      <a:round/>
+                      <a:headEnd type="none" w="med" len="med"/>
+                      <a:tailEnd type="none" w="med" len="med"/>
+                    </a:lnT>
+                    <a:lnB w="6350" cap="flat" cmpd="sng" algn="ctr">
+                      <a:solidFill>
+                        <a:srgbClr val="E2E8F0"/>
+                      </a:solidFill>
+                      <a:prstDash val="solid"/>
+                      <a:round/>
+                      <a:headEnd type="none" w="med" len="med"/>
+                      <a:tailEnd type="none" w="med" len="med"/>
+                    </a:lnB>
+                    <a:solidFill>
+                      <a:srgbClr val="FFFFFF"/>
+                    </a:solidFill>
+                  </a:tcPr>
+                </a:tc>
+              </a:tr>
+              <a:tr h="384048">
+                <a:tc>
+                  <a:txBody>
+                    <a:bodyPr/>
+                    <a:lstStyle/>
+                    <a:p>
+                      <a:pPr algn="l" indent="0" marL="0">
+                        <a:buNone/>
+                      </a:pPr>
+                      <a:r>
+                        <a:rPr lang="en-US" sz="1150" dirty="0">
+                          <a:solidFill>
+                            <a:srgbClr val="0F172A"/>
+                          </a:solidFill>
+                          <a:latin typeface="Calibri" pitchFamily="34" charset="0"/>
+                          <a:ea typeface="Calibri" pitchFamily="34" charset="-122"/>
+                          <a:cs typeface="Calibri" pitchFamily="34" charset="-120"/>
+                        </a:rPr>
+                        <a:t>swisstopo TileMap</a:t>
+                      </a:r>
+                      <a:endParaRPr lang="en-US" sz="1150" dirty="0">
+                        <a:latin typeface="Calibri" charset="0"/>
+                        <a:ea typeface="Calibri" charset="0"/>
+                        <a:cs typeface="Calibri" charset="0"/>
+                      </a:endParaRPr>
+                    </a:p>
+                  </a:txBody>
+                  <a:tcPr marL="91440" marR="91440" marT="45720" marB="45720">
+                    <a:lnL w="6350" cap="flat" cmpd="sng" algn="ctr">
+                      <a:solidFill>
+                        <a:srgbClr val="E2E8F0"/>
+                      </a:solidFill>
+                      <a:prstDash val="solid"/>
+                      <a:round/>
+                      <a:headEnd type="none" w="med" len="med"/>
+                      <a:tailEnd type="none" w="med" len="med"/>
+                    </a:lnL>
+                    <a:lnR w="6350" cap="flat" cmpd="sng" algn="ctr">
+                      <a:solidFill>
+                        <a:srgbClr val="E2E8F0"/>
+                      </a:solidFill>
+                      <a:prstDash val="solid"/>
+                      <a:round/>
+                      <a:headEnd type="none" w="med" len="med"/>
+                      <a:tailEnd type="none" w="med" len="med"/>
+                    </a:lnR>
+                    <a:lnT w="6350" cap="flat" cmpd="sng" algn="ctr">
+                      <a:solidFill>
+                        <a:srgbClr val="E2E8F0"/>
+                      </a:solidFill>
+                      <a:prstDash val="solid"/>
+                      <a:round/>
+                      <a:headEnd type="none" w="med" len="med"/>
+                      <a:tailEnd type="none" w="med" len="med"/>
+                    </a:lnT>
+                    <a:lnB w="6350" cap="flat" cmpd="sng" algn="ctr">
+                      <a:solidFill>
+                        <a:srgbClr val="E2E8F0"/>
+                      </a:solidFill>
+                      <a:prstDash val="solid"/>
+                      <a:round/>
+                      <a:headEnd type="none" w="med" len="med"/>
+                      <a:tailEnd type="none" w="med" len="med"/>
+                    </a:lnB>
+                    <a:solidFill>
+                      <a:srgbClr val="FFFFFF"/>
+                    </a:solidFill>
+                  </a:tcPr>
+                </a:tc>
+                <a:tc>
+                  <a:txBody>
+                    <a:bodyPr/>
+                    <a:lstStyle/>
+                    <a:p>
+                      <a:pPr algn="l" indent="0" marL="0">
+                        <a:buNone/>
+                      </a:pPr>
+                      <a:r>
+                        <a:rPr lang="en-US" sz="1150" dirty="0">
+                          <a:solidFill>
+                            <a:srgbClr val="0F172A"/>
+                          </a:solidFill>
+                          <a:latin typeface="Calibri" pitchFamily="34" charset="0"/>
+                          <a:ea typeface="Calibri" pitchFamily="34" charset="-122"/>
+                          <a:cs typeface="Calibri" pitchFamily="34" charset="-120"/>
+                        </a:rPr>
+                        <a:t>Hintergrundkarten (Folium-Tiles)</a:t>
+                      </a:r>
+                      <a:endParaRPr lang="en-US" sz="1150" dirty="0">
+                        <a:latin typeface="Calibri" charset="0"/>
+                        <a:ea typeface="Calibri" charset="0"/>
+                        <a:cs typeface="Calibri" charset="0"/>
+                      </a:endParaRPr>
+                    </a:p>
+                  </a:txBody>
+                  <a:tcPr marL="91440" marR="91440" marT="45720" marB="45720">
+                    <a:lnL w="6350" cap="flat" cmpd="sng" algn="ctr">
+                      <a:solidFill>
+                        <a:srgbClr val="E2E8F0"/>
+                      </a:solidFill>
+                      <a:prstDash val="solid"/>
+                      <a:round/>
+                      <a:headEnd type="none" w="med" len="med"/>
+                      <a:tailEnd type="none" w="med" len="med"/>
+                    </a:lnL>
+                    <a:lnR w="6350" cap="flat" cmpd="sng" algn="ctr">
+                      <a:solidFill>
+                        <a:srgbClr val="E2E8F0"/>
+                      </a:solidFill>
+                      <a:prstDash val="solid"/>
+                      <a:round/>
+                      <a:headEnd type="none" w="med" len="med"/>
+                      <a:tailEnd type="none" w="med" len="med"/>
+                    </a:lnR>
+                    <a:lnT w="6350" cap="flat" cmpd="sng" algn="ctr">
+                      <a:solidFill>
+                        <a:srgbClr val="E2E8F0"/>
+                      </a:solidFill>
+                      <a:prstDash val="solid"/>
+                      <a:round/>
+                      <a:headEnd type="none" w="med" len="med"/>
+                      <a:tailEnd type="none" w="med" len="med"/>
+                    </a:lnT>
+                    <a:lnB w="6350" cap="flat" cmpd="sng" algn="ctr">
+                      <a:solidFill>
+                        <a:srgbClr val="E2E8F0"/>
+                      </a:solidFill>
+                      <a:prstDash val="solid"/>
+                      <a:round/>
+                      <a:headEnd type="none" w="med" len="med"/>
+                      <a:tailEnd type="none" w="med" len="med"/>
+                    </a:lnB>
+                    <a:solidFill>
+                      <a:srgbClr val="FFFFFF"/>
+                    </a:solidFill>
+                  </a:tcPr>
+                </a:tc>
+                <a:tc>
+                  <a:txBody>
+                    <a:bodyPr/>
+                    <a:lstStyle/>
+                    <a:p>
+                      <a:pPr algn="l" indent="0" marL="0">
+                        <a:buNone/>
+                      </a:pPr>
+                      <a:r>
+                        <a:rPr lang="en-US" sz="1150" dirty="0">
+                          <a:solidFill>
+                            <a:srgbClr val="0F172A"/>
+                          </a:solidFill>
+                          <a:latin typeface="Calibri" pitchFamily="34" charset="0"/>
+                          <a:ea typeface="Calibri" pitchFamily="34" charset="-122"/>
+                          <a:cs typeface="Calibri" pitchFamily="34" charset="-120"/>
+                        </a:rPr>
+                        <a:t>swisstopo Terms</a:t>
                       </a:r>
                       <a:endParaRPr lang="en-US" sz="1150" dirty="0">
                         <a:latin typeface="Calibri" charset="0"/>
@@ -17854,7 +18678,7 @@
                           <a:ea typeface="Calibri" pitchFamily="34" charset="-122"/>
                           <a:cs typeface="Calibri" pitchFamily="34" charset="-120"/>
                         </a:rPr>
-                        <a:t>Distanz-Referenz für H1-Test</a:t>
+                        <a:t>Distanz-Referenz für H1a-Test</a:t>
                       </a:r>
                       <a:endParaRPr lang="en-US" sz="1150" dirty="0">
                         <a:latin typeface="Calibri" charset="0"/>
@@ -17923,418 +18747,6 @@
                           <a:cs typeface="Calibri" pitchFamily="34" charset="-120"/>
                         </a:rPr>
                         <a:t>—</a:t>
-                      </a:r>
-                      <a:endParaRPr lang="en-US" sz="1150" dirty="0">
-                        <a:latin typeface="Calibri" charset="0"/>
-                        <a:ea typeface="Calibri" charset="0"/>
-                        <a:cs typeface="Calibri" charset="0"/>
-                      </a:endParaRPr>
-                    </a:p>
-                  </a:txBody>
-                  <a:tcPr marL="91440" marR="91440" marT="45720" marB="45720">
-                    <a:lnL w="6350" cap="flat" cmpd="sng" algn="ctr">
-                      <a:solidFill>
-                        <a:srgbClr val="E2E8F0"/>
-                      </a:solidFill>
-                      <a:prstDash val="solid"/>
-                      <a:round/>
-                      <a:headEnd type="none" w="med" len="med"/>
-                      <a:tailEnd type="none" w="med" len="med"/>
-                    </a:lnL>
-                    <a:lnR w="6350" cap="flat" cmpd="sng" algn="ctr">
-                      <a:solidFill>
-                        <a:srgbClr val="E2E8F0"/>
-                      </a:solidFill>
-                      <a:prstDash val="solid"/>
-                      <a:round/>
-                      <a:headEnd type="none" w="med" len="med"/>
-                      <a:tailEnd type="none" w="med" len="med"/>
-                    </a:lnR>
-                    <a:lnT w="6350" cap="flat" cmpd="sng" algn="ctr">
-                      <a:solidFill>
-                        <a:srgbClr val="E2E8F0"/>
-                      </a:solidFill>
-                      <a:prstDash val="solid"/>
-                      <a:round/>
-                      <a:headEnd type="none" w="med" len="med"/>
-                      <a:tailEnd type="none" w="med" len="med"/>
-                    </a:lnT>
-                    <a:lnB w="6350" cap="flat" cmpd="sng" algn="ctr">
-                      <a:solidFill>
-                        <a:srgbClr val="E2E8F0"/>
-                      </a:solidFill>
-                      <a:prstDash val="solid"/>
-                      <a:round/>
-                      <a:headEnd type="none" w="med" len="med"/>
-                      <a:tailEnd type="none" w="med" len="med"/>
-                    </a:lnB>
-                    <a:solidFill>
-                      <a:srgbClr val="FFFFFF"/>
-                    </a:solidFill>
-                  </a:tcPr>
-                </a:tc>
-              </a:tr>
-              <a:tr h="384048">
-                <a:tc>
-                  <a:txBody>
-                    <a:bodyPr/>
-                    <a:lstStyle/>
-                    <a:p>
-                      <a:pPr algn="l" indent="0" marL="0">
-                        <a:buNone/>
-                      </a:pPr>
-                      <a:r>
-                        <a:rPr lang="en-US" sz="1150" dirty="0">
-                          <a:solidFill>
-                            <a:srgbClr val="0F172A"/>
-                          </a:solidFill>
-                          <a:latin typeface="Calibri" pitchFamily="34" charset="0"/>
-                          <a:ea typeface="Calibri" pitchFamily="34" charset="-122"/>
-                          <a:cs typeface="Calibri" pitchFamily="34" charset="-120"/>
-                        </a:rPr>
-                        <a:t>Open-Elevation API</a:t>
-                      </a:r>
-                      <a:endParaRPr lang="en-US" sz="1150" dirty="0">
-                        <a:latin typeface="Calibri" charset="0"/>
-                        <a:ea typeface="Calibri" charset="0"/>
-                        <a:cs typeface="Calibri" charset="0"/>
-                      </a:endParaRPr>
-                    </a:p>
-                  </a:txBody>
-                  <a:tcPr marL="91440" marR="91440" marT="45720" marB="45720">
-                    <a:lnL w="6350" cap="flat" cmpd="sng" algn="ctr">
-                      <a:solidFill>
-                        <a:srgbClr val="E2E8F0"/>
-                      </a:solidFill>
-                      <a:prstDash val="solid"/>
-                      <a:round/>
-                      <a:headEnd type="none" w="med" len="med"/>
-                      <a:tailEnd type="none" w="med" len="med"/>
-                    </a:lnL>
-                    <a:lnR w="6350" cap="flat" cmpd="sng" algn="ctr">
-                      <a:solidFill>
-                        <a:srgbClr val="E2E8F0"/>
-                      </a:solidFill>
-                      <a:prstDash val="solid"/>
-                      <a:round/>
-                      <a:headEnd type="none" w="med" len="med"/>
-                      <a:tailEnd type="none" w="med" len="med"/>
-                    </a:lnR>
-                    <a:lnT w="6350" cap="flat" cmpd="sng" algn="ctr">
-                      <a:solidFill>
-                        <a:srgbClr val="E2E8F0"/>
-                      </a:solidFill>
-                      <a:prstDash val="solid"/>
-                      <a:round/>
-                      <a:headEnd type="none" w="med" len="med"/>
-                      <a:tailEnd type="none" w="med" len="med"/>
-                    </a:lnT>
-                    <a:lnB w="6350" cap="flat" cmpd="sng" algn="ctr">
-                      <a:solidFill>
-                        <a:srgbClr val="E2E8F0"/>
-                      </a:solidFill>
-                      <a:prstDash val="solid"/>
-                      <a:round/>
-                      <a:headEnd type="none" w="med" len="med"/>
-                      <a:tailEnd type="none" w="med" len="med"/>
-                    </a:lnB>
-                    <a:solidFill>
-                      <a:srgbClr val="FFFFFF"/>
-                    </a:solidFill>
-                  </a:tcPr>
-                </a:tc>
-                <a:tc>
-                  <a:txBody>
-                    <a:bodyPr/>
-                    <a:lstStyle/>
-                    <a:p>
-                      <a:pPr algn="l" indent="0" marL="0">
-                        <a:buNone/>
-                      </a:pPr>
-                      <a:r>
-                        <a:rPr lang="en-US" sz="1150" dirty="0">
-                          <a:solidFill>
-                            <a:srgbClr val="0F172A"/>
-                          </a:solidFill>
-                          <a:latin typeface="Calibri" pitchFamily="34" charset="0"/>
-                          <a:ea typeface="Calibri" pitchFamily="34" charset="-122"/>
-                          <a:cs typeface="Calibri" pitchFamily="34" charset="-120"/>
-                        </a:rPr>
-                        <a:t>Höhe für Robustness Check (Confounder)</a:t>
-                      </a:r>
-                      <a:endParaRPr lang="en-US" sz="1150" dirty="0">
-                        <a:latin typeface="Calibri" charset="0"/>
-                        <a:ea typeface="Calibri" charset="0"/>
-                        <a:cs typeface="Calibri" charset="0"/>
-                      </a:endParaRPr>
-                    </a:p>
-                  </a:txBody>
-                  <a:tcPr marL="91440" marR="91440" marT="45720" marB="45720">
-                    <a:lnL w="6350" cap="flat" cmpd="sng" algn="ctr">
-                      <a:solidFill>
-                        <a:srgbClr val="E2E8F0"/>
-                      </a:solidFill>
-                      <a:prstDash val="solid"/>
-                      <a:round/>
-                      <a:headEnd type="none" w="med" len="med"/>
-                      <a:tailEnd type="none" w="med" len="med"/>
-                    </a:lnL>
-                    <a:lnR w="6350" cap="flat" cmpd="sng" algn="ctr">
-                      <a:solidFill>
-                        <a:srgbClr val="E2E8F0"/>
-                      </a:solidFill>
-                      <a:prstDash val="solid"/>
-                      <a:round/>
-                      <a:headEnd type="none" w="med" len="med"/>
-                      <a:tailEnd type="none" w="med" len="med"/>
-                    </a:lnR>
-                    <a:lnT w="6350" cap="flat" cmpd="sng" algn="ctr">
-                      <a:solidFill>
-                        <a:srgbClr val="E2E8F0"/>
-                      </a:solidFill>
-                      <a:prstDash val="solid"/>
-                      <a:round/>
-                      <a:headEnd type="none" w="med" len="med"/>
-                      <a:tailEnd type="none" w="med" len="med"/>
-                    </a:lnT>
-                    <a:lnB w="6350" cap="flat" cmpd="sng" algn="ctr">
-                      <a:solidFill>
-                        <a:srgbClr val="E2E8F0"/>
-                      </a:solidFill>
-                      <a:prstDash val="solid"/>
-                      <a:round/>
-                      <a:headEnd type="none" w="med" len="med"/>
-                      <a:tailEnd type="none" w="med" len="med"/>
-                    </a:lnB>
-                    <a:solidFill>
-                      <a:srgbClr val="FFFFFF"/>
-                    </a:solidFill>
-                  </a:tcPr>
-                </a:tc>
-                <a:tc>
-                  <a:txBody>
-                    <a:bodyPr/>
-                    <a:lstStyle/>
-                    <a:p>
-                      <a:pPr algn="l" indent="0" marL="0">
-                        <a:buNone/>
-                      </a:pPr>
-                      <a:r>
-                        <a:rPr lang="en-US" sz="1150" dirty="0">
-                          <a:solidFill>
-                            <a:srgbClr val="0F172A"/>
-                          </a:solidFill>
-                          <a:latin typeface="Calibri" pitchFamily="34" charset="0"/>
-                          <a:ea typeface="Calibri" pitchFamily="34" charset="-122"/>
-                          <a:cs typeface="Calibri" pitchFamily="34" charset="-120"/>
-                        </a:rPr>
-                        <a:t>CC0</a:t>
-                      </a:r>
-                      <a:endParaRPr lang="en-US" sz="1150" dirty="0">
-                        <a:latin typeface="Calibri" charset="0"/>
-                        <a:ea typeface="Calibri" charset="0"/>
-                        <a:cs typeface="Calibri" charset="0"/>
-                      </a:endParaRPr>
-                    </a:p>
-                  </a:txBody>
-                  <a:tcPr marL="91440" marR="91440" marT="45720" marB="45720">
-                    <a:lnL w="6350" cap="flat" cmpd="sng" algn="ctr">
-                      <a:solidFill>
-                        <a:srgbClr val="E2E8F0"/>
-                      </a:solidFill>
-                      <a:prstDash val="solid"/>
-                      <a:round/>
-                      <a:headEnd type="none" w="med" len="med"/>
-                      <a:tailEnd type="none" w="med" len="med"/>
-                    </a:lnL>
-                    <a:lnR w="6350" cap="flat" cmpd="sng" algn="ctr">
-                      <a:solidFill>
-                        <a:srgbClr val="E2E8F0"/>
-                      </a:solidFill>
-                      <a:prstDash val="solid"/>
-                      <a:round/>
-                      <a:headEnd type="none" w="med" len="med"/>
-                      <a:tailEnd type="none" w="med" len="med"/>
-                    </a:lnR>
-                    <a:lnT w="6350" cap="flat" cmpd="sng" algn="ctr">
-                      <a:solidFill>
-                        <a:srgbClr val="E2E8F0"/>
-                      </a:solidFill>
-                      <a:prstDash val="solid"/>
-                      <a:round/>
-                      <a:headEnd type="none" w="med" len="med"/>
-                      <a:tailEnd type="none" w="med" len="med"/>
-                    </a:lnT>
-                    <a:lnB w="6350" cap="flat" cmpd="sng" algn="ctr">
-                      <a:solidFill>
-                        <a:srgbClr val="E2E8F0"/>
-                      </a:solidFill>
-                      <a:prstDash val="solid"/>
-                      <a:round/>
-                      <a:headEnd type="none" w="med" len="med"/>
-                      <a:tailEnd type="none" w="med" len="med"/>
-                    </a:lnB>
-                    <a:solidFill>
-                      <a:srgbClr val="FFFFFF"/>
-                    </a:solidFill>
-                  </a:tcPr>
-                </a:tc>
-              </a:tr>
-              <a:tr h="384048">
-                <a:tc>
-                  <a:txBody>
-                    <a:bodyPr/>
-                    <a:lstStyle/>
-                    <a:p>
-                      <a:pPr algn="l" indent="0" marL="0">
-                        <a:buNone/>
-                      </a:pPr>
-                      <a:r>
-                        <a:rPr lang="en-US" sz="1150" dirty="0">
-                          <a:solidFill>
-                            <a:srgbClr val="0F172A"/>
-                          </a:solidFill>
-                          <a:latin typeface="Calibri" pitchFamily="34" charset="0"/>
-                          <a:ea typeface="Calibri" pitchFamily="34" charset="-122"/>
-                          <a:cs typeface="Calibri" pitchFamily="34" charset="-120"/>
-                        </a:rPr>
-                        <a:t>swisstopo / GeoAdmin</a:t>
-                      </a:r>
-                      <a:endParaRPr lang="en-US" sz="1150" dirty="0">
-                        <a:latin typeface="Calibri" charset="0"/>
-                        <a:ea typeface="Calibri" charset="0"/>
-                        <a:cs typeface="Calibri" charset="0"/>
-                      </a:endParaRPr>
-                    </a:p>
-                  </a:txBody>
-                  <a:tcPr marL="91440" marR="91440" marT="45720" marB="45720">
-                    <a:lnL w="6350" cap="flat" cmpd="sng" algn="ctr">
-                      <a:solidFill>
-                        <a:srgbClr val="E2E8F0"/>
-                      </a:solidFill>
-                      <a:prstDash val="solid"/>
-                      <a:round/>
-                      <a:headEnd type="none" w="med" len="med"/>
-                      <a:tailEnd type="none" w="med" len="med"/>
-                    </a:lnL>
-                    <a:lnR w="6350" cap="flat" cmpd="sng" algn="ctr">
-                      <a:solidFill>
-                        <a:srgbClr val="E2E8F0"/>
-                      </a:solidFill>
-                      <a:prstDash val="solid"/>
-                      <a:round/>
-                      <a:headEnd type="none" w="med" len="med"/>
-                      <a:tailEnd type="none" w="med" len="med"/>
-                    </a:lnR>
-                    <a:lnT w="6350" cap="flat" cmpd="sng" algn="ctr">
-                      <a:solidFill>
-                        <a:srgbClr val="E2E8F0"/>
-                      </a:solidFill>
-                      <a:prstDash val="solid"/>
-                      <a:round/>
-                      <a:headEnd type="none" w="med" len="med"/>
-                      <a:tailEnd type="none" w="med" len="med"/>
-                    </a:lnT>
-                    <a:lnB w="6350" cap="flat" cmpd="sng" algn="ctr">
-                      <a:solidFill>
-                        <a:srgbClr val="E2E8F0"/>
-                      </a:solidFill>
-                      <a:prstDash val="solid"/>
-                      <a:round/>
-                      <a:headEnd type="none" w="med" len="med"/>
-                      <a:tailEnd type="none" w="med" len="med"/>
-                    </a:lnB>
-                    <a:solidFill>
-                      <a:srgbClr val="FFFFFF"/>
-                    </a:solidFill>
-                  </a:tcPr>
-                </a:tc>
-                <a:tc>
-                  <a:txBody>
-                    <a:bodyPr/>
-                    <a:lstStyle/>
-                    <a:p>
-                      <a:pPr algn="l" indent="0" marL="0">
-                        <a:buNone/>
-                      </a:pPr>
-                      <a:r>
-                        <a:rPr lang="en-US" sz="1150" dirty="0">
-                          <a:solidFill>
-                            <a:srgbClr val="0F172A"/>
-                          </a:solidFill>
-                          <a:latin typeface="Calibri" pitchFamily="34" charset="0"/>
-                          <a:ea typeface="Calibri" pitchFamily="34" charset="-122"/>
-                          <a:cs typeface="Calibri" pitchFamily="34" charset="-120"/>
-                        </a:rPr>
-                        <a:t>Hintergrundkarten (Folium-Tiles)</a:t>
-                      </a:r>
-                      <a:endParaRPr lang="en-US" sz="1150" dirty="0">
-                        <a:latin typeface="Calibri" charset="0"/>
-                        <a:ea typeface="Calibri" charset="0"/>
-                        <a:cs typeface="Calibri" charset="0"/>
-                      </a:endParaRPr>
-                    </a:p>
-                  </a:txBody>
-                  <a:tcPr marL="91440" marR="91440" marT="45720" marB="45720">
-                    <a:lnL w="6350" cap="flat" cmpd="sng" algn="ctr">
-                      <a:solidFill>
-                        <a:srgbClr val="E2E8F0"/>
-                      </a:solidFill>
-                      <a:prstDash val="solid"/>
-                      <a:round/>
-                      <a:headEnd type="none" w="med" len="med"/>
-                      <a:tailEnd type="none" w="med" len="med"/>
-                    </a:lnL>
-                    <a:lnR w="6350" cap="flat" cmpd="sng" algn="ctr">
-                      <a:solidFill>
-                        <a:srgbClr val="E2E8F0"/>
-                      </a:solidFill>
-                      <a:prstDash val="solid"/>
-                      <a:round/>
-                      <a:headEnd type="none" w="med" len="med"/>
-                      <a:tailEnd type="none" w="med" len="med"/>
-                    </a:lnR>
-                    <a:lnT w="6350" cap="flat" cmpd="sng" algn="ctr">
-                      <a:solidFill>
-                        <a:srgbClr val="E2E8F0"/>
-                      </a:solidFill>
-                      <a:prstDash val="solid"/>
-                      <a:round/>
-                      <a:headEnd type="none" w="med" len="med"/>
-                      <a:tailEnd type="none" w="med" len="med"/>
-                    </a:lnT>
-                    <a:lnB w="6350" cap="flat" cmpd="sng" algn="ctr">
-                      <a:solidFill>
-                        <a:srgbClr val="E2E8F0"/>
-                      </a:solidFill>
-                      <a:prstDash val="solid"/>
-                      <a:round/>
-                      <a:headEnd type="none" w="med" len="med"/>
-                      <a:tailEnd type="none" w="med" len="med"/>
-                    </a:lnB>
-                    <a:solidFill>
-                      <a:srgbClr val="FFFFFF"/>
-                    </a:solidFill>
-                  </a:tcPr>
-                </a:tc>
-                <a:tc>
-                  <a:txBody>
-                    <a:bodyPr/>
-                    <a:lstStyle/>
-                    <a:p>
-                      <a:pPr algn="l" indent="0" marL="0">
-                        <a:buNone/>
-                      </a:pPr>
-                      <a:r>
-                        <a:rPr lang="en-US" sz="1150" dirty="0">
-                          <a:solidFill>
-                            <a:srgbClr val="0F172A"/>
-                          </a:solidFill>
-                          <a:latin typeface="Calibri" pitchFamily="34" charset="0"/>
-                          <a:ea typeface="Calibri" pitchFamily="34" charset="-122"/>
-                          <a:cs typeface="Calibri" pitchFamily="34" charset="-120"/>
-                        </a:rPr>
-                        <a:t>swisstopo Terms</a:t>
                       </a:r>
                       <a:endParaRPr lang="en-US" sz="1150" dirty="0">
                         <a:latin typeface="Calibri" charset="0"/>

</xml_diff>

<commit_message>
consistency: standardize hex-mean (n=744, mean=29.5) vs quartier-mean (n=34, mean=46.9) labels everywhere
After full red-thread audit:

* NB05 cell 11 print: 'Mittlerer Score (Stadt Zuerich)' -> 'Hex-Cell-Mittel (n=744)' clearly distinguishes hex-level aggregation

* NB06 cell 20 print + write: 'Mittlerer Score' / 'Stadt-Mittelwert' -> 'Quartier-Mittel (n=34)' incl. intro-paragraph in echte_zahlen.md explaining hex vs quartier

* NB05 §7 zusammenfassung: explicit hex-mean 29.5 + cross-ref to NB06 quartier-mean 47

* presenter_notes Slide 11 sprechertext: 'Range 8 bis 93' (quartier-range stale) -> 'Hex-Range 0-94, Median 23, Mean 30'

* ki_einsatz.md: stale '12 000 Zellen x 4 500 POIs' -> 744 x 8092; '1000 vs 12000 Dijkstras' rephrased

Audit script confirms zero stale numbers across 9 NBs + 5 docs + 4 reports + slides
</commit_message>
<xml_diff>
--- a/reports/zh15min_slides.pptx
+++ b/reports/zh15min_slides.pptx
@@ -6053,7 +6053,7 @@
                 <a:ea typeface="Trebuchet MS" pitchFamily="34" charset="-122"/>
                 <a:cs typeface="Trebuchet MS" pitchFamily="34" charset="-120"/>
               </a:rPr>
-              <a:t>Hypothesen-Test</a:t>
+              <a:t>Hypothesen-Test — H1, H1a, H2</a:t>
             </a:r>
             <a:endParaRPr lang="en-US" sz="3000" dirty="0"/>
           </a:p>
@@ -6067,8 +6067,8 @@
         </p:nvSpPr>
         <p:spPr>
           <a:xfrm>
-            <a:off x="457200" y="1508760"/>
-            <a:ext cx="4114800" cy="3108960"/>
+            <a:off x="365760" y="1417320"/>
+            <a:ext cx="2743200" cy="3246120"/>
           </a:xfrm>
           <a:prstGeom prst="rect">
             <a:avLst/>
@@ -6099,8 +6099,8 @@
         </p:nvSpPr>
         <p:spPr>
           <a:xfrm>
-            <a:off x="457200" y="1508760"/>
-            <a:ext cx="4114800" cy="54864"/>
+            <a:off x="365760" y="1417320"/>
+            <a:ext cx="2743200" cy="54864"/>
           </a:xfrm>
           <a:prstGeom prst="rect">
             <a:avLst/>
@@ -6124,24 +6124,24 @@
         </p:nvSpPr>
         <p:spPr>
           <a:xfrm>
-            <a:off x="640080" y="1691640"/>
-            <a:ext cx="3749040" cy="365760"/>
-          </a:xfrm>
-          <a:prstGeom prst="rect">
-            <a:avLst/>
-          </a:prstGeom>
-          <a:noFill/>
-          <a:ln/>
-        </p:spPr>
-        <p:txBody>
-          <a:bodyPr wrap="square" lIns="0" tIns="0" rIns="0" bIns="0" rtlCol="0" anchor="ctr"/>
-          <a:lstStyle/>
-          <a:p>
-            <a:pPr indent="0" marL="0">
-              <a:buNone/>
-            </a:pPr>
-            <a:r>
-              <a:rPr lang="en-US" sz="1600" b="1" dirty="0">
+            <a:off x="502920" y="1572768"/>
+            <a:ext cx="2468880" cy="320040"/>
+          </a:xfrm>
+          <a:prstGeom prst="rect">
+            <a:avLst/>
+          </a:prstGeom>
+          <a:noFill/>
+          <a:ln/>
+        </p:spPr>
+        <p:txBody>
+          <a:bodyPr wrap="square" lIns="0" tIns="0" rIns="0" bIns="0" rtlCol="0" anchor="ctr"/>
+          <a:lstStyle/>
+          <a:p>
+            <a:pPr indent="0" marL="0">
+              <a:buNone/>
+            </a:pPr>
+            <a:r>
+              <a:rPr lang="en-US" sz="1200" b="1" dirty="0">
                 <a:solidFill>
                   <a:srgbClr val="065A82"/>
                 </a:solidFill>
@@ -6149,9 +6149,9 @@
                 <a:ea typeface="Trebuchet MS" pitchFamily="34" charset="-122"/>
                 <a:cs typeface="Trebuchet MS" pitchFamily="34" charset="-120"/>
               </a:rPr>
-              <a:t>H1 — Score ↔ Zentralität</a:t>
-            </a:r>
-            <a:endParaRPr lang="en-US" sz="1600" dirty="0"/>
+              <a:t>H1 — Score ↔ Mietpreis</a:t>
+            </a:r>
+            <a:endParaRPr lang="en-US" sz="1200" dirty="0"/>
           </a:p>
         </p:txBody>
       </p:sp>
@@ -6163,8 +6163,8 @@
         </p:nvSpPr>
         <p:spPr>
           <a:xfrm>
-            <a:off x="457200" y="2240280"/>
-            <a:ext cx="4114800" cy="594360"/>
+            <a:off x="365760" y="1993392"/>
+            <a:ext cx="2743200" cy="534924"/>
           </a:xfrm>
           <a:prstGeom prst="rect">
             <a:avLst/>
@@ -6188,7 +6188,7 @@
                 <a:ea typeface="Trebuchet MS" pitchFamily="34" charset="-122"/>
                 <a:cs typeface="Trebuchet MS" pitchFamily="34" charset="-120"/>
               </a:rPr>
-              <a:t>ρ = −0.81</a:t>
+              <a:t>ρ = +0.56</a:t>
             </a:r>
             <a:endParaRPr lang="en-US" sz="4400" dirty="0"/>
           </a:p>
@@ -6202,8 +6202,8 @@
         </p:nvSpPr>
         <p:spPr>
           <a:xfrm>
-            <a:off x="457200" y="2834640"/>
-            <a:ext cx="4114800" cy="320040"/>
+            <a:off x="365760" y="2528316"/>
+            <a:ext cx="2743200" cy="288036"/>
           </a:xfrm>
           <a:prstGeom prst="rect">
             <a:avLst/>
@@ -6227,7 +6227,7 @@
                 <a:ea typeface="Calibri" pitchFamily="34" charset="-122"/>
                 <a:cs typeface="Calibri" pitchFamily="34" charset="-120"/>
               </a:rPr>
-              <a:t>Spearman, n = 34, p &lt; 10⁻⁸</a:t>
+              <a:t>Spearman, n=34, p&lt;10⁻³</a:t>
             </a:r>
             <a:endParaRPr lang="en-US" sz="1100" dirty="0"/>
           </a:p>
@@ -6241,24 +6241,24 @@
         </p:nvSpPr>
         <p:spPr>
           <a:xfrm>
-            <a:off x="640080" y="3291840"/>
-            <a:ext cx="3749040" cy="1188720"/>
-          </a:xfrm>
-          <a:prstGeom prst="rect">
-            <a:avLst/>
-          </a:prstGeom>
-          <a:noFill/>
-          <a:ln/>
-        </p:spPr>
-        <p:txBody>
-          <a:bodyPr wrap="square" lIns="0" tIns="0" rIns="0" bIns="0" rtlCol="0" anchor="ctr"/>
-          <a:lstStyle/>
-          <a:p>
-            <a:pPr indent="0" marL="0">
-              <a:buNone/>
-            </a:pPr>
-            <a:r>
-              <a:rPr lang="en-US" sz="1100" dirty="0">
+            <a:off x="502920" y="2907792"/>
+            <a:ext cx="2468880" cy="1691640"/>
+          </a:xfrm>
+          <a:prstGeom prst="rect">
+            <a:avLst/>
+          </a:prstGeom>
+          <a:noFill/>
+          <a:ln/>
+        </p:spPr>
+        <p:txBody>
+          <a:bodyPr wrap="square" lIns="0" tIns="0" rIns="0" bIns="0" rtlCol="0" anchor="ctr"/>
+          <a:lstStyle/>
+          <a:p>
+            <a:pPr indent="0" marL="0">
+              <a:buNone/>
+            </a:pPr>
+            <a:r>
+              <a:rPr lang="en-US" sz="950" dirty="0">
                 <a:solidFill>
                   <a:srgbClr val="0F172A"/>
                 </a:solidFill>
@@ -6266,9 +6266,9 @@
                 <a:ea typeface="Calibri" pitchFamily="34" charset="-122"/>
                 <a:cs typeface="Calibri" pitchFamily="34" charset="-120"/>
               </a:rPr>
-              <a:t>Stützt H1 hochsignifikant: je weiter vom HB, desto niedriger der Score. Pearson r = −0.84 mit p &lt; 10⁻⁹. Zusatz-Test mit Stadt-Zürich-Mietpreisen 2024 ist jetzt ebenfalls signifikant (ρ = +0.56, p &lt; 0.001) — Konvergenz beider Validierungen.</a:t>
-            </a:r>
-            <a:endParaRPr lang="en-US" sz="1100" dirty="0"/>
+              <a:t>Stützt H1: höherer Score ↔ höherer Median-Mietpreis (Pearson r = +0.56, p ≈ 5·10⁻⁴). Lindenhof, Rathaus mit hohen Score- UND hohen Miet-Werten; Leimbach, Witikon mit beiden tief.</a:t>
+            </a:r>
+            <a:endParaRPr lang="en-US" sz="950" dirty="0"/>
           </a:p>
         </p:txBody>
       </p:sp>
@@ -6280,8 +6280,8 @@
         </p:nvSpPr>
         <p:spPr>
           <a:xfrm>
-            <a:off x="4617720" y="1508760"/>
-            <a:ext cx="4114800" cy="3108960"/>
+            <a:off x="3200400" y="1417320"/>
+            <a:ext cx="2743200" cy="3246120"/>
           </a:xfrm>
           <a:prstGeom prst="rect">
             <a:avLst/>
@@ -6312,8 +6312,221 @@
         </p:nvSpPr>
         <p:spPr>
           <a:xfrm>
-            <a:off x="4617720" y="1508760"/>
-            <a:ext cx="4114800" cy="54864"/>
+            <a:off x="3200400" y="1417320"/>
+            <a:ext cx="2743200" cy="54864"/>
+          </a:xfrm>
+          <a:prstGeom prst="rect">
+            <a:avLst/>
+          </a:prstGeom>
+          <a:solidFill>
+            <a:srgbClr val="1C7293"/>
+          </a:solidFill>
+          <a:ln w="12700">
+            <a:solidFill>
+              <a:srgbClr val="1C7293"/>
+            </a:solidFill>
+            <a:prstDash val="solid"/>
+          </a:ln>
+        </p:spPr>
+      </p:sp>
+      <p:sp>
+        <p:nvSpPr>
+          <p:cNvPr id="12" name="Text 10"/>
+          <p:cNvSpPr/>
+          <p:nvPr/>
+        </p:nvSpPr>
+        <p:spPr>
+          <a:xfrm>
+            <a:off x="3337560" y="1572768"/>
+            <a:ext cx="2468880" cy="320040"/>
+          </a:xfrm>
+          <a:prstGeom prst="rect">
+            <a:avLst/>
+          </a:prstGeom>
+          <a:noFill/>
+          <a:ln/>
+        </p:spPr>
+        <p:txBody>
+          <a:bodyPr wrap="square" lIns="0" tIns="0" rIns="0" bIns="0" rtlCol="0" anchor="ctr"/>
+          <a:lstStyle/>
+          <a:p>
+            <a:pPr indent="0" marL="0">
+              <a:buNone/>
+            </a:pPr>
+            <a:r>
+              <a:rPr lang="en-US" sz="1200" b="1" dirty="0">
+                <a:solidFill>
+                  <a:srgbClr val="1C7293"/>
+                </a:solidFill>
+                <a:latin typeface="Trebuchet MS" pitchFamily="34" charset="0"/>
+                <a:ea typeface="Trebuchet MS" pitchFamily="34" charset="-122"/>
+                <a:cs typeface="Trebuchet MS" pitchFamily="34" charset="-120"/>
+              </a:rPr>
+              <a:t>H1a — Score ↔ HB-Distanz</a:t>
+            </a:r>
+            <a:endParaRPr lang="en-US" sz="1200" dirty="0"/>
+          </a:p>
+        </p:txBody>
+      </p:sp>
+      <p:sp>
+        <p:nvSpPr>
+          <p:cNvPr id="13" name="Text 11"/>
+          <p:cNvSpPr/>
+          <p:nvPr/>
+        </p:nvSpPr>
+        <p:spPr>
+          <a:xfrm>
+            <a:off x="3200400" y="1993392"/>
+            <a:ext cx="2743200" cy="534924"/>
+          </a:xfrm>
+          <a:prstGeom prst="rect">
+            <a:avLst/>
+          </a:prstGeom>
+          <a:noFill/>
+          <a:ln/>
+        </p:spPr>
+        <p:txBody>
+          <a:bodyPr wrap="square" lIns="0" tIns="0" rIns="0" bIns="0" rtlCol="0" anchor="b"/>
+          <a:lstStyle/>
+          <a:p>
+            <a:pPr algn="ctr" indent="0" marL="0">
+              <a:buNone/>
+            </a:pPr>
+            <a:r>
+              <a:rPr lang="en-US" sz="4400" b="1" dirty="0">
+                <a:solidFill>
+                  <a:srgbClr val="1C7293"/>
+                </a:solidFill>
+                <a:latin typeface="Trebuchet MS" pitchFamily="34" charset="0"/>
+                <a:ea typeface="Trebuchet MS" pitchFamily="34" charset="-122"/>
+                <a:cs typeface="Trebuchet MS" pitchFamily="34" charset="-120"/>
+              </a:rPr>
+              <a:t>ρ = −0.81</a:t>
+            </a:r>
+            <a:endParaRPr lang="en-US" sz="4400" dirty="0"/>
+          </a:p>
+        </p:txBody>
+      </p:sp>
+      <p:sp>
+        <p:nvSpPr>
+          <p:cNvPr id="14" name="Text 12"/>
+          <p:cNvSpPr/>
+          <p:nvPr/>
+        </p:nvSpPr>
+        <p:spPr>
+          <a:xfrm>
+            <a:off x="3200400" y="2528316"/>
+            <a:ext cx="2743200" cy="288036"/>
+          </a:xfrm>
+          <a:prstGeom prst="rect">
+            <a:avLst/>
+          </a:prstGeom>
+          <a:noFill/>
+          <a:ln/>
+        </p:spPr>
+        <p:txBody>
+          <a:bodyPr wrap="square" lIns="0" tIns="0" rIns="0" bIns="0" rtlCol="0" anchor="t"/>
+          <a:lstStyle/>
+          <a:p>
+            <a:pPr algn="ctr" indent="0" marL="0">
+              <a:buNone/>
+            </a:pPr>
+            <a:r>
+              <a:rPr lang="en-US" sz="1100" dirty="0">
+                <a:solidFill>
+                  <a:srgbClr val="64748B"/>
+                </a:solidFill>
+                <a:latin typeface="Calibri" pitchFamily="34" charset="0"/>
+                <a:ea typeface="Calibri" pitchFamily="34" charset="-122"/>
+                <a:cs typeface="Calibri" pitchFamily="34" charset="-120"/>
+              </a:rPr>
+              <a:t>Spearman, n=34, p&lt;10⁻⁸</a:t>
+            </a:r>
+            <a:endParaRPr lang="en-US" sz="1100" dirty="0"/>
+          </a:p>
+        </p:txBody>
+      </p:sp>
+      <p:sp>
+        <p:nvSpPr>
+          <p:cNvPr id="15" name="Text 13"/>
+          <p:cNvSpPr/>
+          <p:nvPr/>
+        </p:nvSpPr>
+        <p:spPr>
+          <a:xfrm>
+            <a:off x="3337560" y="2907792"/>
+            <a:ext cx="2468880" cy="1691640"/>
+          </a:xfrm>
+          <a:prstGeom prst="rect">
+            <a:avLst/>
+          </a:prstGeom>
+          <a:noFill/>
+          <a:ln/>
+        </p:spPr>
+        <p:txBody>
+          <a:bodyPr wrap="square" lIns="0" tIns="0" rIns="0" bIns="0" rtlCol="0" anchor="ctr"/>
+          <a:lstStyle/>
+          <a:p>
+            <a:pPr indent="0" marL="0">
+              <a:buNone/>
+            </a:pPr>
+            <a:r>
+              <a:rPr lang="en-US" sz="950" dirty="0">
+                <a:solidFill>
+                  <a:srgbClr val="0F172A"/>
+                </a:solidFill>
+                <a:latin typeface="Calibri" pitchFamily="34" charset="0"/>
+                <a:ea typeface="Calibri" pitchFamily="34" charset="-122"/>
+                <a:cs typeface="Calibri" pitchFamily="34" charset="-120"/>
+              </a:rPr>
+              <a:t>Stützt H1a hochsignifikant: je weiter vom HB, desto niedriger der Score. Pearson r = −0.84, p &lt; 10⁻⁹. Konvergenz beider H1-Tests bestätigt das Zentralitäts-Muster ohne Markt-Confounder.</a:t>
+            </a:r>
+            <a:endParaRPr lang="en-US" sz="950" dirty="0"/>
+          </a:p>
+        </p:txBody>
+      </p:sp>
+      <p:sp>
+        <p:nvSpPr>
+          <p:cNvPr id="16" name="Shape 14"/>
+          <p:cNvSpPr/>
+          <p:nvPr/>
+        </p:nvSpPr>
+        <p:spPr>
+          <a:xfrm>
+            <a:off x="6035040" y="1417320"/>
+            <a:ext cx="2743200" cy="3246120"/>
+          </a:xfrm>
+          <a:prstGeom prst="rect">
+            <a:avLst/>
+          </a:prstGeom>
+          <a:solidFill>
+            <a:srgbClr val="FFFFFF"/>
+          </a:solidFill>
+          <a:ln w="9525">
+            <a:solidFill>
+              <a:srgbClr val="E2E8F0"/>
+            </a:solidFill>
+            <a:prstDash val="solid"/>
+          </a:ln>
+          <a:effectLst>
+            <a:outerShdw sx="100000" sy="100000" kx="0" ky="0" algn="bl" rotWithShape="0" blurRad="101600" dist="12700" dir="5400000">
+              <a:srgbClr val="94A3B8">
+                <a:alpha val="12000"/>
+              </a:srgbClr>
+            </a:outerShdw>
+          </a:effectLst>
+        </p:spPr>
+      </p:sp>
+      <p:sp>
+        <p:nvSpPr>
+          <p:cNvPr id="17" name="Shape 15"/>
+          <p:cNvSpPr/>
+          <p:nvPr/>
+        </p:nvSpPr>
+        <p:spPr>
+          <a:xfrm>
+            <a:off x="6035040" y="1417320"/>
+            <a:ext cx="2743200" cy="54864"/>
           </a:xfrm>
           <a:prstGeom prst="rect">
             <a:avLst/>
@@ -6331,30 +6544,30 @@
       </p:sp>
       <p:sp>
         <p:nvSpPr>
-          <p:cNvPr id="12" name="Text 10"/>
-          <p:cNvSpPr/>
-          <p:nvPr/>
-        </p:nvSpPr>
-        <p:spPr>
-          <a:xfrm>
-            <a:off x="4800600" y="1691640"/>
-            <a:ext cx="3749040" cy="365760"/>
-          </a:xfrm>
-          <a:prstGeom prst="rect">
-            <a:avLst/>
-          </a:prstGeom>
-          <a:noFill/>
-          <a:ln/>
-        </p:spPr>
-        <p:txBody>
-          <a:bodyPr wrap="square" lIns="0" tIns="0" rIns="0" bIns="0" rtlCol="0" anchor="ctr"/>
-          <a:lstStyle/>
-          <a:p>
-            <a:pPr indent="0" marL="0">
-              <a:buNone/>
-            </a:pPr>
-            <a:r>
-              <a:rPr lang="en-US" sz="1600" b="1" dirty="0">
+          <p:cNvPr id="18" name="Text 16"/>
+          <p:cNvSpPr/>
+          <p:nvPr/>
+        </p:nvSpPr>
+        <p:spPr>
+          <a:xfrm>
+            <a:off x="6172200" y="1572768"/>
+            <a:ext cx="2468880" cy="320040"/>
+          </a:xfrm>
+          <a:prstGeom prst="rect">
+            <a:avLst/>
+          </a:prstGeom>
+          <a:noFill/>
+          <a:ln/>
+        </p:spPr>
+        <p:txBody>
+          <a:bodyPr wrap="square" lIns="0" tIns="0" rIns="0" bIns="0" rtlCol="0" anchor="ctr"/>
+          <a:lstStyle/>
+          <a:p>
+            <a:pPr indent="0" marL="0">
+              <a:buNone/>
+            </a:pPr>
+            <a:r>
+              <a:rPr lang="en-US" sz="1200" b="1" dirty="0">
                 <a:solidFill>
                   <a:srgbClr val="1A9850"/>
                 </a:solidFill>
@@ -6364,20 +6577,20 @@
               </a:rPr>
               <a:t>H2 — Wüsteneffekt widerlegt</a:t>
             </a:r>
-            <a:endParaRPr lang="en-US" sz="1600" dirty="0"/>
-          </a:p>
-        </p:txBody>
-      </p:sp>
-      <p:sp>
-        <p:nvSpPr>
-          <p:cNvPr id="13" name="Text 11"/>
-          <p:cNvSpPr/>
-          <p:nvPr/>
-        </p:nvSpPr>
-        <p:spPr>
-          <a:xfrm>
-            <a:off x="4617720" y="2240280"/>
-            <a:ext cx="4114800" cy="594360"/>
+            <a:endParaRPr lang="en-US" sz="1200" dirty="0"/>
+          </a:p>
+        </p:txBody>
+      </p:sp>
+      <p:sp>
+        <p:nvSpPr>
+          <p:cNvPr id="19" name="Text 17"/>
+          <p:cNvSpPr/>
+          <p:nvPr/>
+        </p:nvSpPr>
+        <p:spPr>
+          <a:xfrm>
+            <a:off x="6035040" y="1993392"/>
+            <a:ext cx="2743200" cy="534924"/>
           </a:xfrm>
           <a:prstGeom prst="rect">
             <a:avLst/>
@@ -6409,14 +6622,14 @@
       </p:sp>
       <p:sp>
         <p:nvSpPr>
-          <p:cNvPr id="14" name="Text 12"/>
-          <p:cNvSpPr/>
-          <p:nvPr/>
-        </p:nvSpPr>
-        <p:spPr>
-          <a:xfrm>
-            <a:off x="4617720" y="2834640"/>
-            <a:ext cx="4114800" cy="320040"/>
+          <p:cNvPr id="20" name="Text 18"/>
+          <p:cNvSpPr/>
+          <p:nvPr/>
+        </p:nvSpPr>
+        <p:spPr>
+          <a:xfrm>
+            <a:off x="6035040" y="2528316"/>
+            <a:ext cx="2743200" cy="288036"/>
           </a:xfrm>
           <a:prstGeom prst="rect">
             <a:avLst/>
@@ -6440,7 +6653,7 @@
                 <a:ea typeface="Calibri" pitchFamily="34" charset="-122"/>
                 <a:cs typeface="Calibri" pitchFamily="34" charset="-120"/>
               </a:rPr>
-              <a:t>Quartiere mit Dichte &gt; P75 UND Score-P25 ≤ P25</a:t>
+              <a:t>Dichte &gt; P75 ∧ Score-P25 ≤ P25</a:t>
             </a:r>
             <a:endParaRPr lang="en-US" sz="1100" dirty="0"/>
           </a:p>
@@ -6448,30 +6661,30 @@
       </p:sp>
       <p:sp>
         <p:nvSpPr>
-          <p:cNvPr id="15" name="Text 13"/>
-          <p:cNvSpPr/>
-          <p:nvPr/>
-        </p:nvSpPr>
-        <p:spPr>
-          <a:xfrm>
-            <a:off x="4800600" y="3291840"/>
-            <a:ext cx="3749040" cy="1188720"/>
-          </a:xfrm>
-          <a:prstGeom prst="rect">
-            <a:avLst/>
-          </a:prstGeom>
-          <a:noFill/>
-          <a:ln/>
-        </p:spPr>
-        <p:txBody>
-          <a:bodyPr wrap="square" lIns="0" tIns="0" rIns="0" bIns="0" rtlCol="0" anchor="ctr"/>
-          <a:lstStyle/>
-          <a:p>
-            <a:pPr indent="0" marL="0">
-              <a:buNone/>
-            </a:pPr>
-            <a:r>
-              <a:rPr lang="en-US" sz="1100" dirty="0">
+          <p:cNvPr id="21" name="Text 19"/>
+          <p:cNvSpPr/>
+          <p:nvPr/>
+        </p:nvSpPr>
+        <p:spPr>
+          <a:xfrm>
+            <a:off x="6172200" y="2907792"/>
+            <a:ext cx="2468880" cy="1691640"/>
+          </a:xfrm>
+          <a:prstGeom prst="rect">
+            <a:avLst/>
+          </a:prstGeom>
+          <a:noFill/>
+          <a:ln/>
+        </p:spPr>
+        <p:txBody>
+          <a:bodyPr wrap="square" lIns="0" tIns="0" rIns="0" bIns="0" rtlCol="0" anchor="ctr"/>
+          <a:lstStyle/>
+          <a:p>
+            <a:pPr indent="0" marL="0">
+              <a:buNone/>
+            </a:pPr>
+            <a:r>
+              <a:rPr lang="en-US" sz="950" dirty="0">
                 <a:solidFill>
                   <a:srgbClr val="0F172A"/>
                 </a:solidFill>
@@ -6479,15 +6692,15 @@
                 <a:ea typeface="Calibri" pitchFamily="34" charset="-122"/>
                 <a:cs typeface="Calibri" pitchFamily="34" charset="-120"/>
               </a:rPr>
-              <a:t>Quantitativer Test mit STATPOP-Bevölkerungsdichte: kein Quartier erfüllt beide Schwellen. Zürichs Stadtstruktur ist konsistent — keine US-typischen 'food deserts'. Periphere Quartiere haben tiefen Score (5 mit &lt; 20), aber dort wohnen auch wenige Menschen.</a:t>
-            </a:r>
-            <a:endParaRPr lang="en-US" sz="1100" dirty="0"/>
-          </a:p>
-        </p:txBody>
-      </p:sp>
-      <p:sp>
-        <p:nvSpPr>
-          <p:cNvPr id="16" name="Text 14"/>
+              <a:t>Kein Quartier erfüllt beide Schwellen. Zürichs Stadtstruktur ist konsistent — keine US-typischen 'food deserts'. Periphere Quartiere haben tiefen Score (5 &lt; 20), dort wohnen aber auch wenige Menschen.</a:t>
+            </a:r>
+            <a:endParaRPr lang="en-US" sz="950" dirty="0"/>
+          </a:p>
+        </p:txBody>
+      </p:sp>
+      <p:sp>
+        <p:nvSpPr>
+          <p:cNvPr id="22" name="Text 20"/>
           <p:cNvSpPr/>
           <p:nvPr/>
         </p:nvSpPr>
@@ -6526,7 +6739,7 @@
       </p:sp>
       <p:sp>
         <p:nvSpPr>
-          <p:cNvPr id="17" name="Text 15"/>
+          <p:cNvPr id="23" name="Text 21"/>
           <p:cNvSpPr/>
           <p:nvPr/>
         </p:nvSpPr>
@@ -11366,7 +11579,7 @@
                 <a:ea typeface="Calibri" pitchFamily="34" charset="-122"/>
                 <a:cs typeface="Calibri" pitchFamily="34" charset="-120"/>
               </a:rPr>
-              <a:t>Luftlinie vs. Strassennetz: r = 0.988.</a:t>
+              <a:t>Luftlinie vs. Strassennetz: r = 0.991.</a:t>
             </a:r>
             <a:endParaRPr lang="en-US" sz="1000" dirty="0"/>
           </a:p>
@@ -16286,7 +16499,7 @@
                 <a:ea typeface="Trebuchet MS" pitchFamily="34" charset="-122"/>
                 <a:cs typeface="Trebuchet MS" pitchFamily="34" charset="-120"/>
               </a:rPr>
-              <a:t>Zwei testbare Hypothesen</a:t>
+              <a:t>Drei testbare Hypothesen</a:t>
             </a:r>
             <a:endParaRPr lang="en-US" sz="3000" dirty="0"/>
           </a:p>
@@ -16300,8 +16513,8 @@
         </p:nvSpPr>
         <p:spPr>
           <a:xfrm>
-            <a:off x="457200" y="1554480"/>
-            <a:ext cx="8229600" cy="1280160"/>
+            <a:off x="457200" y="1463040"/>
+            <a:ext cx="8229600" cy="1005840"/>
           </a:xfrm>
           <a:prstGeom prst="rect">
             <a:avLst/>
@@ -16332,7 +16545,7 @@
         </p:nvSpPr>
         <p:spPr>
           <a:xfrm>
-            <a:off x="457200" y="1554480"/>
+            <a:off x="457200" y="1463040"/>
             <a:ext cx="8229600" cy="54864"/>
           </a:xfrm>
           <a:prstGeom prst="rect">
@@ -16357,8 +16570,8 @@
         </p:nvSpPr>
         <p:spPr>
           <a:xfrm>
-            <a:off x="640080" y="1810512"/>
-            <a:ext cx="777240" cy="777240"/>
+            <a:off x="640080" y="1627632"/>
+            <a:ext cx="685800" cy="685800"/>
           </a:xfrm>
           <a:prstGeom prst="ellipse">
             <a:avLst/>
@@ -16382,8 +16595,8 @@
         </p:nvSpPr>
         <p:spPr>
           <a:xfrm>
-            <a:off x="640080" y="1810512"/>
-            <a:ext cx="777240" cy="777240"/>
+            <a:off x="640080" y="1627632"/>
+            <a:ext cx="685800" cy="685800"/>
           </a:xfrm>
           <a:prstGeom prst="rect">
             <a:avLst/>
@@ -16399,7 +16612,7 @@
               <a:buNone/>
             </a:pPr>
             <a:r>
-              <a:rPr lang="en-US" sz="2200" b="1" dirty="0">
+              <a:rPr lang="en-US" sz="1800" b="1" dirty="0">
                 <a:solidFill>
                   <a:srgbClr val="FFFFFF"/>
                 </a:solidFill>
@@ -16409,7 +16622,7 @@
               </a:rPr>
               <a:t>H1</a:t>
             </a:r>
-            <a:endParaRPr lang="en-US" sz="2200" dirty="0"/>
+            <a:endParaRPr lang="en-US" sz="1800" dirty="0"/>
           </a:p>
         </p:txBody>
       </p:sp>
@@ -16421,24 +16634,24 @@
         </p:nvSpPr>
         <p:spPr>
           <a:xfrm>
-            <a:off x="1554480" y="1737360"/>
-            <a:ext cx="6949440" cy="365760"/>
-          </a:xfrm>
-          <a:prstGeom prst="rect">
-            <a:avLst/>
-          </a:prstGeom>
-          <a:noFill/>
-          <a:ln/>
-        </p:spPr>
-        <p:txBody>
-          <a:bodyPr wrap="square" lIns="0" tIns="0" rIns="0" bIns="0" rtlCol="0" anchor="ctr"/>
-          <a:lstStyle/>
-          <a:p>
-            <a:pPr indent="0" marL="0">
-              <a:buNone/>
-            </a:pPr>
-            <a:r>
-              <a:rPr lang="en-US" sz="1600" b="1" dirty="0">
+            <a:off x="1463040" y="1591056"/>
+            <a:ext cx="7040880" cy="292608"/>
+          </a:xfrm>
+          <a:prstGeom prst="rect">
+            <a:avLst/>
+          </a:prstGeom>
+          <a:noFill/>
+          <a:ln/>
+        </p:spPr>
+        <p:txBody>
+          <a:bodyPr wrap="square" lIns="0" tIns="0" rIns="0" bIns="0" rtlCol="0" anchor="ctr"/>
+          <a:lstStyle/>
+          <a:p>
+            <a:pPr indent="0" marL="0">
+              <a:buNone/>
+            </a:pPr>
+            <a:r>
+              <a:rPr lang="en-US" sz="1400" b="1" dirty="0">
                 <a:solidFill>
                   <a:srgbClr val="0F172A"/>
                 </a:solidFill>
@@ -16446,9 +16659,9 @@
                 <a:ea typeface="Trebuchet MS" pitchFamily="34" charset="-122"/>
                 <a:cs typeface="Trebuchet MS" pitchFamily="34" charset="-120"/>
               </a:rPr>
-              <a:t>Score korreliert mit Zentralität</a:t>
-            </a:r>
-            <a:endParaRPr lang="en-US" sz="1600" dirty="0"/>
+              <a:t>Score ↔ Mietpreis</a:t>
+            </a:r>
+            <a:endParaRPr lang="en-US" sz="1400" dirty="0"/>
           </a:p>
         </p:txBody>
       </p:sp>
@@ -16460,24 +16673,24 @@
         </p:nvSpPr>
         <p:spPr>
           <a:xfrm>
-            <a:off x="1554480" y="2103120"/>
-            <a:ext cx="6949440" cy="457200"/>
-          </a:xfrm>
-          <a:prstGeom prst="rect">
-            <a:avLst/>
-          </a:prstGeom>
-          <a:noFill/>
-          <a:ln/>
-        </p:spPr>
-        <p:txBody>
-          <a:bodyPr wrap="square" lIns="0" tIns="0" rIns="0" bIns="0" rtlCol="0" anchor="ctr"/>
-          <a:lstStyle/>
-          <a:p>
-            <a:pPr indent="0" marL="0">
-              <a:buNone/>
-            </a:pPr>
-            <a:r>
-              <a:rPr lang="en-US" sz="1200" dirty="0">
+            <a:off x="1463040" y="1865376"/>
+            <a:ext cx="7040880" cy="365760"/>
+          </a:xfrm>
+          <a:prstGeom prst="rect">
+            <a:avLst/>
+          </a:prstGeom>
+          <a:noFill/>
+          <a:ln/>
+        </p:spPr>
+        <p:txBody>
+          <a:bodyPr wrap="square" lIns="0" tIns="0" rIns="0" bIns="0" rtlCol="0" anchor="ctr"/>
+          <a:lstStyle/>
+          <a:p>
+            <a:pPr indent="0" marL="0">
+              <a:buNone/>
+            </a:pPr>
+            <a:r>
+              <a:rPr lang="en-US" sz="1050" dirty="0">
                 <a:solidFill>
                   <a:srgbClr val="0F172A"/>
                 </a:solidFill>
@@ -16485,9 +16698,9 @@
                 <a:ea typeface="Calibri" pitchFamily="34" charset="-122"/>
                 <a:cs typeface="Calibri" pitchFamily="34" charset="-120"/>
               </a:rPr>
-              <a:t>Quartiere mit grösserer Distanz zum Hauptbahnhof haben einen niedrigeren 15-Min-Score — zentrale Lage bedeutet bessere Erreichbarkeit.</a:t>
-            </a:r>
-            <a:endParaRPr lang="en-US" sz="1200" dirty="0"/>
+              <a:t>Quartiere mit höherem 15-Min-Score haben höhere Median-Mietpreise — Erreichbarkeit übersetzt sich in Standortwert.</a:t>
+            </a:r>
+            <a:endParaRPr lang="en-US" sz="1050" dirty="0"/>
           </a:p>
         </p:txBody>
       </p:sp>
@@ -16499,24 +16712,24 @@
         </p:nvSpPr>
         <p:spPr>
           <a:xfrm>
-            <a:off x="1554480" y="2514600"/>
-            <a:ext cx="6949440" cy="274320"/>
-          </a:xfrm>
-          <a:prstGeom prst="rect">
-            <a:avLst/>
-          </a:prstGeom>
-          <a:noFill/>
-          <a:ln/>
-        </p:spPr>
-        <p:txBody>
-          <a:bodyPr wrap="square" lIns="0" tIns="0" rIns="0" bIns="0" rtlCol="0" anchor="ctr"/>
-          <a:lstStyle/>
-          <a:p>
-            <a:pPr indent="0" marL="0">
-              <a:buNone/>
-            </a:pPr>
-            <a:r>
-              <a:rPr lang="en-US" sz="1050" i="1" dirty="0">
+            <a:off x="1463040" y="2212848"/>
+            <a:ext cx="7040880" cy="228600"/>
+          </a:xfrm>
+          <a:prstGeom prst="rect">
+            <a:avLst/>
+          </a:prstGeom>
+          <a:noFill/>
+          <a:ln/>
+        </p:spPr>
+        <p:txBody>
+          <a:bodyPr wrap="square" lIns="0" tIns="0" rIns="0" bIns="0" rtlCol="0" anchor="ctr"/>
+          <a:lstStyle/>
+          <a:p>
+            <a:pPr indent="0" marL="0">
+              <a:buNone/>
+            </a:pPr>
+            <a:r>
+              <a:rPr lang="en-US" sz="950" i="1" dirty="0">
                 <a:solidFill>
                   <a:srgbClr val="64748B"/>
                 </a:solidFill>
@@ -16524,9 +16737,9 @@
                 <a:ea typeface="Calibri" pitchFamily="34" charset="-122"/>
                 <a:cs typeface="Calibri" pitchFamily="34" charset="-120"/>
               </a:rPr>
-              <a:t>Test: Pearson- &amp; Spearman-Korrelation Score × Distanz HB (n = 34 Quartiere)</a:t>
-            </a:r>
-            <a:endParaRPr lang="en-US" sz="1050" dirty="0"/>
+              <a:t>Test: Pearson + Spearman Score × Median-Mietpreis (Stadt Zürich Open Data, n = 34)</a:t>
+            </a:r>
+            <a:endParaRPr lang="en-US" sz="950" dirty="0"/>
           </a:p>
         </p:txBody>
       </p:sp>
@@ -16538,8 +16751,8 @@
         </p:nvSpPr>
         <p:spPr>
           <a:xfrm>
-            <a:off x="457200" y="2971800"/>
-            <a:ext cx="8229600" cy="1280160"/>
+            <a:off x="457200" y="2560320"/>
+            <a:ext cx="8229600" cy="1005840"/>
           </a:xfrm>
           <a:prstGeom prst="rect">
             <a:avLst/>
@@ -16570,7 +16783,245 @@
         </p:nvSpPr>
         <p:spPr>
           <a:xfrm>
-            <a:off x="457200" y="2971800"/>
+            <a:off x="457200" y="2560320"/>
+            <a:ext cx="8229600" cy="54864"/>
+          </a:xfrm>
+          <a:prstGeom prst="rect">
+            <a:avLst/>
+          </a:prstGeom>
+          <a:solidFill>
+            <a:srgbClr val="1C7293"/>
+          </a:solidFill>
+          <a:ln w="12700">
+            <a:solidFill>
+              <a:srgbClr val="1C7293"/>
+            </a:solidFill>
+            <a:prstDash val="solid"/>
+          </a:ln>
+        </p:spPr>
+      </p:sp>
+      <p:sp>
+        <p:nvSpPr>
+          <p:cNvPr id="13" name="Shape 11"/>
+          <p:cNvSpPr/>
+          <p:nvPr/>
+        </p:nvSpPr>
+        <p:spPr>
+          <a:xfrm>
+            <a:off x="640080" y="2724912"/>
+            <a:ext cx="685800" cy="685800"/>
+          </a:xfrm>
+          <a:prstGeom prst="ellipse">
+            <a:avLst/>
+          </a:prstGeom>
+          <a:solidFill>
+            <a:srgbClr val="1C7293"/>
+          </a:solidFill>
+          <a:ln w="12700">
+            <a:solidFill>
+              <a:srgbClr val="1C7293"/>
+            </a:solidFill>
+            <a:prstDash val="solid"/>
+          </a:ln>
+        </p:spPr>
+      </p:sp>
+      <p:sp>
+        <p:nvSpPr>
+          <p:cNvPr id="14" name="Text 12"/>
+          <p:cNvSpPr/>
+          <p:nvPr/>
+        </p:nvSpPr>
+        <p:spPr>
+          <a:xfrm>
+            <a:off x="640080" y="2724912"/>
+            <a:ext cx="685800" cy="685800"/>
+          </a:xfrm>
+          <a:prstGeom prst="rect">
+            <a:avLst/>
+          </a:prstGeom>
+          <a:noFill/>
+          <a:ln/>
+        </p:spPr>
+        <p:txBody>
+          <a:bodyPr wrap="square" lIns="0" tIns="0" rIns="0" bIns="0" rtlCol="0" anchor="ctr"/>
+          <a:lstStyle/>
+          <a:p>
+            <a:pPr algn="ctr" indent="0" marL="0">
+              <a:buNone/>
+            </a:pPr>
+            <a:r>
+              <a:rPr lang="en-US" sz="1800" b="1" dirty="0">
+                <a:solidFill>
+                  <a:srgbClr val="FFFFFF"/>
+                </a:solidFill>
+                <a:latin typeface="Trebuchet MS" pitchFamily="34" charset="0"/>
+                <a:ea typeface="Trebuchet MS" pitchFamily="34" charset="-122"/>
+                <a:cs typeface="Trebuchet MS" pitchFamily="34" charset="-120"/>
+              </a:rPr>
+              <a:t>H1a</a:t>
+            </a:r>
+            <a:endParaRPr lang="en-US" sz="1800" dirty="0"/>
+          </a:p>
+        </p:txBody>
+      </p:sp>
+      <p:sp>
+        <p:nvSpPr>
+          <p:cNvPr id="15" name="Text 13"/>
+          <p:cNvSpPr/>
+          <p:nvPr/>
+        </p:nvSpPr>
+        <p:spPr>
+          <a:xfrm>
+            <a:off x="1463040" y="2688336"/>
+            <a:ext cx="7040880" cy="292608"/>
+          </a:xfrm>
+          <a:prstGeom prst="rect">
+            <a:avLst/>
+          </a:prstGeom>
+          <a:noFill/>
+          <a:ln/>
+        </p:spPr>
+        <p:txBody>
+          <a:bodyPr wrap="square" lIns="0" tIns="0" rIns="0" bIns="0" rtlCol="0" anchor="ctr"/>
+          <a:lstStyle/>
+          <a:p>
+            <a:pPr indent="0" marL="0">
+              <a:buNone/>
+            </a:pPr>
+            <a:r>
+              <a:rPr lang="en-US" sz="1400" b="1" dirty="0">
+                <a:solidFill>
+                  <a:srgbClr val="0F172A"/>
+                </a:solidFill>
+                <a:latin typeface="Trebuchet MS" pitchFamily="34" charset="0"/>
+                <a:ea typeface="Trebuchet MS" pitchFamily="34" charset="-122"/>
+                <a:cs typeface="Trebuchet MS" pitchFamily="34" charset="-120"/>
+              </a:rPr>
+              <a:t>Zentralitäts-Robustness</a:t>
+            </a:r>
+            <a:endParaRPr lang="en-US" sz="1400" dirty="0"/>
+          </a:p>
+        </p:txBody>
+      </p:sp>
+      <p:sp>
+        <p:nvSpPr>
+          <p:cNvPr id="16" name="Text 14"/>
+          <p:cNvSpPr/>
+          <p:nvPr/>
+        </p:nvSpPr>
+        <p:spPr>
+          <a:xfrm>
+            <a:off x="1463040" y="2962656"/>
+            <a:ext cx="7040880" cy="365760"/>
+          </a:xfrm>
+          <a:prstGeom prst="rect">
+            <a:avLst/>
+          </a:prstGeom>
+          <a:noFill/>
+          <a:ln/>
+        </p:spPr>
+        <p:txBody>
+          <a:bodyPr wrap="square" lIns="0" tIns="0" rIns="0" bIns="0" rtlCol="0" anchor="ctr"/>
+          <a:lstStyle/>
+          <a:p>
+            <a:pPr indent="0" marL="0">
+              <a:buNone/>
+            </a:pPr>
+            <a:r>
+              <a:rPr lang="en-US" sz="1050" dirty="0">
+                <a:solidFill>
+                  <a:srgbClr val="0F172A"/>
+                </a:solidFill>
+                <a:latin typeface="Calibri" pitchFamily="34" charset="0"/>
+                <a:ea typeface="Calibri" pitchFamily="34" charset="-122"/>
+                <a:cs typeface="Calibri" pitchFamily="34" charset="-120"/>
+              </a:rPr>
+              <a:t>Quartiere mit grösserer HB-Distanz haben einen niedrigeren Score — methodisch sauberer Proxy ohne Marktdaten-Confounder.</a:t>
+            </a:r>
+            <a:endParaRPr lang="en-US" sz="1050" dirty="0"/>
+          </a:p>
+        </p:txBody>
+      </p:sp>
+      <p:sp>
+        <p:nvSpPr>
+          <p:cNvPr id="17" name="Text 15"/>
+          <p:cNvSpPr/>
+          <p:nvPr/>
+        </p:nvSpPr>
+        <p:spPr>
+          <a:xfrm>
+            <a:off x="1463040" y="3310128"/>
+            <a:ext cx="7040880" cy="228600"/>
+          </a:xfrm>
+          <a:prstGeom prst="rect">
+            <a:avLst/>
+          </a:prstGeom>
+          <a:noFill/>
+          <a:ln/>
+        </p:spPr>
+        <p:txBody>
+          <a:bodyPr wrap="square" lIns="0" tIns="0" rIns="0" bIns="0" rtlCol="0" anchor="ctr"/>
+          <a:lstStyle/>
+          <a:p>
+            <a:pPr indent="0" marL="0">
+              <a:buNone/>
+            </a:pPr>
+            <a:r>
+              <a:rPr lang="en-US" sz="950" i="1" dirty="0">
+                <a:solidFill>
+                  <a:srgbClr val="64748B"/>
+                </a:solidFill>
+                <a:latin typeface="Calibri" pitchFamily="34" charset="0"/>
+                <a:ea typeface="Calibri" pitchFamily="34" charset="-122"/>
+                <a:cs typeface="Calibri" pitchFamily="34" charset="-120"/>
+              </a:rPr>
+              <a:t>Test: Pearson + Spearman Score × Distanz HB (LV95-Centroide, n = 34)</a:t>
+            </a:r>
+            <a:endParaRPr lang="en-US" sz="950" dirty="0"/>
+          </a:p>
+        </p:txBody>
+      </p:sp>
+      <p:sp>
+        <p:nvSpPr>
+          <p:cNvPr id="18" name="Shape 16"/>
+          <p:cNvSpPr/>
+          <p:nvPr/>
+        </p:nvSpPr>
+        <p:spPr>
+          <a:xfrm>
+            <a:off x="457200" y="3657600"/>
+            <a:ext cx="8229600" cy="1005840"/>
+          </a:xfrm>
+          <a:prstGeom prst="rect">
+            <a:avLst/>
+          </a:prstGeom>
+          <a:solidFill>
+            <a:srgbClr val="FFFFFF"/>
+          </a:solidFill>
+          <a:ln w="9525">
+            <a:solidFill>
+              <a:srgbClr val="E2E8F0"/>
+            </a:solidFill>
+            <a:prstDash val="solid"/>
+          </a:ln>
+          <a:effectLst>
+            <a:outerShdw sx="100000" sy="100000" kx="0" ky="0" algn="bl" rotWithShape="0" blurRad="101600" dist="12700" dir="5400000">
+              <a:srgbClr val="94A3B8">
+                <a:alpha val="12000"/>
+              </a:srgbClr>
+            </a:outerShdw>
+          </a:effectLst>
+        </p:spPr>
+      </p:sp>
+      <p:sp>
+        <p:nvSpPr>
+          <p:cNvPr id="19" name="Shape 17"/>
+          <p:cNvSpPr/>
+          <p:nvPr/>
+        </p:nvSpPr>
+        <p:spPr>
+          <a:xfrm>
+            <a:off x="457200" y="3657600"/>
             <a:ext cx="8229600" cy="54864"/>
           </a:xfrm>
           <a:prstGeom prst="rect">
@@ -16589,14 +17040,14 @@
       </p:sp>
       <p:sp>
         <p:nvSpPr>
-          <p:cNvPr id="13" name="Shape 11"/>
-          <p:cNvSpPr/>
-          <p:nvPr/>
-        </p:nvSpPr>
-        <p:spPr>
-          <a:xfrm>
-            <a:off x="640080" y="3227832"/>
-            <a:ext cx="777240" cy="777240"/>
+          <p:cNvPr id="20" name="Shape 18"/>
+          <p:cNvSpPr/>
+          <p:nvPr/>
+        </p:nvSpPr>
+        <p:spPr>
+          <a:xfrm>
+            <a:off x="640080" y="3822192"/>
+            <a:ext cx="685800" cy="685800"/>
           </a:xfrm>
           <a:prstGeom prst="ellipse">
             <a:avLst/>
@@ -16614,14 +17065,14 @@
       </p:sp>
       <p:sp>
         <p:nvSpPr>
-          <p:cNvPr id="14" name="Text 12"/>
-          <p:cNvSpPr/>
-          <p:nvPr/>
-        </p:nvSpPr>
-        <p:spPr>
-          <a:xfrm>
-            <a:off x="640080" y="3227832"/>
-            <a:ext cx="777240" cy="777240"/>
+          <p:cNvPr id="21" name="Text 19"/>
+          <p:cNvSpPr/>
+          <p:nvPr/>
+        </p:nvSpPr>
+        <p:spPr>
+          <a:xfrm>
+            <a:off x="640080" y="3822192"/>
+            <a:ext cx="685800" cy="685800"/>
           </a:xfrm>
           <a:prstGeom prst="rect">
             <a:avLst/>
@@ -16637,7 +17088,7 @@
               <a:buNone/>
             </a:pPr>
             <a:r>
-              <a:rPr lang="en-US" sz="2200" b="1" dirty="0">
+              <a:rPr lang="en-US" sz="1800" b="1" dirty="0">
                 <a:solidFill>
                   <a:srgbClr val="FFFFFF"/>
                 </a:solidFill>
@@ -16647,36 +17098,36 @@
               </a:rPr>
               <a:t>H2</a:t>
             </a:r>
-            <a:endParaRPr lang="en-US" sz="2200" dirty="0"/>
-          </a:p>
-        </p:txBody>
-      </p:sp>
-      <p:sp>
-        <p:nvSpPr>
-          <p:cNvPr id="15" name="Text 13"/>
-          <p:cNvSpPr/>
-          <p:nvPr/>
-        </p:nvSpPr>
-        <p:spPr>
-          <a:xfrm>
-            <a:off x="1554480" y="3154680"/>
-            <a:ext cx="6949440" cy="365760"/>
-          </a:xfrm>
-          <a:prstGeom prst="rect">
-            <a:avLst/>
-          </a:prstGeom>
-          <a:noFill/>
-          <a:ln/>
-        </p:spPr>
-        <p:txBody>
-          <a:bodyPr wrap="square" lIns="0" tIns="0" rIns="0" bIns="0" rtlCol="0" anchor="ctr"/>
-          <a:lstStyle/>
-          <a:p>
-            <a:pPr indent="0" marL="0">
-              <a:buNone/>
-            </a:pPr>
-            <a:r>
-              <a:rPr lang="en-US" sz="1600" b="1" dirty="0">
+            <a:endParaRPr lang="en-US" sz="1800" dirty="0"/>
+          </a:p>
+        </p:txBody>
+      </p:sp>
+      <p:sp>
+        <p:nvSpPr>
+          <p:cNvPr id="22" name="Text 20"/>
+          <p:cNvSpPr/>
+          <p:nvPr/>
+        </p:nvSpPr>
+        <p:spPr>
+          <a:xfrm>
+            <a:off x="1463040" y="3785616"/>
+            <a:ext cx="7040880" cy="292608"/>
+          </a:xfrm>
+          <a:prstGeom prst="rect">
+            <a:avLst/>
+          </a:prstGeom>
+          <a:noFill/>
+          <a:ln/>
+        </p:spPr>
+        <p:txBody>
+          <a:bodyPr wrap="square" lIns="0" tIns="0" rIns="0" bIns="0" rtlCol="0" anchor="ctr"/>
+          <a:lstStyle/>
+          <a:p>
+            <a:pPr indent="0" marL="0">
+              <a:buNone/>
+            </a:pPr>
+            <a:r>
+              <a:rPr lang="en-US" sz="1400" b="1" dirty="0">
                 <a:solidFill>
                   <a:srgbClr val="0F172A"/>
                 </a:solidFill>
@@ -16686,36 +17137,36 @@
               </a:rPr>
               <a:t>Wüsteneffekt</a:t>
             </a:r>
-            <a:endParaRPr lang="en-US" sz="1600" dirty="0"/>
-          </a:p>
-        </p:txBody>
-      </p:sp>
-      <p:sp>
-        <p:nvSpPr>
-          <p:cNvPr id="16" name="Text 14"/>
-          <p:cNvSpPr/>
-          <p:nvPr/>
-        </p:nvSpPr>
-        <p:spPr>
-          <a:xfrm>
-            <a:off x="1554480" y="3520440"/>
-            <a:ext cx="6949440" cy="457200"/>
-          </a:xfrm>
-          <a:prstGeom prst="rect">
-            <a:avLst/>
-          </a:prstGeom>
-          <a:noFill/>
-          <a:ln/>
-        </p:spPr>
-        <p:txBody>
-          <a:bodyPr wrap="square" lIns="0" tIns="0" rIns="0" bIns="0" rtlCol="0" anchor="ctr"/>
-          <a:lstStyle/>
-          <a:p>
-            <a:pPr indent="0" marL="0">
-              <a:buNone/>
-            </a:pPr>
-            <a:r>
-              <a:rPr lang="en-US" sz="1200" dirty="0">
+            <a:endParaRPr lang="en-US" sz="1400" dirty="0"/>
+          </a:p>
+        </p:txBody>
+      </p:sp>
+      <p:sp>
+        <p:nvSpPr>
+          <p:cNvPr id="23" name="Text 21"/>
+          <p:cNvSpPr/>
+          <p:nvPr/>
+        </p:nvSpPr>
+        <p:spPr>
+          <a:xfrm>
+            <a:off x="1463040" y="4059936"/>
+            <a:ext cx="7040880" cy="365760"/>
+          </a:xfrm>
+          <a:prstGeom prst="rect">
+            <a:avLst/>
+          </a:prstGeom>
+          <a:noFill/>
+          <a:ln/>
+        </p:spPr>
+        <p:txBody>
+          <a:bodyPr wrap="square" lIns="0" tIns="0" rIns="0" bIns="0" rtlCol="0" anchor="ctr"/>
+          <a:lstStyle/>
+          <a:p>
+            <a:pPr indent="0" marL="0">
+              <a:buNone/>
+            </a:pPr>
+            <a:r>
+              <a:rPr lang="en-US" sz="1050" dirty="0">
                 <a:solidFill>
                   <a:srgbClr val="0F172A"/>
                 </a:solidFill>
@@ -16725,36 +17176,36 @@
               </a:rPr>
               <a:t>Es gibt Quartiere mit hoher Bevölkerungsdichte und niedrigem Score — strukturelle Versorgungs-Wüsten.</a:t>
             </a:r>
-            <a:endParaRPr lang="en-US" sz="1200" dirty="0"/>
-          </a:p>
-        </p:txBody>
-      </p:sp>
-      <p:sp>
-        <p:nvSpPr>
-          <p:cNvPr id="17" name="Text 15"/>
-          <p:cNvSpPr/>
-          <p:nvPr/>
-        </p:nvSpPr>
-        <p:spPr>
-          <a:xfrm>
-            <a:off x="1554480" y="3931920"/>
-            <a:ext cx="6949440" cy="274320"/>
-          </a:xfrm>
-          <a:prstGeom prst="rect">
-            <a:avLst/>
-          </a:prstGeom>
-          <a:noFill/>
-          <a:ln/>
-        </p:spPr>
-        <p:txBody>
-          <a:bodyPr wrap="square" lIns="0" tIns="0" rIns="0" bIns="0" rtlCol="0" anchor="ctr"/>
-          <a:lstStyle/>
-          <a:p>
-            <a:pPr indent="0" marL="0">
-              <a:buNone/>
-            </a:pPr>
-            <a:r>
-              <a:rPr lang="en-US" sz="1050" i="1" dirty="0">
+            <a:endParaRPr lang="en-US" sz="1050" dirty="0"/>
+          </a:p>
+        </p:txBody>
+      </p:sp>
+      <p:sp>
+        <p:nvSpPr>
+          <p:cNvPr id="24" name="Text 22"/>
+          <p:cNvSpPr/>
+          <p:nvPr/>
+        </p:nvSpPr>
+        <p:spPr>
+          <a:xfrm>
+            <a:off x="1463040" y="4407408"/>
+            <a:ext cx="7040880" cy="228600"/>
+          </a:xfrm>
+          <a:prstGeom prst="rect">
+            <a:avLst/>
+          </a:prstGeom>
+          <a:noFill/>
+          <a:ln/>
+        </p:spPr>
+        <p:txBody>
+          <a:bodyPr wrap="square" lIns="0" tIns="0" rIns="0" bIns="0" rtlCol="0" anchor="ctr"/>
+          <a:lstStyle/>
+          <a:p>
+            <a:pPr indent="0" marL="0">
+              <a:buNone/>
+            </a:pPr>
+            <a:r>
+              <a:rPr lang="en-US" sz="950" i="1" dirty="0">
                 <a:solidFill>
                   <a:srgbClr val="64748B"/>
                 </a:solidFill>
@@ -16762,15 +17213,15 @@
                 <a:ea typeface="Calibri" pitchFamily="34" charset="-122"/>
                 <a:cs typeface="Calibri" pitchFamily="34" charset="-120"/>
               </a:rPr>
-              <a:t>Test: Schwellenwert-Test: Dichte &gt; P75 UND Score-P25 ≤ P25 (BFS STATPOP 2024)</a:t>
-            </a:r>
-            <a:endParaRPr lang="en-US" sz="1050" dirty="0"/>
-          </a:p>
-        </p:txBody>
-      </p:sp>
-      <p:sp>
-        <p:nvSpPr>
-          <p:cNvPr id="18" name="Text 16"/>
+              <a:t>Test: Schwellenwert-Test: Dichte &gt; P75 UND Score-P25 ≤ P25 (BFS STATPOP 2023)</a:t>
+            </a:r>
+            <a:endParaRPr lang="en-US" sz="950" dirty="0"/>
+          </a:p>
+        </p:txBody>
+      </p:sp>
+      <p:sp>
+        <p:nvSpPr>
+          <p:cNvPr id="25" name="Text 23"/>
           <p:cNvSpPr/>
           <p:nvPr/>
         </p:nvSpPr>

</xml_diff>

<commit_message>
fix(presentation): real names + repo URL in slide 1+20, README, presenter notes
Removed all template placeholders that were missed in earlier audits:

* Slide 1: 'Mitglied 1/2/3' -> 'Memis Sanir · Andrea Callegari · Ioannis Organtzidis'

* Slide 20 footer: '<gruppe>' -> 'sanirmem' (real GitHub username)

* presenter_notes Slide 1: 'Gruppe X' -> personal greeting with names

* README §4.1: '<repo-url>' -> https://github.com/sanirmem/zh15min.git

* SETUP.md Schritt 1: '<eure-org>' -> sanirmem; simplified to clone-only (was also: initial-commit boilerplate)

* Add docs/projekt_pitch.md: 5-min explanation for colleagues incl. anticipated Q&A

Regenerate PPTX (3.4 MB) + PDF (985 KB). Audit script confirms zero remaining placeholders.
</commit_message>
<xml_diff>
--- a/reports/zh15min_slides.pptx
+++ b/reports/zh15min_slides.pptx
@@ -2780,7 +2780,7 @@
                 <a:ea typeface="Calibri" pitchFamily="34" charset="-122"/>
                 <a:cs typeface="Calibri" pitchFamily="34" charset="-120"/>
               </a:rPr>
-              <a:t>Mitglied 1 · Mitglied 2 · Mitglied 3</a:t>
+              <a:t>Memis Sanir · Andrea Callegari · Ioannis Organtzidis</a:t>
             </a:r>
             <a:endParaRPr lang="en-US" sz="1300" dirty="0"/>
           </a:p>
@@ -13777,7 +13777,7 @@
                 <a:ea typeface="Calibri" pitchFamily="34" charset="-122"/>
                 <a:cs typeface="Calibri" pitchFamily="34" charset="-120"/>
               </a:rPr>
-              <a:t>Repository · github.com/&lt;gruppe&gt;/zh15min   ·   Live-Demo: docker compose up -d</a:t>
+              <a:t>Repository · github.com/sanirmem/zh15min   ·   Live-Demo: docker compose up -d</a:t>
             </a:r>
             <a:endParaRPr lang="en-US" sz="1200" dirty="0"/>
           </a:p>

</xml_diff>

<commit_message>
slides 4/12/14/20: visuelle Sprache an neutrales Skript angeglichen
Nach Slide 8 jetzt auch die übrigen Pitch-Marker und Live-Demo-Reste aus dem Deck entfernt:

* Slide 4: 'harten Wertfaktor' → 'Relevanz als Wertfaktor'; Intro 'ist heute Leitbild' → 'ist in der Stadtplanung etabliert' (matched script wording)

* Slide 12: 'ragen wie Wolkenkratzer' → 'erscheinen erhöht'; 'Live-Demo via PostGIS' → 'PostGIS-Anbindung'; 'neue POIs lassen sich live einsetzen, Score reagiert dynamisch' → 'Layer-Zugriff auf zh15min.score — bei Änderungen der Datenbasis aktualisiert sich die Darstellung'

* Slide 14: Footer 'Live-Reproduzierbar' → 'vollständig reproduzierbar'

* Slide 20: Ausblick-Item 'Dynamisches Re-Scoring bei neuem POI (QGIS-Live-Demo)' → '... via QGIS' (letzte Live-Demo-Referenz im Deck)

Final-Sweep über alle 20 Slides bestätigt 0 Treffer auf Pitch-/Live-Demo-Marker. Skript unverändert. PPTX + PDF neu generiert.
</commit_message>
<xml_diff>
--- a/reports/zh15min_slides.pptx
+++ b/reports/zh15min_slides.pptx
@@ -4854,7 +4854,7 @@
                 <a:ea typeface="Calibri" pitchFamily="34" charset="-122"/>
                 <a:cs typeface="Calibri" pitchFamily="34" charset="-120"/>
               </a:rPr>
-              <a:t>Innenstadt-Quartiere ragen wie Wolkenkratzer (Score 90+)</a:t>
+              <a:t>Innenstadt-Quartiere erscheinen erhöht (Score 90+)</a:t>
             </a:r>
             <a:endParaRPr lang="en-US" sz="1050" dirty="0"/>
           </a:p>
@@ -4939,7 +4939,7 @@
                 <a:ea typeface="Calibri" pitchFamily="34" charset="-122"/>
                 <a:cs typeface="Calibri" pitchFamily="34" charset="-120"/>
               </a:rPr>
-              <a:t>Live-Demo via PostGIS</a:t>
+              <a:t>PostGIS-Anbindung</a:t>
             </a:r>
             <a:endParaRPr lang="en-US" sz="1050" dirty="0"/>
           </a:p>
@@ -4956,7 +4956,7 @@
                 <a:ea typeface="Calibri" pitchFamily="34" charset="-122"/>
                 <a:cs typeface="Calibri" pitchFamily="34" charset="-120"/>
               </a:rPr>
-              <a:t>QGIS 3.40 LTR + PostGIS-Verbindung — neue POIs lassen sich live einsetzen, der Score reagiert dynamisch.</a:t>
+              <a:t>QGIS 3.40 LTR mit Layer-Zugriff auf zh15min.score — bei Änderungen der Datenbasis aktualisiert sich die Darstellung.</a:t>
             </a:r>
             <a:endParaRPr lang="en-US" sz="1050" dirty="0"/>
           </a:p>
@@ -6793,7 +6793,7 @@
                 <a:ea typeface="Calibri" pitchFamily="34" charset="-122"/>
                 <a:cs typeface="Calibri" pitchFamily="34" charset="-120"/>
               </a:rPr>
-              <a:t>Werte aus 06_gap_analysis.ipynb · Live-Reproduzierbar</a:t>
+              <a:t>Werte aus 06_gap_analysis.ipynb · vollständig reproduzierbar</a:t>
             </a:r>
             <a:endParaRPr lang="en-US" sz="900" dirty="0"/>
           </a:p>
@@ -13633,7 +13633,7 @@
                 <a:ea typeface="Calibri" pitchFamily="34" charset="-122"/>
                 <a:cs typeface="Calibri" pitchFamily="34" charset="-120"/>
               </a:rPr>
-              <a:t>Dynamisches Re-Scoring bei neuem POI (QGIS-Live-Demo)</a:t>
+              <a:t>Dynamisches Re-Scoring bei neuem POI via QGIS</a:t>
             </a:r>
             <a:endParaRPr lang="en-US" sz="1400" dirty="0"/>
           </a:p>
@@ -15476,7 +15476,7 @@
                 <a:ea typeface="Calibri" pitchFamily="34" charset="-122"/>
                 <a:cs typeface="Calibri" pitchFamily="34" charset="-120"/>
               </a:rPr>
-              <a:t> (Moreno 2021) ist heute Leitbild moderner Stadtplanung — und wird zunehmend zum </a:t>
+              <a:t> (Moreno 2021) ist in der Stadtplanung etabliert und gewinnt zunehmend </a:t>
             </a:r>
             <a:pPr indent="0" marL="0">
               <a:buNone/>
@@ -15490,7 +15490,7 @@
                 <a:ea typeface="Calibri" pitchFamily="34" charset="-122"/>
                 <a:cs typeface="Calibri" pitchFamily="34" charset="-120"/>
               </a:rPr>
-              <a:t>harten Wertfaktor</a:t>
+              <a:t>Relevanz als Wertfaktor</a:t>
             </a:r>
             <a:pPr indent="0" marL="0">
               <a:buNone/>

</xml_diff>